<commit_message>
Clarify narrow exchange-traded product examples
</commit_message>
<xml_diff>
--- a/docs/module3-etfs/output/Module_3_ETFs_Lesson.pptx
+++ b/docs/module3-etfs/output/Module_3_ETFs_Lesson.pptx
@@ -2,24 +2,24 @@
 <file path=ppt/presentation.xml><?xml version="1.0" encoding="utf-8"?>
 <p:presentation xmlns:p="http://schemas.openxmlformats.org/presentationml/2006/main">
   <p:sldMasterIdLst>
-    <p:sldMasterId xmlns:r="http://schemas.openxmlformats.org/officeDocument/2006/relationships" id="2147483648" r:id="R06fcdbbda9024c70"/>
+    <p:sldMasterId xmlns:r="http://schemas.openxmlformats.org/officeDocument/2006/relationships" id="2147483648" r:id="R0ef058fca9884a77"/>
   </p:sldMasterIdLst>
   <p:notesMasterIdLst>
-    <p:notesMasterId xmlns:r="http://schemas.openxmlformats.org/officeDocument/2006/relationships" r:id="Rc35a89f5476c4c05"/>
+    <p:notesMasterId xmlns:r="http://schemas.openxmlformats.org/officeDocument/2006/relationships" r:id="R32e95d3c5cf1421e"/>
   </p:notesMasterIdLst>
   <p:sldIdLst>
-    <p:sldId xmlns:r="http://schemas.openxmlformats.org/officeDocument/2006/relationships" id="256" r:id="R3c93086244584487"/>
-    <p:sldId xmlns:r="http://schemas.openxmlformats.org/officeDocument/2006/relationships" id="257" r:id="Re92ae508cfa3477d"/>
-    <p:sldId xmlns:r="http://schemas.openxmlformats.org/officeDocument/2006/relationships" id="258" r:id="R4818d1fe88324de7"/>
-    <p:sldId xmlns:r="http://schemas.openxmlformats.org/officeDocument/2006/relationships" id="259" r:id="R483ffc773cb9404a"/>
-    <p:sldId xmlns:r="http://schemas.openxmlformats.org/officeDocument/2006/relationships" id="260" r:id="Rddf52f00cb5d4a27"/>
-    <p:sldId xmlns:r="http://schemas.openxmlformats.org/officeDocument/2006/relationships" id="261" r:id="R736e0cc5c2864428"/>
-    <p:sldId xmlns:r="http://schemas.openxmlformats.org/officeDocument/2006/relationships" id="262" r:id="R2fa91985820b4394"/>
-    <p:sldId xmlns:r="http://schemas.openxmlformats.org/officeDocument/2006/relationships" id="263" r:id="Rebc4abe021104aa5"/>
-    <p:sldId xmlns:r="http://schemas.openxmlformats.org/officeDocument/2006/relationships" id="264" r:id="R7375963cdf23481f"/>
-    <p:sldId xmlns:r="http://schemas.openxmlformats.org/officeDocument/2006/relationships" id="265" r:id="Rceb3147d5fdd4c57"/>
-    <p:sldId xmlns:r="http://schemas.openxmlformats.org/officeDocument/2006/relationships" id="266" r:id="R368d0ca74f664d2d"/>
-    <p:sldId xmlns:r="http://schemas.openxmlformats.org/officeDocument/2006/relationships" id="267" r:id="Rd358c22ae77c470c"/>
+    <p:sldId xmlns:r="http://schemas.openxmlformats.org/officeDocument/2006/relationships" id="256" r:id="Ra570fb1e6c19456a"/>
+    <p:sldId xmlns:r="http://schemas.openxmlformats.org/officeDocument/2006/relationships" id="257" r:id="R01c4e2b6f4b64465"/>
+    <p:sldId xmlns:r="http://schemas.openxmlformats.org/officeDocument/2006/relationships" id="258" r:id="R809c267f8ec145eb"/>
+    <p:sldId xmlns:r="http://schemas.openxmlformats.org/officeDocument/2006/relationships" id="259" r:id="Rfdad04ab1b1343bb"/>
+    <p:sldId xmlns:r="http://schemas.openxmlformats.org/officeDocument/2006/relationships" id="260" r:id="Rf2dc0ba6cb994a37"/>
+    <p:sldId xmlns:r="http://schemas.openxmlformats.org/officeDocument/2006/relationships" id="261" r:id="R54951a412b2249d9"/>
+    <p:sldId xmlns:r="http://schemas.openxmlformats.org/officeDocument/2006/relationships" id="262" r:id="R069fb44d633b408e"/>
+    <p:sldId xmlns:r="http://schemas.openxmlformats.org/officeDocument/2006/relationships" id="263" r:id="R1f52f3d564b54c5e"/>
+    <p:sldId xmlns:r="http://schemas.openxmlformats.org/officeDocument/2006/relationships" id="264" r:id="R9f83001a9edf44c9"/>
+    <p:sldId xmlns:r="http://schemas.openxmlformats.org/officeDocument/2006/relationships" id="265" r:id="Rff0bb9324f5740f1"/>
+    <p:sldId xmlns:r="http://schemas.openxmlformats.org/officeDocument/2006/relationships" id="266" r:id="Rcf66c546ef6f4456"/>
+    <p:sldId xmlns:r="http://schemas.openxmlformats.org/officeDocument/2006/relationships" id="267" r:id="R11c3da9166334c5d"/>
   </p:sldIdLst>
   <p:sldSz cx="12192000" cy="6858000"/>
   <p:notesSz cx="6858000" cy="9144000"/>
@@ -1441,7 +1441,7 @@
   </p:cSld>
   <p:clrMap bg1="lt1" tx1="dk1" bg2="lt2" tx2="dk2" accent1="accent1" accent2="accent2" accent3="accent3" accent4="accent4" accent5="accent5" accent6="accent6" hlink="hlink" folHlink="folHlink"/>
   <p:sldLayoutIdLst>
-    <p:sldLayoutId xmlns:r="http://schemas.openxmlformats.org/officeDocument/2006/relationships" id="2147483649" r:id="Rb3796cb02edb429f"/>
+    <p:sldLayoutId xmlns:r="http://schemas.openxmlformats.org/officeDocument/2006/relationships" id="2147483649" r:id="Re0087b03fe5a435f"/>
   </p:sldLayoutIdLst>
   <p:txStyles>
     <p:titleStyle>
@@ -1992,7 +1992,7 @@
           <p:cNvPr id="6" name="">
             <a:extLst xmlns:a="http://schemas.openxmlformats.org/drawingml/2006/main">
               <a:ext uri="{FF2B5EF4-FFF2-40B4-BE49-F238E27FC236}">
-                <a16:creationId xmlns:a16="http://schemas.microsoft.com/office/drawing/2014/main" id="{34479084-2DAC-4C60-A883-F034AC952DC3}"/>
+                <a16:creationId xmlns:a16="http://schemas.microsoft.com/office/drawing/2014/main" id="{836B39D3-3AEF-4A64-A5EF-076E4F4E420F}"/>
               </a:ext>
             </a:extLst>
           </p:cNvPr>
@@ -2049,7 +2049,7 @@
           <p:cNvPr id="2" name="">
             <a:extLst xmlns:a="http://schemas.openxmlformats.org/drawingml/2006/main">
               <a:ext uri="{FF2B5EF4-FFF2-40B4-BE49-F238E27FC236}">
-                <a16:creationId xmlns:a16="http://schemas.microsoft.com/office/drawing/2014/main" id="{D20D63BE-7047-4B9F-822C-229E5C9E0F30}"/>
+                <a16:creationId xmlns:a16="http://schemas.microsoft.com/office/drawing/2014/main" id="{AC676FF8-8CBD-4827-B1DD-77BD4BF61C99}"/>
               </a:ext>
             </a:extLst>
           </p:cNvPr>
@@ -2106,7 +2106,7 @@
           <p:cNvPr id="3" name="">
             <a:extLst xmlns:a="http://schemas.openxmlformats.org/drawingml/2006/main">
               <a:ext uri="{FF2B5EF4-FFF2-40B4-BE49-F238E27FC236}">
-                <a16:creationId xmlns:a16="http://schemas.microsoft.com/office/drawing/2014/main" id="{DE68BA6D-723A-4E5A-BF28-9B1E4461530D}"/>
+                <a16:creationId xmlns:a16="http://schemas.microsoft.com/office/drawing/2014/main" id="{7D018B78-595F-482F-BC77-2A09281F983C}"/>
               </a:ext>
             </a:extLst>
           </p:cNvPr>
@@ -2163,7 +2163,7 @@
           <p:cNvPr id="4" name="">
             <a:extLst xmlns:a="http://schemas.openxmlformats.org/drawingml/2006/main">
               <a:ext uri="{FF2B5EF4-FFF2-40B4-BE49-F238E27FC236}">
-                <a16:creationId xmlns:a16="http://schemas.microsoft.com/office/drawing/2014/main" id="{8E62EBC3-16FA-4FAF-AE10-5B937BB495D9}"/>
+                <a16:creationId xmlns:a16="http://schemas.microsoft.com/office/drawing/2014/main" id="{D78FDDC6-B9E3-49C2-8A76-F9E47F994A2F}"/>
               </a:ext>
             </a:extLst>
           </p:cNvPr>
@@ -2220,7 +2220,7 @@
           <p:cNvPr id="5" name="">
             <a:extLst xmlns:a="http://schemas.openxmlformats.org/drawingml/2006/main">
               <a:ext uri="{FF2B5EF4-FFF2-40B4-BE49-F238E27FC236}">
-                <a16:creationId xmlns:a16="http://schemas.microsoft.com/office/drawing/2014/main" id="{D9A1A4AB-EB5E-4036-8DB9-F4992C361FF8}"/>
+                <a16:creationId xmlns:a16="http://schemas.microsoft.com/office/drawing/2014/main" id="{C63F1C36-8D3C-4F89-80BB-2D5D45460EAF}"/>
               </a:ext>
             </a:extLst>
           </p:cNvPr>
@@ -2275,7 +2275,7 @@
     </p:spTree>
     <p:extLst>
       <p:ext uri="{BB962C8B-B14F-4D97-AF65-F5344CB8AC3E}">
-        <p14:creationId xmlns:p14="http://schemas.microsoft.com/office/powerpoint/2010/main" val="1874838343"/>
+        <p14:creationId xmlns:p14="http://schemas.microsoft.com/office/powerpoint/2010/main" val="204427643"/>
       </p:ext>
     </p:extLst>
   </p:cSld>
@@ -2306,7 +2306,7 @@
           <p:cNvPr id="8" name="">
             <a:extLst xmlns:a="http://schemas.openxmlformats.org/drawingml/2006/main">
               <a:ext uri="{FF2B5EF4-FFF2-40B4-BE49-F238E27FC236}">
-                <a16:creationId xmlns:a16="http://schemas.microsoft.com/office/drawing/2014/main" id="{FB750421-E0BE-4E3B-BDD5-4EE481291036}"/>
+                <a16:creationId xmlns:a16="http://schemas.microsoft.com/office/drawing/2014/main" id="{E6F8152D-D740-48F6-A168-4FD5E3175FA7}"/>
               </a:ext>
             </a:extLst>
           </p:cNvPr>
@@ -2363,7 +2363,7 @@
           <p:cNvPr id="2" name="">
             <a:extLst xmlns:a="http://schemas.openxmlformats.org/drawingml/2006/main">
               <a:ext uri="{FF2B5EF4-FFF2-40B4-BE49-F238E27FC236}">
-                <a16:creationId xmlns:a16="http://schemas.microsoft.com/office/drawing/2014/main" id="{0089C40A-219D-4BB1-8313-87BE3F51E6D5}"/>
+                <a16:creationId xmlns:a16="http://schemas.microsoft.com/office/drawing/2014/main" id="{C00D4682-1EA4-4C40-99B6-430A7E0401E5}"/>
               </a:ext>
             </a:extLst>
           </p:cNvPr>
@@ -2420,7 +2420,7 @@
           <p:cNvPr id="3" name="">
             <a:extLst xmlns:a="http://schemas.openxmlformats.org/drawingml/2006/main">
               <a:ext uri="{FF2B5EF4-FFF2-40B4-BE49-F238E27FC236}">
-                <a16:creationId xmlns:a16="http://schemas.microsoft.com/office/drawing/2014/main" id="{4A8AC04D-B714-400F-A858-774C3B7CA28C}"/>
+                <a16:creationId xmlns:a16="http://schemas.microsoft.com/office/drawing/2014/main" id="{43C0B552-9B91-49E5-9355-125551629117}"/>
               </a:ext>
             </a:extLst>
           </p:cNvPr>
@@ -2477,7 +2477,7 @@
           <p:cNvPr id="4" name="">
             <a:extLst xmlns:a="http://schemas.openxmlformats.org/drawingml/2006/main">
               <a:ext uri="{FF2B5EF4-FFF2-40B4-BE49-F238E27FC236}">
-                <a16:creationId xmlns:a16="http://schemas.microsoft.com/office/drawing/2014/main" id="{1C5C8CED-27D3-4C7D-BD68-AD97772353F8}"/>
+                <a16:creationId xmlns:a16="http://schemas.microsoft.com/office/drawing/2014/main" id="{2D44B5B9-6F36-436A-9517-655D3127C9CD}"/>
               </a:ext>
             </a:extLst>
           </p:cNvPr>
@@ -2534,7 +2534,7 @@
           <p:cNvPr id="5" name="">
             <a:extLst xmlns:a="http://schemas.openxmlformats.org/drawingml/2006/main">
               <a:ext uri="{FF2B5EF4-FFF2-40B4-BE49-F238E27FC236}">
-                <a16:creationId xmlns:a16="http://schemas.microsoft.com/office/drawing/2014/main" id="{5E8C4FC7-146F-4B1F-9F98-062198FE3D4A}"/>
+                <a16:creationId xmlns:a16="http://schemas.microsoft.com/office/drawing/2014/main" id="{4133FD98-B72C-43DA-A029-72C6806F70F4}"/>
               </a:ext>
             </a:extLst>
           </p:cNvPr>
@@ -2591,7 +2591,7 @@
           <p:cNvPr id="6" name="">
             <a:extLst xmlns:a="http://schemas.openxmlformats.org/drawingml/2006/main">
               <a:ext uri="{FF2B5EF4-FFF2-40B4-BE49-F238E27FC236}">
-                <a16:creationId xmlns:a16="http://schemas.microsoft.com/office/drawing/2014/main" id="{B31EDBAE-3558-49E5-B393-84C7A6419A00}"/>
+                <a16:creationId xmlns:a16="http://schemas.microsoft.com/office/drawing/2014/main" id="{AE67FC85-E4EE-4A64-8925-E2BB7C129128}"/>
               </a:ext>
             </a:extLst>
           </p:cNvPr>
@@ -2648,7 +2648,7 @@
           <p:cNvPr id="7" name="">
             <a:extLst xmlns:a="http://schemas.openxmlformats.org/drawingml/2006/main">
               <a:ext uri="{FF2B5EF4-FFF2-40B4-BE49-F238E27FC236}">
-                <a16:creationId xmlns:a16="http://schemas.microsoft.com/office/drawing/2014/main" id="{AC753D42-23D5-4DC5-A2DA-12873E0B16DE}"/>
+                <a16:creationId xmlns:a16="http://schemas.microsoft.com/office/drawing/2014/main" id="{A57A111F-02A6-4E75-BF8B-A5CAFB50FF66}"/>
               </a:ext>
             </a:extLst>
           </p:cNvPr>
@@ -2703,7 +2703,7 @@
     </p:spTree>
     <p:extLst>
       <p:ext uri="{BB962C8B-B14F-4D97-AF65-F5344CB8AC3E}">
-        <p14:creationId xmlns:p14="http://schemas.microsoft.com/office/powerpoint/2010/main" val="1886929919"/>
+        <p14:creationId xmlns:p14="http://schemas.microsoft.com/office/powerpoint/2010/main" val="527651236"/>
       </p:ext>
     </p:extLst>
   </p:cSld>
@@ -2734,7 +2734,7 @@
           <p:cNvPr id="5" name="">
             <a:extLst xmlns:a="http://schemas.openxmlformats.org/drawingml/2006/main">
               <a:ext uri="{FF2B5EF4-FFF2-40B4-BE49-F238E27FC236}">
-                <a16:creationId xmlns:a16="http://schemas.microsoft.com/office/drawing/2014/main" id="{896F552B-B3DC-4EDC-8755-2EBEC71FE998}"/>
+                <a16:creationId xmlns:a16="http://schemas.microsoft.com/office/drawing/2014/main" id="{3CDCB948-03DF-44B8-9D1F-920799252D94}"/>
               </a:ext>
             </a:extLst>
           </p:cNvPr>
@@ -2791,7 +2791,7 @@
           <p:cNvPr id="2" name="">
             <a:extLst xmlns:a="http://schemas.openxmlformats.org/drawingml/2006/main">
               <a:ext uri="{FF2B5EF4-FFF2-40B4-BE49-F238E27FC236}">
-                <a16:creationId xmlns:a16="http://schemas.microsoft.com/office/drawing/2014/main" id="{CBDEBF4E-2FF1-48D0-91BE-B819B2C74C56}"/>
+                <a16:creationId xmlns:a16="http://schemas.microsoft.com/office/drawing/2014/main" id="{27C2D3C7-90E8-49F4-B587-56A866EDAFD6}"/>
               </a:ext>
             </a:extLst>
           </p:cNvPr>
@@ -2848,7 +2848,7 @@
           <p:cNvPr id="3" name="">
             <a:extLst xmlns:a="http://schemas.openxmlformats.org/drawingml/2006/main">
               <a:ext uri="{FF2B5EF4-FFF2-40B4-BE49-F238E27FC236}">
-                <a16:creationId xmlns:a16="http://schemas.microsoft.com/office/drawing/2014/main" id="{1F0EDB0A-B4D4-419B-A48A-2B6182CE7386}"/>
+                <a16:creationId xmlns:a16="http://schemas.microsoft.com/office/drawing/2014/main" id="{5BD79CC8-9DC8-48A5-BB3B-97D6729B29E7}"/>
               </a:ext>
             </a:extLst>
           </p:cNvPr>
@@ -2905,7 +2905,7 @@
           <p:cNvPr id="4" name="">
             <a:extLst xmlns:a="http://schemas.openxmlformats.org/drawingml/2006/main">
               <a:ext uri="{FF2B5EF4-FFF2-40B4-BE49-F238E27FC236}">
-                <a16:creationId xmlns:a16="http://schemas.microsoft.com/office/drawing/2014/main" id="{11B6964B-E510-444E-8B1C-86547B059180}"/>
+                <a16:creationId xmlns:a16="http://schemas.microsoft.com/office/drawing/2014/main" id="{69C1F1CF-AA11-49C4-8DA5-AE6B2CDAC9F9}"/>
               </a:ext>
             </a:extLst>
           </p:cNvPr>
@@ -2960,7 +2960,7 @@
     </p:spTree>
     <p:extLst>
       <p:ext uri="{BB962C8B-B14F-4D97-AF65-F5344CB8AC3E}">
-        <p14:creationId xmlns:p14="http://schemas.microsoft.com/office/powerpoint/2010/main" val="784520816"/>
+        <p14:creationId xmlns:p14="http://schemas.microsoft.com/office/powerpoint/2010/main" val="1334399815"/>
       </p:ext>
     </p:extLst>
   </p:cSld>
@@ -2991,7 +2991,7 @@
           <p:cNvPr id="8" name="">
             <a:extLst xmlns:a="http://schemas.openxmlformats.org/drawingml/2006/main">
               <a:ext uri="{FF2B5EF4-FFF2-40B4-BE49-F238E27FC236}">
-                <a16:creationId xmlns:a16="http://schemas.microsoft.com/office/drawing/2014/main" id="{F6E07D42-E9FD-489F-A7F6-4F7F470C7453}"/>
+                <a16:creationId xmlns:a16="http://schemas.microsoft.com/office/drawing/2014/main" id="{BA8648AA-4B1F-49AF-A643-3E7544C14426}"/>
               </a:ext>
             </a:extLst>
           </p:cNvPr>
@@ -3048,7 +3048,7 @@
           <p:cNvPr id="2" name="">
             <a:extLst xmlns:a="http://schemas.openxmlformats.org/drawingml/2006/main">
               <a:ext uri="{FF2B5EF4-FFF2-40B4-BE49-F238E27FC236}">
-                <a16:creationId xmlns:a16="http://schemas.microsoft.com/office/drawing/2014/main" id="{3FEAA383-03CA-4E69-9EED-896089BDB2B6}"/>
+                <a16:creationId xmlns:a16="http://schemas.microsoft.com/office/drawing/2014/main" id="{69742FA8-40EA-44A1-92FF-9DCE4C1B2D0D}"/>
               </a:ext>
             </a:extLst>
           </p:cNvPr>
@@ -3105,7 +3105,7 @@
           <p:cNvPr id="3" name="">
             <a:extLst xmlns:a="http://schemas.openxmlformats.org/drawingml/2006/main">
               <a:ext uri="{FF2B5EF4-FFF2-40B4-BE49-F238E27FC236}">
-                <a16:creationId xmlns:a16="http://schemas.microsoft.com/office/drawing/2014/main" id="{69F1A30D-E2CA-4C64-925C-FCCB593D5CBB}"/>
+                <a16:creationId xmlns:a16="http://schemas.microsoft.com/office/drawing/2014/main" id="{A2346768-F2C5-44E4-AE32-F10C375635AB}"/>
               </a:ext>
             </a:extLst>
           </p:cNvPr>
@@ -3162,7 +3162,7 @@
           <p:cNvPr id="4" name="">
             <a:extLst xmlns:a="http://schemas.openxmlformats.org/drawingml/2006/main">
               <a:ext uri="{FF2B5EF4-FFF2-40B4-BE49-F238E27FC236}">
-                <a16:creationId xmlns:a16="http://schemas.microsoft.com/office/drawing/2014/main" id="{B62C48C9-EF86-4E68-979F-46E17FB140BE}"/>
+                <a16:creationId xmlns:a16="http://schemas.microsoft.com/office/drawing/2014/main" id="{C57C0F29-CE68-4410-9171-C50C02377F72}"/>
               </a:ext>
             </a:extLst>
           </p:cNvPr>
@@ -3219,7 +3219,7 @@
           <p:cNvPr id="5" name="">
             <a:extLst xmlns:a="http://schemas.openxmlformats.org/drawingml/2006/main">
               <a:ext uri="{FF2B5EF4-FFF2-40B4-BE49-F238E27FC236}">
-                <a16:creationId xmlns:a16="http://schemas.microsoft.com/office/drawing/2014/main" id="{3BDA6565-7FA0-4756-9D26-30D304EC739C}"/>
+                <a16:creationId xmlns:a16="http://schemas.microsoft.com/office/drawing/2014/main" id="{02551EFB-6C6A-4528-8089-994A02D9EBF1}"/>
               </a:ext>
             </a:extLst>
           </p:cNvPr>
@@ -3276,7 +3276,7 @@
           <p:cNvPr id="6" name="">
             <a:extLst xmlns:a="http://schemas.openxmlformats.org/drawingml/2006/main">
               <a:ext uri="{FF2B5EF4-FFF2-40B4-BE49-F238E27FC236}">
-                <a16:creationId xmlns:a16="http://schemas.microsoft.com/office/drawing/2014/main" id="{050F3CCC-A433-41A2-985B-D9D1E7DCBBDA}"/>
+                <a16:creationId xmlns:a16="http://schemas.microsoft.com/office/drawing/2014/main" id="{9465D5D5-094F-4A35-A0E8-64EFCAE93036}"/>
               </a:ext>
             </a:extLst>
           </p:cNvPr>
@@ -3333,7 +3333,7 @@
           <p:cNvPr id="7" name="">
             <a:extLst xmlns:a="http://schemas.openxmlformats.org/drawingml/2006/main">
               <a:ext uri="{FF2B5EF4-FFF2-40B4-BE49-F238E27FC236}">
-                <a16:creationId xmlns:a16="http://schemas.microsoft.com/office/drawing/2014/main" id="{9BC1B1B2-72B5-4725-AFA5-9354DDD53B76}"/>
+                <a16:creationId xmlns:a16="http://schemas.microsoft.com/office/drawing/2014/main" id="{D8C9402E-9830-4A81-A246-5B0B229EA744}"/>
               </a:ext>
             </a:extLst>
           </p:cNvPr>
@@ -3388,7 +3388,7 @@
     </p:spTree>
     <p:extLst>
       <p:ext uri="{BB962C8B-B14F-4D97-AF65-F5344CB8AC3E}">
-        <p14:creationId xmlns:p14="http://schemas.microsoft.com/office/powerpoint/2010/main" val="119561139"/>
+        <p14:creationId xmlns:p14="http://schemas.microsoft.com/office/powerpoint/2010/main" val="33982885"/>
       </p:ext>
     </p:extLst>
   </p:cSld>
@@ -3419,7 +3419,7 @@
           <p:cNvPr id="7" name="">
             <a:extLst xmlns:a="http://schemas.openxmlformats.org/drawingml/2006/main">
               <a:ext uri="{FF2B5EF4-FFF2-40B4-BE49-F238E27FC236}">
-                <a16:creationId xmlns:a16="http://schemas.microsoft.com/office/drawing/2014/main" id="{4CD24268-1197-407D-8FFD-B1C13B465A49}"/>
+                <a16:creationId xmlns:a16="http://schemas.microsoft.com/office/drawing/2014/main" id="{606B4F3F-826A-4EC1-BF4E-DC71881D87FD}"/>
               </a:ext>
             </a:extLst>
           </p:cNvPr>
@@ -3476,7 +3476,7 @@
           <p:cNvPr id="2" name="">
             <a:extLst xmlns:a="http://schemas.openxmlformats.org/drawingml/2006/main">
               <a:ext uri="{FF2B5EF4-FFF2-40B4-BE49-F238E27FC236}">
-                <a16:creationId xmlns:a16="http://schemas.microsoft.com/office/drawing/2014/main" id="{3F4246AC-6791-4C0A-B505-6A8A3C3803BF}"/>
+                <a16:creationId xmlns:a16="http://schemas.microsoft.com/office/drawing/2014/main" id="{97C45CBA-2516-472D-B00B-E522C841CF4D}"/>
               </a:ext>
             </a:extLst>
           </p:cNvPr>
@@ -3533,7 +3533,7 @@
           <p:cNvPr id="3" name="">
             <a:extLst xmlns:a="http://schemas.openxmlformats.org/drawingml/2006/main">
               <a:ext uri="{FF2B5EF4-FFF2-40B4-BE49-F238E27FC236}">
-                <a16:creationId xmlns:a16="http://schemas.microsoft.com/office/drawing/2014/main" id="{B51C71A8-5799-4E34-8571-BBCED4F5046C}"/>
+                <a16:creationId xmlns:a16="http://schemas.microsoft.com/office/drawing/2014/main" id="{AD9ADE17-4EA5-4536-9992-34C86807B03E}"/>
               </a:ext>
             </a:extLst>
           </p:cNvPr>
@@ -3590,7 +3590,7 @@
           <p:cNvPr id="4" name="">
             <a:extLst xmlns:a="http://schemas.openxmlformats.org/drawingml/2006/main">
               <a:ext uri="{FF2B5EF4-FFF2-40B4-BE49-F238E27FC236}">
-                <a16:creationId xmlns:a16="http://schemas.microsoft.com/office/drawing/2014/main" id="{0DF493F5-A9BB-455C-8DF3-DBD2461B0127}"/>
+                <a16:creationId xmlns:a16="http://schemas.microsoft.com/office/drawing/2014/main" id="{2B694F19-DC55-499D-A4C8-68AB163195FF}"/>
               </a:ext>
             </a:extLst>
           </p:cNvPr>
@@ -3647,7 +3647,7 @@
           <p:cNvPr id="5" name="">
             <a:extLst xmlns:a="http://schemas.openxmlformats.org/drawingml/2006/main">
               <a:ext uri="{FF2B5EF4-FFF2-40B4-BE49-F238E27FC236}">
-                <a16:creationId xmlns:a16="http://schemas.microsoft.com/office/drawing/2014/main" id="{E264CE28-129E-4D50-9A77-1FDA25988E14}"/>
+                <a16:creationId xmlns:a16="http://schemas.microsoft.com/office/drawing/2014/main" id="{1C8B8E7B-4389-441E-B756-186519E5A75C}"/>
               </a:ext>
             </a:extLst>
           </p:cNvPr>
@@ -3704,7 +3704,7 @@
           <p:cNvPr id="6" name="">
             <a:extLst xmlns:a="http://schemas.openxmlformats.org/drawingml/2006/main">
               <a:ext uri="{FF2B5EF4-FFF2-40B4-BE49-F238E27FC236}">
-                <a16:creationId xmlns:a16="http://schemas.microsoft.com/office/drawing/2014/main" id="{62874E39-46D0-4C2E-8C46-735441E0707F}"/>
+                <a16:creationId xmlns:a16="http://schemas.microsoft.com/office/drawing/2014/main" id="{33BEF1FA-D298-44A3-BB8D-4102F8792174}"/>
               </a:ext>
             </a:extLst>
           </p:cNvPr>
@@ -3759,7 +3759,7 @@
     </p:spTree>
     <p:extLst>
       <p:ext uri="{BB962C8B-B14F-4D97-AF65-F5344CB8AC3E}">
-        <p14:creationId xmlns:p14="http://schemas.microsoft.com/office/powerpoint/2010/main" val="1467521795"/>
+        <p14:creationId xmlns:p14="http://schemas.microsoft.com/office/powerpoint/2010/main" val="1610357757"/>
       </p:ext>
     </p:extLst>
   </p:cSld>
@@ -3790,7 +3790,7 @@
           <p:cNvPr id="9" name="">
             <a:extLst xmlns:a="http://schemas.openxmlformats.org/drawingml/2006/main">
               <a:ext uri="{FF2B5EF4-FFF2-40B4-BE49-F238E27FC236}">
-                <a16:creationId xmlns:a16="http://schemas.microsoft.com/office/drawing/2014/main" id="{AA229F89-66E5-42DC-BF8E-243D4A996AFF}"/>
+                <a16:creationId xmlns:a16="http://schemas.microsoft.com/office/drawing/2014/main" id="{E16DA133-9EE8-4E9A-ACD3-619C1C072961}"/>
               </a:ext>
             </a:extLst>
           </p:cNvPr>
@@ -3847,7 +3847,7 @@
           <p:cNvPr id="2" name="">
             <a:extLst xmlns:a="http://schemas.openxmlformats.org/drawingml/2006/main">
               <a:ext uri="{FF2B5EF4-FFF2-40B4-BE49-F238E27FC236}">
-                <a16:creationId xmlns:a16="http://schemas.microsoft.com/office/drawing/2014/main" id="{2EDF7A52-F1D0-4F37-9210-E2015699C670}"/>
+                <a16:creationId xmlns:a16="http://schemas.microsoft.com/office/drawing/2014/main" id="{CEB2B7F9-45D4-4331-8C40-629EDE0D61BF}"/>
               </a:ext>
             </a:extLst>
           </p:cNvPr>
@@ -3904,7 +3904,7 @@
           <p:cNvPr id="3" name="">
             <a:extLst xmlns:a="http://schemas.openxmlformats.org/drawingml/2006/main">
               <a:ext uri="{FF2B5EF4-FFF2-40B4-BE49-F238E27FC236}">
-                <a16:creationId xmlns:a16="http://schemas.microsoft.com/office/drawing/2014/main" id="{1FAFE55D-AE12-412A-9B96-092C0B49753A}"/>
+                <a16:creationId xmlns:a16="http://schemas.microsoft.com/office/drawing/2014/main" id="{77F9A663-0E8E-42C7-AA14-469FFDE47DA6}"/>
               </a:ext>
             </a:extLst>
           </p:cNvPr>
@@ -3961,7 +3961,7 @@
           <p:cNvPr id="4" name="">
             <a:extLst xmlns:a="http://schemas.openxmlformats.org/drawingml/2006/main">
               <a:ext uri="{FF2B5EF4-FFF2-40B4-BE49-F238E27FC236}">
-                <a16:creationId xmlns:a16="http://schemas.microsoft.com/office/drawing/2014/main" id="{037D9500-CC9C-4436-BDC9-3D5AFB8B7372}"/>
+                <a16:creationId xmlns:a16="http://schemas.microsoft.com/office/drawing/2014/main" id="{90C5025B-554C-4348-8449-6C16A8065B05}"/>
               </a:ext>
             </a:extLst>
           </p:cNvPr>
@@ -4018,7 +4018,7 @@
           <p:cNvPr id="5" name="">
             <a:extLst xmlns:a="http://schemas.openxmlformats.org/drawingml/2006/main">
               <a:ext uri="{FF2B5EF4-FFF2-40B4-BE49-F238E27FC236}">
-                <a16:creationId xmlns:a16="http://schemas.microsoft.com/office/drawing/2014/main" id="{3A687795-D0ED-42F6-ACB4-E88872092CAC}"/>
+                <a16:creationId xmlns:a16="http://schemas.microsoft.com/office/drawing/2014/main" id="{04EDFE0E-5A03-4754-84C6-664E5EC2528B}"/>
               </a:ext>
             </a:extLst>
           </p:cNvPr>
@@ -4075,7 +4075,7 @@
           <p:cNvPr id="6" name="">
             <a:extLst xmlns:a="http://schemas.openxmlformats.org/drawingml/2006/main">
               <a:ext uri="{FF2B5EF4-FFF2-40B4-BE49-F238E27FC236}">
-                <a16:creationId xmlns:a16="http://schemas.microsoft.com/office/drawing/2014/main" id="{FA7C8280-ACE2-4660-8E2D-CAF2F6E92D54}"/>
+                <a16:creationId xmlns:a16="http://schemas.microsoft.com/office/drawing/2014/main" id="{F201F98A-9437-419C-8CCC-6DB7CA67324F}"/>
               </a:ext>
             </a:extLst>
           </p:cNvPr>
@@ -4132,7 +4132,7 @@
           <p:cNvPr id="7" name="">
             <a:extLst xmlns:a="http://schemas.openxmlformats.org/drawingml/2006/main">
               <a:ext uri="{FF2B5EF4-FFF2-40B4-BE49-F238E27FC236}">
-                <a16:creationId xmlns:a16="http://schemas.microsoft.com/office/drawing/2014/main" id="{F23C7883-9919-4A55-9326-0E0EE9EEE8E8}"/>
+                <a16:creationId xmlns:a16="http://schemas.microsoft.com/office/drawing/2014/main" id="{B0111D62-8A53-4FA8-88BA-6691360EDD2D}"/>
               </a:ext>
             </a:extLst>
           </p:cNvPr>
@@ -4189,7 +4189,7 @@
           <p:cNvPr id="8" name="">
             <a:extLst xmlns:a="http://schemas.openxmlformats.org/drawingml/2006/main">
               <a:ext uri="{FF2B5EF4-FFF2-40B4-BE49-F238E27FC236}">
-                <a16:creationId xmlns:a16="http://schemas.microsoft.com/office/drawing/2014/main" id="{0F306395-B28B-40B5-B7C6-B56F0A3D667D}"/>
+                <a16:creationId xmlns:a16="http://schemas.microsoft.com/office/drawing/2014/main" id="{15CC0673-B143-45A9-B070-FFF4FA663AC7}"/>
               </a:ext>
             </a:extLst>
           </p:cNvPr>
@@ -4244,7 +4244,7 @@
     </p:spTree>
     <p:extLst>
       <p:ext uri="{BB962C8B-B14F-4D97-AF65-F5344CB8AC3E}">
-        <p14:creationId xmlns:p14="http://schemas.microsoft.com/office/powerpoint/2010/main" val="1382801620"/>
+        <p14:creationId xmlns:p14="http://schemas.microsoft.com/office/powerpoint/2010/main" val="720734449"/>
       </p:ext>
     </p:extLst>
   </p:cSld>
@@ -4275,7 +4275,7 @@
           <p:cNvPr id="9" name="">
             <a:extLst xmlns:a="http://schemas.openxmlformats.org/drawingml/2006/main">
               <a:ext uri="{FF2B5EF4-FFF2-40B4-BE49-F238E27FC236}">
-                <a16:creationId xmlns:a16="http://schemas.microsoft.com/office/drawing/2014/main" id="{D0C60694-17CF-42C0-AA7F-DE09D6AC40F7}"/>
+                <a16:creationId xmlns:a16="http://schemas.microsoft.com/office/drawing/2014/main" id="{F37D4BC6-FE30-4757-BB4F-7FA720C92C39}"/>
               </a:ext>
             </a:extLst>
           </p:cNvPr>
@@ -4332,7 +4332,7 @@
           <p:cNvPr id="2" name="">
             <a:extLst xmlns:a="http://schemas.openxmlformats.org/drawingml/2006/main">
               <a:ext uri="{FF2B5EF4-FFF2-40B4-BE49-F238E27FC236}">
-                <a16:creationId xmlns:a16="http://schemas.microsoft.com/office/drawing/2014/main" id="{6E5F32BA-19E3-4B7F-A465-9368223D393A}"/>
+                <a16:creationId xmlns:a16="http://schemas.microsoft.com/office/drawing/2014/main" id="{7B550425-DCBB-48BE-8D01-BA2B089F7CB7}"/>
               </a:ext>
             </a:extLst>
           </p:cNvPr>
@@ -4389,7 +4389,7 @@
           <p:cNvPr id="3" name="">
             <a:extLst xmlns:a="http://schemas.openxmlformats.org/drawingml/2006/main">
               <a:ext uri="{FF2B5EF4-FFF2-40B4-BE49-F238E27FC236}">
-                <a16:creationId xmlns:a16="http://schemas.microsoft.com/office/drawing/2014/main" id="{BF145D71-43A6-4591-8591-B27148B0262D}"/>
+                <a16:creationId xmlns:a16="http://schemas.microsoft.com/office/drawing/2014/main" id="{8AB0CE40-6B65-429A-9F71-949CF60D40B7}"/>
               </a:ext>
             </a:extLst>
           </p:cNvPr>
@@ -4446,7 +4446,7 @@
           <p:cNvPr id="4" name="">
             <a:extLst xmlns:a="http://schemas.openxmlformats.org/drawingml/2006/main">
               <a:ext uri="{FF2B5EF4-FFF2-40B4-BE49-F238E27FC236}">
-                <a16:creationId xmlns:a16="http://schemas.microsoft.com/office/drawing/2014/main" id="{42A42110-83B1-4169-BBA6-F850D1FDB0F9}"/>
+                <a16:creationId xmlns:a16="http://schemas.microsoft.com/office/drawing/2014/main" id="{4967F643-185B-441F-BCD4-E3CE6A40C8DA}"/>
               </a:ext>
             </a:extLst>
           </p:cNvPr>
@@ -4503,7 +4503,7 @@
           <p:cNvPr id="5" name="">
             <a:extLst xmlns:a="http://schemas.openxmlformats.org/drawingml/2006/main">
               <a:ext uri="{FF2B5EF4-FFF2-40B4-BE49-F238E27FC236}">
-                <a16:creationId xmlns:a16="http://schemas.microsoft.com/office/drawing/2014/main" id="{F7D33038-1AB3-409D-AB21-11C3D9151B46}"/>
+                <a16:creationId xmlns:a16="http://schemas.microsoft.com/office/drawing/2014/main" id="{96756E61-48CA-40D7-8332-BCA0C51E96AE}"/>
               </a:ext>
             </a:extLst>
           </p:cNvPr>
@@ -4560,7 +4560,7 @@
           <p:cNvPr id="6" name="">
             <a:extLst xmlns:a="http://schemas.openxmlformats.org/drawingml/2006/main">
               <a:ext uri="{FF2B5EF4-FFF2-40B4-BE49-F238E27FC236}">
-                <a16:creationId xmlns:a16="http://schemas.microsoft.com/office/drawing/2014/main" id="{79ABBD69-B8BF-4842-B07B-AE87A03040E1}"/>
+                <a16:creationId xmlns:a16="http://schemas.microsoft.com/office/drawing/2014/main" id="{93CF5C9E-CC01-4C2C-AA1F-301BDB257F5F}"/>
               </a:ext>
             </a:extLst>
           </p:cNvPr>
@@ -4617,7 +4617,7 @@
           <p:cNvPr id="7" name="">
             <a:extLst xmlns:a="http://schemas.openxmlformats.org/drawingml/2006/main">
               <a:ext uri="{FF2B5EF4-FFF2-40B4-BE49-F238E27FC236}">
-                <a16:creationId xmlns:a16="http://schemas.microsoft.com/office/drawing/2014/main" id="{4D81D37F-3B8F-4EF5-89BA-B2DEE1144268}"/>
+                <a16:creationId xmlns:a16="http://schemas.microsoft.com/office/drawing/2014/main" id="{6A1763E6-6E84-4B1C-882D-79015D1314CC}"/>
               </a:ext>
             </a:extLst>
           </p:cNvPr>
@@ -4674,7 +4674,7 @@
           <p:cNvPr id="8" name="">
             <a:extLst xmlns:a="http://schemas.openxmlformats.org/drawingml/2006/main">
               <a:ext uri="{FF2B5EF4-FFF2-40B4-BE49-F238E27FC236}">
-                <a16:creationId xmlns:a16="http://schemas.microsoft.com/office/drawing/2014/main" id="{E0F8B966-697A-4E14-AA35-D2397F4FF5B2}"/>
+                <a16:creationId xmlns:a16="http://schemas.microsoft.com/office/drawing/2014/main" id="{8900C267-2DAB-4195-9BB2-419556983BC8}"/>
               </a:ext>
             </a:extLst>
           </p:cNvPr>
@@ -4721,7 +4721,7 @@
                 <a:ea typeface="Arial"/>
                 <a:cs typeface="Arial"/>
               </a:rPr>
-              <a:t>IBIT  →  Bitcoin exposure</a:t>
+              <a:t>QQQ  →  Large Nasdaq companies; technology tilted</a:t>
             </a:r>
           </a:p>
         </p:txBody>
@@ -4729,7 +4729,7 @@
     </p:spTree>
     <p:extLst>
       <p:ext uri="{BB962C8B-B14F-4D97-AF65-F5344CB8AC3E}">
-        <p14:creationId xmlns:p14="http://schemas.microsoft.com/office/powerpoint/2010/main" val="1892121322"/>
+        <p14:creationId xmlns:p14="http://schemas.microsoft.com/office/powerpoint/2010/main" val="216281331"/>
       </p:ext>
     </p:extLst>
   </p:cSld>
@@ -4760,7 +4760,7 @@
           <p:cNvPr id="9" name="">
             <a:extLst xmlns:a="http://schemas.openxmlformats.org/drawingml/2006/main">
               <a:ext uri="{FF2B5EF4-FFF2-40B4-BE49-F238E27FC236}">
-                <a16:creationId xmlns:a16="http://schemas.microsoft.com/office/drawing/2014/main" id="{E0772533-DC81-4E65-9076-0660167702DB}"/>
+                <a16:creationId xmlns:a16="http://schemas.microsoft.com/office/drawing/2014/main" id="{371C7F9F-37EC-414D-A58C-A506C3A0344A}"/>
               </a:ext>
             </a:extLst>
           </p:cNvPr>
@@ -4817,7 +4817,7 @@
           <p:cNvPr id="2" name="">
             <a:extLst xmlns:a="http://schemas.openxmlformats.org/drawingml/2006/main">
               <a:ext uri="{FF2B5EF4-FFF2-40B4-BE49-F238E27FC236}">
-                <a16:creationId xmlns:a16="http://schemas.microsoft.com/office/drawing/2014/main" id="{97CCCDB0-E27C-41AA-80CD-B5CED06B5A09}"/>
+                <a16:creationId xmlns:a16="http://schemas.microsoft.com/office/drawing/2014/main" id="{E77D3F4B-3DD1-4D72-A509-E7E1E2A270F2}"/>
               </a:ext>
             </a:extLst>
           </p:cNvPr>
@@ -4874,7 +4874,7 @@
           <p:cNvPr id="3" name="">
             <a:extLst xmlns:a="http://schemas.openxmlformats.org/drawingml/2006/main">
               <a:ext uri="{FF2B5EF4-FFF2-40B4-BE49-F238E27FC236}">
-                <a16:creationId xmlns:a16="http://schemas.microsoft.com/office/drawing/2014/main" id="{B519EED4-28C2-4B36-921C-D10C2B80A02D}"/>
+                <a16:creationId xmlns:a16="http://schemas.microsoft.com/office/drawing/2014/main" id="{486B99B3-60E9-4207-8307-DD9DED00ED8D}"/>
               </a:ext>
             </a:extLst>
           </p:cNvPr>
@@ -4931,7 +4931,7 @@
           <p:cNvPr id="4" name="">
             <a:extLst xmlns:a="http://schemas.openxmlformats.org/drawingml/2006/main">
               <a:ext uri="{FF2B5EF4-FFF2-40B4-BE49-F238E27FC236}">
-                <a16:creationId xmlns:a16="http://schemas.microsoft.com/office/drawing/2014/main" id="{119C5706-3C55-4922-BA79-62DEF8976FCB}"/>
+                <a16:creationId xmlns:a16="http://schemas.microsoft.com/office/drawing/2014/main" id="{F44FC570-35EE-4FD0-B45F-E17A42344255}"/>
               </a:ext>
             </a:extLst>
           </p:cNvPr>
@@ -4988,7 +4988,7 @@
           <p:cNvPr id="5" name="">
             <a:extLst xmlns:a="http://schemas.openxmlformats.org/drawingml/2006/main">
               <a:ext uri="{FF2B5EF4-FFF2-40B4-BE49-F238E27FC236}">
-                <a16:creationId xmlns:a16="http://schemas.microsoft.com/office/drawing/2014/main" id="{CD0FFD23-8406-4070-A351-BC407E92B07E}"/>
+                <a16:creationId xmlns:a16="http://schemas.microsoft.com/office/drawing/2014/main" id="{416D9622-8341-494A-8C3B-106D12178781}"/>
               </a:ext>
             </a:extLst>
           </p:cNvPr>
@@ -5045,7 +5045,7 @@
           <p:cNvPr id="6" name="">
             <a:extLst xmlns:a="http://schemas.openxmlformats.org/drawingml/2006/main">
               <a:ext uri="{FF2B5EF4-FFF2-40B4-BE49-F238E27FC236}">
-                <a16:creationId xmlns:a16="http://schemas.microsoft.com/office/drawing/2014/main" id="{CCA6647D-A679-4FD5-8DB2-B7B158DC52C2}"/>
+                <a16:creationId xmlns:a16="http://schemas.microsoft.com/office/drawing/2014/main" id="{10B39352-8D40-4E33-A77F-D662FCC4B826}"/>
               </a:ext>
             </a:extLst>
           </p:cNvPr>
@@ -5102,7 +5102,7 @@
           <p:cNvPr id="7" name="">
             <a:extLst xmlns:a="http://schemas.openxmlformats.org/drawingml/2006/main">
               <a:ext uri="{FF2B5EF4-FFF2-40B4-BE49-F238E27FC236}">
-                <a16:creationId xmlns:a16="http://schemas.microsoft.com/office/drawing/2014/main" id="{3B26B477-07DC-4A72-B6AB-BA3F8440CCDA}"/>
+                <a16:creationId xmlns:a16="http://schemas.microsoft.com/office/drawing/2014/main" id="{5F7F5E26-1B73-4336-A5AD-35048522EFB9}"/>
               </a:ext>
             </a:extLst>
           </p:cNvPr>
@@ -5159,7 +5159,7 @@
           <p:cNvPr id="8" name="">
             <a:extLst xmlns:a="http://schemas.openxmlformats.org/drawingml/2006/main">
               <a:ext uri="{FF2B5EF4-FFF2-40B4-BE49-F238E27FC236}">
-                <a16:creationId xmlns:a16="http://schemas.microsoft.com/office/drawing/2014/main" id="{6CFA2D5C-5AB3-4D76-B7DD-F9F9A7999E3C}"/>
+                <a16:creationId xmlns:a16="http://schemas.microsoft.com/office/drawing/2014/main" id="{665D299D-6992-4A78-8B51-DD8A3D2F6959}"/>
               </a:ext>
             </a:extLst>
           </p:cNvPr>
@@ -5214,7 +5214,7 @@
     </p:spTree>
     <p:extLst>
       <p:ext uri="{BB962C8B-B14F-4D97-AF65-F5344CB8AC3E}">
-        <p14:creationId xmlns:p14="http://schemas.microsoft.com/office/powerpoint/2010/main" val="42237504"/>
+        <p14:creationId xmlns:p14="http://schemas.microsoft.com/office/powerpoint/2010/main" val="527990130"/>
       </p:ext>
     </p:extLst>
   </p:cSld>
@@ -5245,7 +5245,7 @@
           <p:cNvPr id="9" name="">
             <a:extLst xmlns:a="http://schemas.openxmlformats.org/drawingml/2006/main">
               <a:ext uri="{FF2B5EF4-FFF2-40B4-BE49-F238E27FC236}">
-                <a16:creationId xmlns:a16="http://schemas.microsoft.com/office/drawing/2014/main" id="{D4C38262-E4AE-4C36-A9AE-CC293FB7AFAB}"/>
+                <a16:creationId xmlns:a16="http://schemas.microsoft.com/office/drawing/2014/main" id="{60FEA383-7CED-41AF-B0E4-6CE975828210}"/>
               </a:ext>
             </a:extLst>
           </p:cNvPr>
@@ -5302,7 +5302,7 @@
           <p:cNvPr id="2" name="">
             <a:extLst xmlns:a="http://schemas.openxmlformats.org/drawingml/2006/main">
               <a:ext uri="{FF2B5EF4-FFF2-40B4-BE49-F238E27FC236}">
-                <a16:creationId xmlns:a16="http://schemas.microsoft.com/office/drawing/2014/main" id="{97BA51D0-CF89-4384-BF26-63D4682B5C89}"/>
+                <a16:creationId xmlns:a16="http://schemas.microsoft.com/office/drawing/2014/main" id="{96DB7AAB-CA36-4651-85B9-2EEA1996828E}"/>
               </a:ext>
             </a:extLst>
           </p:cNvPr>
@@ -5359,7 +5359,7 @@
           <p:cNvPr id="3" name="">
             <a:extLst xmlns:a="http://schemas.openxmlformats.org/drawingml/2006/main">
               <a:ext uri="{FF2B5EF4-FFF2-40B4-BE49-F238E27FC236}">
-                <a16:creationId xmlns:a16="http://schemas.microsoft.com/office/drawing/2014/main" id="{46205BF9-414E-46D7-8D0A-2A9254B5438C}"/>
+                <a16:creationId xmlns:a16="http://schemas.microsoft.com/office/drawing/2014/main" id="{21C038A9-1D8D-4246-9AB5-30ACAAEBBB61}"/>
               </a:ext>
             </a:extLst>
           </p:cNvPr>
@@ -5416,7 +5416,7 @@
           <p:cNvPr id="4" name="">
             <a:extLst xmlns:a="http://schemas.openxmlformats.org/drawingml/2006/main">
               <a:ext uri="{FF2B5EF4-FFF2-40B4-BE49-F238E27FC236}">
-                <a16:creationId xmlns:a16="http://schemas.microsoft.com/office/drawing/2014/main" id="{976D8840-42A2-401F-A3F5-1C419E6353A1}"/>
+                <a16:creationId xmlns:a16="http://schemas.microsoft.com/office/drawing/2014/main" id="{3241C036-1CC2-4917-B359-8ED393952A84}"/>
               </a:ext>
             </a:extLst>
           </p:cNvPr>
@@ -5473,7 +5473,7 @@
           <p:cNvPr id="5" name="">
             <a:extLst xmlns:a="http://schemas.openxmlformats.org/drawingml/2006/main">
               <a:ext uri="{FF2B5EF4-FFF2-40B4-BE49-F238E27FC236}">
-                <a16:creationId xmlns:a16="http://schemas.microsoft.com/office/drawing/2014/main" id="{E80C58D1-2738-443C-A259-8DFC2E29E836}"/>
+                <a16:creationId xmlns:a16="http://schemas.microsoft.com/office/drawing/2014/main" id="{F9814781-206B-4D2E-A63B-224B82E75C73}"/>
               </a:ext>
             </a:extLst>
           </p:cNvPr>
@@ -5530,7 +5530,7 @@
           <p:cNvPr id="6" name="">
             <a:extLst xmlns:a="http://schemas.openxmlformats.org/drawingml/2006/main">
               <a:ext uri="{FF2B5EF4-FFF2-40B4-BE49-F238E27FC236}">
-                <a16:creationId xmlns:a16="http://schemas.microsoft.com/office/drawing/2014/main" id="{F3F43B51-5B00-4623-9C32-7DC9F4B23EE5}"/>
+                <a16:creationId xmlns:a16="http://schemas.microsoft.com/office/drawing/2014/main" id="{5982B1D7-B0CD-4A48-AA6D-69108C715F06}"/>
               </a:ext>
             </a:extLst>
           </p:cNvPr>
@@ -5587,7 +5587,7 @@
           <p:cNvPr id="7" name="">
             <a:extLst xmlns:a="http://schemas.openxmlformats.org/drawingml/2006/main">
               <a:ext uri="{FF2B5EF4-FFF2-40B4-BE49-F238E27FC236}">
-                <a16:creationId xmlns:a16="http://schemas.microsoft.com/office/drawing/2014/main" id="{482B13AF-FD1E-46B5-8E61-E3FE68BFAC82}"/>
+                <a16:creationId xmlns:a16="http://schemas.microsoft.com/office/drawing/2014/main" id="{041637BA-1E4F-4C95-8D77-92786E57B2EE}"/>
               </a:ext>
             </a:extLst>
           </p:cNvPr>
@@ -5644,7 +5644,7 @@
           <p:cNvPr id="8" name="">
             <a:extLst xmlns:a="http://schemas.openxmlformats.org/drawingml/2006/main">
               <a:ext uri="{FF2B5EF4-FFF2-40B4-BE49-F238E27FC236}">
-                <a16:creationId xmlns:a16="http://schemas.microsoft.com/office/drawing/2014/main" id="{96269B6B-A645-4655-BEDE-CDF9EA406C5F}"/>
+                <a16:creationId xmlns:a16="http://schemas.microsoft.com/office/drawing/2014/main" id="{C2E6A98E-8A46-46DD-80B2-8F81F0507C31}"/>
               </a:ext>
             </a:extLst>
           </p:cNvPr>
@@ -5699,7 +5699,7 @@
     </p:spTree>
     <p:extLst>
       <p:ext uri="{BB962C8B-B14F-4D97-AF65-F5344CB8AC3E}">
-        <p14:creationId xmlns:p14="http://schemas.microsoft.com/office/powerpoint/2010/main" val="1109976672"/>
+        <p14:creationId xmlns:p14="http://schemas.microsoft.com/office/powerpoint/2010/main" val="2057541329"/>
       </p:ext>
     </p:extLst>
   </p:cSld>
@@ -5730,7 +5730,7 @@
           <p:cNvPr id="8" name="">
             <a:extLst xmlns:a="http://schemas.openxmlformats.org/drawingml/2006/main">
               <a:ext uri="{FF2B5EF4-FFF2-40B4-BE49-F238E27FC236}">
-                <a16:creationId xmlns:a16="http://schemas.microsoft.com/office/drawing/2014/main" id="{F232C863-1DDB-401C-8852-7641291DC111}"/>
+                <a16:creationId xmlns:a16="http://schemas.microsoft.com/office/drawing/2014/main" id="{1328366E-F8DF-47E0-A7CF-B3824BB46305}"/>
               </a:ext>
             </a:extLst>
           </p:cNvPr>
@@ -5787,7 +5787,7 @@
           <p:cNvPr id="2" name="">
             <a:extLst xmlns:a="http://schemas.openxmlformats.org/drawingml/2006/main">
               <a:ext uri="{FF2B5EF4-FFF2-40B4-BE49-F238E27FC236}">
-                <a16:creationId xmlns:a16="http://schemas.microsoft.com/office/drawing/2014/main" id="{EF76F8B9-A182-4F7A-A342-462EF391EE3C}"/>
+                <a16:creationId xmlns:a16="http://schemas.microsoft.com/office/drawing/2014/main" id="{0526294E-77F2-4C87-8E34-324D07831ED7}"/>
               </a:ext>
             </a:extLst>
           </p:cNvPr>
@@ -5844,7 +5844,7 @@
           <p:cNvPr id="3" name="">
             <a:extLst xmlns:a="http://schemas.openxmlformats.org/drawingml/2006/main">
               <a:ext uri="{FF2B5EF4-FFF2-40B4-BE49-F238E27FC236}">
-                <a16:creationId xmlns:a16="http://schemas.microsoft.com/office/drawing/2014/main" id="{1FA600BC-9480-4298-ACFF-92E71FD2C60C}"/>
+                <a16:creationId xmlns:a16="http://schemas.microsoft.com/office/drawing/2014/main" id="{C73D0935-7FAC-4908-BDD8-61425058D054}"/>
               </a:ext>
             </a:extLst>
           </p:cNvPr>
@@ -5901,7 +5901,7 @@
           <p:cNvPr id="4" name="">
             <a:extLst xmlns:a="http://schemas.openxmlformats.org/drawingml/2006/main">
               <a:ext uri="{FF2B5EF4-FFF2-40B4-BE49-F238E27FC236}">
-                <a16:creationId xmlns:a16="http://schemas.microsoft.com/office/drawing/2014/main" id="{703BC8BC-2965-4317-B8CC-639D922D2EA6}"/>
+                <a16:creationId xmlns:a16="http://schemas.microsoft.com/office/drawing/2014/main" id="{30521CAD-5C56-4B87-BCF9-59996F258B7E}"/>
               </a:ext>
             </a:extLst>
           </p:cNvPr>
@@ -5958,7 +5958,7 @@
           <p:cNvPr id="5" name="">
             <a:extLst xmlns:a="http://schemas.openxmlformats.org/drawingml/2006/main">
               <a:ext uri="{FF2B5EF4-FFF2-40B4-BE49-F238E27FC236}">
-                <a16:creationId xmlns:a16="http://schemas.microsoft.com/office/drawing/2014/main" id="{D259593A-7E99-4F10-8B7F-126B5BC7E047}"/>
+                <a16:creationId xmlns:a16="http://schemas.microsoft.com/office/drawing/2014/main" id="{EA45623E-7B0B-4E9A-972A-1C9DA9EE2D14}"/>
               </a:ext>
             </a:extLst>
           </p:cNvPr>
@@ -6015,7 +6015,7 @@
           <p:cNvPr id="6" name="">
             <a:extLst xmlns:a="http://schemas.openxmlformats.org/drawingml/2006/main">
               <a:ext uri="{FF2B5EF4-FFF2-40B4-BE49-F238E27FC236}">
-                <a16:creationId xmlns:a16="http://schemas.microsoft.com/office/drawing/2014/main" id="{45994CEB-BE02-435A-9F05-073C806AE851}"/>
+                <a16:creationId xmlns:a16="http://schemas.microsoft.com/office/drawing/2014/main" id="{0A29D0B0-6AD0-43B4-9424-7D6C9C413F53}"/>
               </a:ext>
             </a:extLst>
           </p:cNvPr>
@@ -6072,7 +6072,7 @@
           <p:cNvPr id="7" name="">
             <a:extLst xmlns:a="http://schemas.openxmlformats.org/drawingml/2006/main">
               <a:ext uri="{FF2B5EF4-FFF2-40B4-BE49-F238E27FC236}">
-                <a16:creationId xmlns:a16="http://schemas.microsoft.com/office/drawing/2014/main" id="{09783333-4EAA-4067-B357-15A6B50EAC5A}"/>
+                <a16:creationId xmlns:a16="http://schemas.microsoft.com/office/drawing/2014/main" id="{391C5C6D-5452-497C-82AC-BD5FA19FE05A}"/>
               </a:ext>
             </a:extLst>
           </p:cNvPr>
@@ -6127,7 +6127,7 @@
     </p:spTree>
     <p:extLst>
       <p:ext uri="{BB962C8B-B14F-4D97-AF65-F5344CB8AC3E}">
-        <p14:creationId xmlns:p14="http://schemas.microsoft.com/office/powerpoint/2010/main" val="820098016"/>
+        <p14:creationId xmlns:p14="http://schemas.microsoft.com/office/powerpoint/2010/main" val="756145041"/>
       </p:ext>
     </p:extLst>
   </p:cSld>
@@ -6158,7 +6158,7 @@
           <p:cNvPr id="7" name="">
             <a:extLst xmlns:a="http://schemas.openxmlformats.org/drawingml/2006/main">
               <a:ext uri="{FF2B5EF4-FFF2-40B4-BE49-F238E27FC236}">
-                <a16:creationId xmlns:a16="http://schemas.microsoft.com/office/drawing/2014/main" id="{E296CFDF-07C9-45EF-916F-4DE9D37A42CE}"/>
+                <a16:creationId xmlns:a16="http://schemas.microsoft.com/office/drawing/2014/main" id="{64AE453E-FD53-4807-8323-EA9DFBC20D1E}"/>
               </a:ext>
             </a:extLst>
           </p:cNvPr>
@@ -6215,7 +6215,7 @@
           <p:cNvPr id="2" name="">
             <a:extLst xmlns:a="http://schemas.openxmlformats.org/drawingml/2006/main">
               <a:ext uri="{FF2B5EF4-FFF2-40B4-BE49-F238E27FC236}">
-                <a16:creationId xmlns:a16="http://schemas.microsoft.com/office/drawing/2014/main" id="{EC0BF7C0-81E7-4DDE-A1EA-92406AE7AA1F}"/>
+                <a16:creationId xmlns:a16="http://schemas.microsoft.com/office/drawing/2014/main" id="{47D89786-6D2C-41C0-8512-09044869DFC4}"/>
               </a:ext>
             </a:extLst>
           </p:cNvPr>
@@ -6272,7 +6272,7 @@
           <p:cNvPr id="3" name="">
             <a:extLst xmlns:a="http://schemas.openxmlformats.org/drawingml/2006/main">
               <a:ext uri="{FF2B5EF4-FFF2-40B4-BE49-F238E27FC236}">
-                <a16:creationId xmlns:a16="http://schemas.microsoft.com/office/drawing/2014/main" id="{7E01127C-DD18-4D89-AF31-0C969B09D4AC}"/>
+                <a16:creationId xmlns:a16="http://schemas.microsoft.com/office/drawing/2014/main" id="{8ABA28E7-BF1E-4C2F-B6C1-2DF4F229EB0B}"/>
               </a:ext>
             </a:extLst>
           </p:cNvPr>
@@ -6329,7 +6329,7 @@
           <p:cNvPr id="4" name="">
             <a:extLst xmlns:a="http://schemas.openxmlformats.org/drawingml/2006/main">
               <a:ext uri="{FF2B5EF4-FFF2-40B4-BE49-F238E27FC236}">
-                <a16:creationId xmlns:a16="http://schemas.microsoft.com/office/drawing/2014/main" id="{6D9951F6-247B-45CA-8E52-D5C828AE5999}"/>
+                <a16:creationId xmlns:a16="http://schemas.microsoft.com/office/drawing/2014/main" id="{B50C6662-31D9-49D7-8F57-BBC4A17C9516}"/>
               </a:ext>
             </a:extLst>
           </p:cNvPr>
@@ -6386,7 +6386,7 @@
           <p:cNvPr id="5" name="">
             <a:extLst xmlns:a="http://schemas.openxmlformats.org/drawingml/2006/main">
               <a:ext uri="{FF2B5EF4-FFF2-40B4-BE49-F238E27FC236}">
-                <a16:creationId xmlns:a16="http://schemas.microsoft.com/office/drawing/2014/main" id="{D2EC08B6-C3C0-4E9D-9F72-DED7C2C0B7CE}"/>
+                <a16:creationId xmlns:a16="http://schemas.microsoft.com/office/drawing/2014/main" id="{BE8BE172-B793-4F8B-8207-01E8B3875B53}"/>
               </a:ext>
             </a:extLst>
           </p:cNvPr>
@@ -6443,7 +6443,7 @@
           <p:cNvPr id="6" name="">
             <a:extLst xmlns:a="http://schemas.openxmlformats.org/drawingml/2006/main">
               <a:ext uri="{FF2B5EF4-FFF2-40B4-BE49-F238E27FC236}">
-                <a16:creationId xmlns:a16="http://schemas.microsoft.com/office/drawing/2014/main" id="{D5952C9E-D6D5-47D1-B3A6-110DF226D811}"/>
+                <a16:creationId xmlns:a16="http://schemas.microsoft.com/office/drawing/2014/main" id="{7D12867A-E134-4D13-8AD3-FF94359B3ED5}"/>
               </a:ext>
             </a:extLst>
           </p:cNvPr>
@@ -6498,7 +6498,7 @@
     </p:spTree>
     <p:extLst>
       <p:ext uri="{BB962C8B-B14F-4D97-AF65-F5344CB8AC3E}">
-        <p14:creationId xmlns:p14="http://schemas.microsoft.com/office/powerpoint/2010/main" val="381415624"/>
+        <p14:creationId xmlns:p14="http://schemas.microsoft.com/office/powerpoint/2010/main" val="965544412"/>
       </p:ext>
     </p:extLst>
   </p:cSld>
@@ -6529,7 +6529,7 @@
           <p:cNvPr id="9" name="">
             <a:extLst xmlns:a="http://schemas.openxmlformats.org/drawingml/2006/main">
               <a:ext uri="{FF2B5EF4-FFF2-40B4-BE49-F238E27FC236}">
-                <a16:creationId xmlns:a16="http://schemas.microsoft.com/office/drawing/2014/main" id="{A8321EF9-EEC4-4E14-882E-FA7A986DD481}"/>
+                <a16:creationId xmlns:a16="http://schemas.microsoft.com/office/drawing/2014/main" id="{C8772634-4CFB-4C82-B2B0-15B1E39C176A}"/>
               </a:ext>
             </a:extLst>
           </p:cNvPr>
@@ -6586,7 +6586,7 @@
           <p:cNvPr id="2" name="">
             <a:extLst xmlns:a="http://schemas.openxmlformats.org/drawingml/2006/main">
               <a:ext uri="{FF2B5EF4-FFF2-40B4-BE49-F238E27FC236}">
-                <a16:creationId xmlns:a16="http://schemas.microsoft.com/office/drawing/2014/main" id="{2524E38A-1FD9-4FF9-81BF-1FF158334DB2}"/>
+                <a16:creationId xmlns:a16="http://schemas.microsoft.com/office/drawing/2014/main" id="{4086E3D1-A76D-4FDC-AEDD-1F714CD31464}"/>
               </a:ext>
             </a:extLst>
           </p:cNvPr>
@@ -6643,7 +6643,7 @@
           <p:cNvPr id="3" name="">
             <a:extLst xmlns:a="http://schemas.openxmlformats.org/drawingml/2006/main">
               <a:ext uri="{FF2B5EF4-FFF2-40B4-BE49-F238E27FC236}">
-                <a16:creationId xmlns:a16="http://schemas.microsoft.com/office/drawing/2014/main" id="{4E2075FE-C666-467F-8450-8202EC677914}"/>
+                <a16:creationId xmlns:a16="http://schemas.microsoft.com/office/drawing/2014/main" id="{0AFDFD2F-9DE2-4E10-8E16-EB9AB89FBB36}"/>
               </a:ext>
             </a:extLst>
           </p:cNvPr>
@@ -6700,7 +6700,7 @@
           <p:cNvPr id="4" name="">
             <a:extLst xmlns:a="http://schemas.openxmlformats.org/drawingml/2006/main">
               <a:ext uri="{FF2B5EF4-FFF2-40B4-BE49-F238E27FC236}">
-                <a16:creationId xmlns:a16="http://schemas.microsoft.com/office/drawing/2014/main" id="{9AB21FD0-689A-4F12-93C4-B11C20D559F2}"/>
+                <a16:creationId xmlns:a16="http://schemas.microsoft.com/office/drawing/2014/main" id="{727882C9-76A1-44AE-80F6-D8AC0BD1BEDA}"/>
               </a:ext>
             </a:extLst>
           </p:cNvPr>
@@ -6757,7 +6757,7 @@
           <p:cNvPr id="5" name="">
             <a:extLst xmlns:a="http://schemas.openxmlformats.org/drawingml/2006/main">
               <a:ext uri="{FF2B5EF4-FFF2-40B4-BE49-F238E27FC236}">
-                <a16:creationId xmlns:a16="http://schemas.microsoft.com/office/drawing/2014/main" id="{4F68ACE3-C9EC-4C93-AECE-D471C47D204A}"/>
+                <a16:creationId xmlns:a16="http://schemas.microsoft.com/office/drawing/2014/main" id="{B27F4AB9-834B-4FE9-A07C-24F212905117}"/>
               </a:ext>
             </a:extLst>
           </p:cNvPr>
@@ -6814,7 +6814,7 @@
           <p:cNvPr id="6" name="">
             <a:extLst xmlns:a="http://schemas.openxmlformats.org/drawingml/2006/main">
               <a:ext uri="{FF2B5EF4-FFF2-40B4-BE49-F238E27FC236}">
-                <a16:creationId xmlns:a16="http://schemas.microsoft.com/office/drawing/2014/main" id="{3BC94B0E-5F7E-4F17-B6FC-93F483EE0456}"/>
+                <a16:creationId xmlns:a16="http://schemas.microsoft.com/office/drawing/2014/main" id="{03B02B38-0E6E-4CE4-854B-4AFBB6A90D39}"/>
               </a:ext>
             </a:extLst>
           </p:cNvPr>
@@ -6917,7 +6917,7 @@
           <p:cNvPr id="7" name="">
             <a:extLst xmlns:a="http://schemas.openxmlformats.org/drawingml/2006/main">
               <a:ext uri="{FF2B5EF4-FFF2-40B4-BE49-F238E27FC236}">
-                <a16:creationId xmlns:a16="http://schemas.microsoft.com/office/drawing/2014/main" id="{D5C123C1-E956-4373-B0C1-3CEAAF7BCA0A}"/>
+                <a16:creationId xmlns:a16="http://schemas.microsoft.com/office/drawing/2014/main" id="{B02D5346-967E-43AD-B23B-E867ECF6B50C}"/>
               </a:ext>
             </a:extLst>
           </p:cNvPr>
@@ -6974,7 +6974,7 @@
           <p:cNvPr id="8" name="">
             <a:extLst xmlns:a="http://schemas.openxmlformats.org/drawingml/2006/main">
               <a:ext uri="{FF2B5EF4-FFF2-40B4-BE49-F238E27FC236}">
-                <a16:creationId xmlns:a16="http://schemas.microsoft.com/office/drawing/2014/main" id="{069F27BE-4B27-4AB6-82AF-E5DECDB27231}"/>
+                <a16:creationId xmlns:a16="http://schemas.microsoft.com/office/drawing/2014/main" id="{4529001F-7A4F-430E-A629-02AB24F5D686}"/>
               </a:ext>
             </a:extLst>
           </p:cNvPr>
@@ -7075,7 +7075,7 @@
     </p:spTree>
     <p:extLst>
       <p:ext uri="{BB962C8B-B14F-4D97-AF65-F5344CB8AC3E}">
-        <p14:creationId xmlns:p14="http://schemas.microsoft.com/office/powerpoint/2010/main" val="1726282112"/>
+        <p14:creationId xmlns:p14="http://schemas.microsoft.com/office/powerpoint/2010/main" val="1960122303"/>
       </p:ext>
     </p:extLst>
   </p:cSld>

</xml_diff>

<commit_message>
Make Module 3 a two-ETF portfolio mission
</commit_message>
<xml_diff>
--- a/docs/module3-etfs/output/Module_3_ETFs_Lesson.pptx
+++ b/docs/module3-etfs/output/Module_3_ETFs_Lesson.pptx
@@ -2,24 +2,24 @@
 <file path=ppt/presentation.xml><?xml version="1.0" encoding="utf-8"?>
 <p:presentation xmlns:p="http://schemas.openxmlformats.org/presentationml/2006/main">
   <p:sldMasterIdLst>
-    <p:sldMasterId xmlns:r="http://schemas.openxmlformats.org/officeDocument/2006/relationships" id="2147483648" r:id="R0ef058fca9884a77"/>
+    <p:sldMasterId xmlns:r="http://schemas.openxmlformats.org/officeDocument/2006/relationships" id="2147483648" r:id="R10b659b71ca740ba"/>
   </p:sldMasterIdLst>
   <p:notesMasterIdLst>
-    <p:notesMasterId xmlns:r="http://schemas.openxmlformats.org/officeDocument/2006/relationships" r:id="R32e95d3c5cf1421e"/>
+    <p:notesMasterId xmlns:r="http://schemas.openxmlformats.org/officeDocument/2006/relationships" r:id="Rc2c7becfba024ee2"/>
   </p:notesMasterIdLst>
   <p:sldIdLst>
-    <p:sldId xmlns:r="http://schemas.openxmlformats.org/officeDocument/2006/relationships" id="256" r:id="Ra570fb1e6c19456a"/>
-    <p:sldId xmlns:r="http://schemas.openxmlformats.org/officeDocument/2006/relationships" id="257" r:id="R01c4e2b6f4b64465"/>
-    <p:sldId xmlns:r="http://schemas.openxmlformats.org/officeDocument/2006/relationships" id="258" r:id="R809c267f8ec145eb"/>
-    <p:sldId xmlns:r="http://schemas.openxmlformats.org/officeDocument/2006/relationships" id="259" r:id="Rfdad04ab1b1343bb"/>
-    <p:sldId xmlns:r="http://schemas.openxmlformats.org/officeDocument/2006/relationships" id="260" r:id="Rf2dc0ba6cb994a37"/>
-    <p:sldId xmlns:r="http://schemas.openxmlformats.org/officeDocument/2006/relationships" id="261" r:id="R54951a412b2249d9"/>
-    <p:sldId xmlns:r="http://schemas.openxmlformats.org/officeDocument/2006/relationships" id="262" r:id="R069fb44d633b408e"/>
-    <p:sldId xmlns:r="http://schemas.openxmlformats.org/officeDocument/2006/relationships" id="263" r:id="R1f52f3d564b54c5e"/>
-    <p:sldId xmlns:r="http://schemas.openxmlformats.org/officeDocument/2006/relationships" id="264" r:id="R9f83001a9edf44c9"/>
-    <p:sldId xmlns:r="http://schemas.openxmlformats.org/officeDocument/2006/relationships" id="265" r:id="Rff0bb9324f5740f1"/>
-    <p:sldId xmlns:r="http://schemas.openxmlformats.org/officeDocument/2006/relationships" id="266" r:id="Rcf66c546ef6f4456"/>
-    <p:sldId xmlns:r="http://schemas.openxmlformats.org/officeDocument/2006/relationships" id="267" r:id="R11c3da9166334c5d"/>
+    <p:sldId xmlns:r="http://schemas.openxmlformats.org/officeDocument/2006/relationships" id="256" r:id="R749cb38325fd41db"/>
+    <p:sldId xmlns:r="http://schemas.openxmlformats.org/officeDocument/2006/relationships" id="257" r:id="Rea5c12c3d6404266"/>
+    <p:sldId xmlns:r="http://schemas.openxmlformats.org/officeDocument/2006/relationships" id="258" r:id="R11f5e08630cf4ba6"/>
+    <p:sldId xmlns:r="http://schemas.openxmlformats.org/officeDocument/2006/relationships" id="259" r:id="Rf87fa734e4bb4ac2"/>
+    <p:sldId xmlns:r="http://schemas.openxmlformats.org/officeDocument/2006/relationships" id="260" r:id="Rb87fc5ee152f43b1"/>
+    <p:sldId xmlns:r="http://schemas.openxmlformats.org/officeDocument/2006/relationships" id="261" r:id="R5c6118cd47f84767"/>
+    <p:sldId xmlns:r="http://schemas.openxmlformats.org/officeDocument/2006/relationships" id="262" r:id="R44327b9ecf1a468e"/>
+    <p:sldId xmlns:r="http://schemas.openxmlformats.org/officeDocument/2006/relationships" id="263" r:id="R8d379beb1d724bdc"/>
+    <p:sldId xmlns:r="http://schemas.openxmlformats.org/officeDocument/2006/relationships" id="264" r:id="R50b05ae3690e4c7c"/>
+    <p:sldId xmlns:r="http://schemas.openxmlformats.org/officeDocument/2006/relationships" id="265" r:id="R9bd9db0a819a4fbf"/>
+    <p:sldId xmlns:r="http://schemas.openxmlformats.org/officeDocument/2006/relationships" id="266" r:id="R18462eea307f479e"/>
+    <p:sldId xmlns:r="http://schemas.openxmlformats.org/officeDocument/2006/relationships" id="267" r:id="R59811aa17c124809"/>
   </p:sldIdLst>
   <p:sldSz cx="12192000" cy="6858000"/>
   <p:notesSz cx="6858000" cy="9144000"/>
@@ -523,7 +523,7 @@
           <a:lstStyle xmlns:a="http://schemas.openxmlformats.org/drawingml/2006/main"/>
           <a:p xmlns:a="http://schemas.openxmlformats.org/drawingml/2006/main">
             <a:r>
-              <a:t>The app checks current holdings for a broad stock or bond ETF. Students choose one held fund and enter a second ETF they researched. No fixed spending minimum and no requirement to preserve Module 2 holdings. Sector, thematic, commodity, and crypto single-asset ETFs do not satisfy the broad fund check.</a:t>
+              <a:t>The app checks for two different current ETF holdings. Broad, sector, and thematic funds count; single asset products do not. The teacher judges whether each explanation connects the fund to the stated goal. No fixed spending minimum and no requirement to preserve Module 2 holdings.</a:t>
             </a:r>
           </a:p>
         </p:txBody>
@@ -593,7 +593,7 @@
           <a:lstStyle xmlns:a="http://schemas.openxmlformats.org/drawingml/2006/main"/>
           <a:p xmlns:a="http://schemas.openxmlformats.org/drawingml/2006/main">
             <a:r>
-              <a:t>Model answer only. Students should use their own actual portfolio and fund research. Ask the class to identify the gap, comparison, decision, and remaining risk. Do not grade on agreement with one ticker.</a:t>
+              <a:t>Model answer only. Students should use their own actual portfolio and fund research. Ask the class to identify both goals, the fund fit, overlap, and remaining risks. Do not grade on agreement with one ticker.</a:t>
             </a:r>
           </a:p>
           <a:p xmlns:a="http://schemas.openxmlformats.org/drawingml/2006/main">
@@ -683,7 +683,7 @@
           <a:lstStyle xmlns:a="http://schemas.openxmlformats.org/drawingml/2006/main"/>
           <a:p xmlns:a="http://schemas.openxmlformats.org/drawingml/2006/main">
             <a:r>
-              <a:t>Collect responses before independent work. Ask students to name a concrete holding or sector in their current portfolio. Teacher can publish the saved draft from Teacher → Class when ready.</a:t>
+              <a:t>Collect responses before independent work. Ask students to name a concrete holding or sector in their current portfolio.</a:t>
             </a:r>
           </a:p>
         </p:txBody>
@@ -1358,7 +1358,7 @@
           <a:lstStyle xmlns:a="http://schemas.openxmlformats.org/drawingml/2006/main"/>
           <a:p xmlns:a="http://schemas.openxmlformats.org/drawingml/2006/main">
             <a:r>
-              <a:t>Ask students: Which fits the stated gap better? If the gap is geographic, VXUS is the clearer explanation. If the goal is broad U.S. coverage, VTI may fit. Check current fund pages for holdings and costs; do not imply one is universally best.</a:t>
+              <a:t>Ask students: Which area has little exposure, and which different area do they want to emphasize? These sample funds illustrate exposure, not a recommendation. Check current fund pages for holdings and costs.</a:t>
             </a:r>
           </a:p>
           <a:p xmlns:a="http://schemas.openxmlformats.org/drawingml/2006/main">
@@ -1441,7 +1441,7 @@
   </p:cSld>
   <p:clrMap bg1="lt1" tx1="dk1" bg2="lt2" tx2="dk2" accent1="accent1" accent2="accent2" accent3="accent3" accent4="accent4" accent5="accent5" accent6="accent6" hlink="hlink" folHlink="folHlink"/>
   <p:sldLayoutIdLst>
-    <p:sldLayoutId xmlns:r="http://schemas.openxmlformats.org/officeDocument/2006/relationships" id="2147483649" r:id="Re0087b03fe5a435f"/>
+    <p:sldLayoutId xmlns:r="http://schemas.openxmlformats.org/officeDocument/2006/relationships" id="2147483649" r:id="R5ab128c0b00d48dc"/>
   </p:sldLayoutIdLst>
   <p:txStyles>
     <p:titleStyle>
@@ -1992,7 +1992,7 @@
           <p:cNvPr id="6" name="">
             <a:extLst xmlns:a="http://schemas.openxmlformats.org/drawingml/2006/main">
               <a:ext uri="{FF2B5EF4-FFF2-40B4-BE49-F238E27FC236}">
-                <a16:creationId xmlns:a16="http://schemas.microsoft.com/office/drawing/2014/main" id="{836B39D3-3AEF-4A64-A5EF-076E4F4E420F}"/>
+                <a16:creationId xmlns:a16="http://schemas.microsoft.com/office/drawing/2014/main" id="{59860AB7-6138-45B3-BD64-73FE2B3EC5F6}"/>
               </a:ext>
             </a:extLst>
           </p:cNvPr>
@@ -2049,7 +2049,7 @@
           <p:cNvPr id="2" name="">
             <a:extLst xmlns:a="http://schemas.openxmlformats.org/drawingml/2006/main">
               <a:ext uri="{FF2B5EF4-FFF2-40B4-BE49-F238E27FC236}">
-                <a16:creationId xmlns:a16="http://schemas.microsoft.com/office/drawing/2014/main" id="{AC676FF8-8CBD-4827-B1DD-77BD4BF61C99}"/>
+                <a16:creationId xmlns:a16="http://schemas.microsoft.com/office/drawing/2014/main" id="{AFB14DD9-1369-4395-96D7-84E9E3F796FB}"/>
               </a:ext>
             </a:extLst>
           </p:cNvPr>
@@ -2106,7 +2106,7 @@
           <p:cNvPr id="3" name="">
             <a:extLst xmlns:a="http://schemas.openxmlformats.org/drawingml/2006/main">
               <a:ext uri="{FF2B5EF4-FFF2-40B4-BE49-F238E27FC236}">
-                <a16:creationId xmlns:a16="http://schemas.microsoft.com/office/drawing/2014/main" id="{7D018B78-595F-482F-BC77-2A09281F983C}"/>
+                <a16:creationId xmlns:a16="http://schemas.microsoft.com/office/drawing/2014/main" id="{CA8F09AD-964C-4DEA-BE07-D015CEBAE220}"/>
               </a:ext>
             </a:extLst>
           </p:cNvPr>
@@ -2163,7 +2163,7 @@
           <p:cNvPr id="4" name="">
             <a:extLst xmlns:a="http://schemas.openxmlformats.org/drawingml/2006/main">
               <a:ext uri="{FF2B5EF4-FFF2-40B4-BE49-F238E27FC236}">
-                <a16:creationId xmlns:a16="http://schemas.microsoft.com/office/drawing/2014/main" id="{D78FDDC6-B9E3-49C2-8A76-F9E47F994A2F}"/>
+                <a16:creationId xmlns:a16="http://schemas.microsoft.com/office/drawing/2014/main" id="{2A2C137A-E192-4006-9EC4-7CA8EC821ACD}"/>
               </a:ext>
             </a:extLst>
           </p:cNvPr>
@@ -2220,7 +2220,7 @@
           <p:cNvPr id="5" name="">
             <a:extLst xmlns:a="http://schemas.openxmlformats.org/drawingml/2006/main">
               <a:ext uri="{FF2B5EF4-FFF2-40B4-BE49-F238E27FC236}">
-                <a16:creationId xmlns:a16="http://schemas.microsoft.com/office/drawing/2014/main" id="{C63F1C36-8D3C-4F89-80BB-2D5D45460EAF}"/>
+                <a16:creationId xmlns:a16="http://schemas.microsoft.com/office/drawing/2014/main" id="{F0639318-249D-4899-BFC2-4C9F3C418496}"/>
               </a:ext>
             </a:extLst>
           </p:cNvPr>
@@ -2267,7 +2267,7 @@
                 <a:ea typeface="Arial"/>
                 <a:cs typeface="Arial"/>
               </a:rPr>
-              <a:t>Today: find a gap in your portfolio, compare funds, and choose one you can explain.</a:t>
+              <a:t>Today: use one ETF to fill a gap and another to back an idea you believe in.</a:t>
             </a:r>
           </a:p>
         </p:txBody>
@@ -2275,7 +2275,7 @@
     </p:spTree>
     <p:extLst>
       <p:ext uri="{BB962C8B-B14F-4D97-AF65-F5344CB8AC3E}">
-        <p14:creationId xmlns:p14="http://schemas.microsoft.com/office/powerpoint/2010/main" val="204427643"/>
+        <p14:creationId xmlns:p14="http://schemas.microsoft.com/office/powerpoint/2010/main" val="229057472"/>
       </p:ext>
     </p:extLst>
   </p:cSld>
@@ -2306,7 +2306,7 @@
           <p:cNvPr id="8" name="">
             <a:extLst xmlns:a="http://schemas.openxmlformats.org/drawingml/2006/main">
               <a:ext uri="{FF2B5EF4-FFF2-40B4-BE49-F238E27FC236}">
-                <a16:creationId xmlns:a16="http://schemas.microsoft.com/office/drawing/2014/main" id="{E6F8152D-D740-48F6-A168-4FD5E3175FA7}"/>
+                <a16:creationId xmlns:a16="http://schemas.microsoft.com/office/drawing/2014/main" id="{2C5CCD9C-2C3F-4241-901A-02303AEC2D95}"/>
               </a:ext>
             </a:extLst>
           </p:cNvPr>
@@ -2363,7 +2363,7 @@
           <p:cNvPr id="2" name="">
             <a:extLst xmlns:a="http://schemas.openxmlformats.org/drawingml/2006/main">
               <a:ext uri="{FF2B5EF4-FFF2-40B4-BE49-F238E27FC236}">
-                <a16:creationId xmlns:a16="http://schemas.microsoft.com/office/drawing/2014/main" id="{C00D4682-1EA4-4C40-99B6-430A7E0401E5}"/>
+                <a16:creationId xmlns:a16="http://schemas.microsoft.com/office/drawing/2014/main" id="{C120D794-C6CE-49AD-982B-17B2C5AD20D7}"/>
               </a:ext>
             </a:extLst>
           </p:cNvPr>
@@ -2420,7 +2420,7 @@
           <p:cNvPr id="3" name="">
             <a:extLst xmlns:a="http://schemas.openxmlformats.org/drawingml/2006/main">
               <a:ext uri="{FF2B5EF4-FFF2-40B4-BE49-F238E27FC236}">
-                <a16:creationId xmlns:a16="http://schemas.microsoft.com/office/drawing/2014/main" id="{43C0B552-9B91-49E5-9355-125551629117}"/>
+                <a16:creationId xmlns:a16="http://schemas.microsoft.com/office/drawing/2014/main" id="{EFBD91FD-1395-46EC-8D36-B7F4965F4442}"/>
               </a:ext>
             </a:extLst>
           </p:cNvPr>
@@ -2477,7 +2477,7 @@
           <p:cNvPr id="4" name="">
             <a:extLst xmlns:a="http://schemas.openxmlformats.org/drawingml/2006/main">
               <a:ext uri="{FF2B5EF4-FFF2-40B4-BE49-F238E27FC236}">
-                <a16:creationId xmlns:a16="http://schemas.microsoft.com/office/drawing/2014/main" id="{2D44B5B9-6F36-436A-9517-655D3127C9CD}"/>
+                <a16:creationId xmlns:a16="http://schemas.microsoft.com/office/drawing/2014/main" id="{A520B61A-AA83-48EB-861C-2071450F45D5}"/>
               </a:ext>
             </a:extLst>
           </p:cNvPr>
@@ -2524,7 +2524,7 @@
                 <a:ea typeface="Arial"/>
                 <a:cs typeface="Arial"/>
               </a:rPr>
-              <a:t>Identify a gap or concentration in your portfolio.</a:t>
+              <a:t>Find an area with little exposure; hold an ETF to fill it.</a:t>
             </a:r>
           </a:p>
         </p:txBody>
@@ -2534,7 +2534,7 @@
           <p:cNvPr id="5" name="">
             <a:extLst xmlns:a="http://schemas.openxmlformats.org/drawingml/2006/main">
               <a:ext uri="{FF2B5EF4-FFF2-40B4-BE49-F238E27FC236}">
-                <a16:creationId xmlns:a16="http://schemas.microsoft.com/office/drawing/2014/main" id="{4133FD98-B72C-43DA-A029-72C6806F70F4}"/>
+                <a16:creationId xmlns:a16="http://schemas.microsoft.com/office/drawing/2014/main" id="{0B7098A9-F000-453D-B270-3B14C097DDEF}"/>
               </a:ext>
             </a:extLst>
           </p:cNvPr>
@@ -2581,7 +2581,7 @@
                 <a:ea typeface="Arial"/>
                 <a:cs typeface="Arial"/>
               </a:rPr>
-              <a:t>Compare two ETFs: holdings, overlap, fees, and risk.</a:t>
+              <a:t>Find a different idea you believe in; hold a second ETF.</a:t>
             </a:r>
           </a:p>
         </p:txBody>
@@ -2591,7 +2591,7 @@
           <p:cNvPr id="6" name="">
             <a:extLst xmlns:a="http://schemas.openxmlformats.org/drawingml/2006/main">
               <a:ext uri="{FF2B5EF4-FFF2-40B4-BE49-F238E27FC236}">
-                <a16:creationId xmlns:a16="http://schemas.microsoft.com/office/drawing/2014/main" id="{AE67FC85-E4EE-4A64-8925-E2BB7C129128}"/>
+                <a16:creationId xmlns:a16="http://schemas.microsoft.com/office/drawing/2014/main" id="{198339A1-80A4-4AB2-8BD7-3B6B62BF1FDE}"/>
               </a:ext>
             </a:extLst>
           </p:cNvPr>
@@ -2638,7 +2638,7 @@
                 <a:ea typeface="Arial"/>
                 <a:cs typeface="Arial"/>
               </a:rPr>
-              <a:t>Hold one broad stock or bond ETF that fits your goal.</a:t>
+              <a:t>Explain how each fund serves its goal.</a:t>
             </a:r>
           </a:p>
         </p:txBody>
@@ -2648,7 +2648,7 @@
           <p:cNvPr id="7" name="">
             <a:extLst xmlns:a="http://schemas.openxmlformats.org/drawingml/2006/main">
               <a:ext uri="{FF2B5EF4-FFF2-40B4-BE49-F238E27FC236}">
-                <a16:creationId xmlns:a16="http://schemas.microsoft.com/office/drawing/2014/main" id="{A57A111F-02A6-4E75-BF8B-A5CAFB50FF66}"/>
+                <a16:creationId xmlns:a16="http://schemas.microsoft.com/office/drawing/2014/main" id="{5E472AF8-78FF-4A03-8CF3-F805D79AC87C}"/>
               </a:ext>
             </a:extLst>
           </p:cNvPr>
@@ -2695,7 +2695,7 @@
                 <a:ea typeface="Arial"/>
                 <a:cs typeface="Arial"/>
               </a:rPr>
-              <a:t>Explain the effect you expect and the risk that remains.</a:t>
+              <a:t>Check both funds’ holdings, overlap, fees, and risks.</a:t>
             </a:r>
           </a:p>
         </p:txBody>
@@ -2703,7 +2703,7 @@
     </p:spTree>
     <p:extLst>
       <p:ext uri="{BB962C8B-B14F-4D97-AF65-F5344CB8AC3E}">
-        <p14:creationId xmlns:p14="http://schemas.microsoft.com/office/powerpoint/2010/main" val="527651236"/>
+        <p14:creationId xmlns:p14="http://schemas.microsoft.com/office/powerpoint/2010/main" val="1523284784"/>
       </p:ext>
     </p:extLst>
   </p:cSld>
@@ -2734,7 +2734,7 @@
           <p:cNvPr id="5" name="">
             <a:extLst xmlns:a="http://schemas.openxmlformats.org/drawingml/2006/main">
               <a:ext uri="{FF2B5EF4-FFF2-40B4-BE49-F238E27FC236}">
-                <a16:creationId xmlns:a16="http://schemas.microsoft.com/office/drawing/2014/main" id="{3CDCB948-03DF-44B8-9D1F-920799252D94}"/>
+                <a16:creationId xmlns:a16="http://schemas.microsoft.com/office/drawing/2014/main" id="{9AEE6A04-98CB-4CC1-B0D6-9F3F724F45F5}"/>
               </a:ext>
             </a:extLst>
           </p:cNvPr>
@@ -2791,7 +2791,7 @@
           <p:cNvPr id="2" name="">
             <a:extLst xmlns:a="http://schemas.openxmlformats.org/drawingml/2006/main">
               <a:ext uri="{FF2B5EF4-FFF2-40B4-BE49-F238E27FC236}">
-                <a16:creationId xmlns:a16="http://schemas.microsoft.com/office/drawing/2014/main" id="{27C2D3C7-90E8-49F4-B587-56A866EDAFD6}"/>
+                <a16:creationId xmlns:a16="http://schemas.microsoft.com/office/drawing/2014/main" id="{20560128-69C8-4995-B833-C68C47544792}"/>
               </a:ext>
             </a:extLst>
           </p:cNvPr>
@@ -2848,7 +2848,7 @@
           <p:cNvPr id="3" name="">
             <a:extLst xmlns:a="http://schemas.openxmlformats.org/drawingml/2006/main">
               <a:ext uri="{FF2B5EF4-FFF2-40B4-BE49-F238E27FC236}">
-                <a16:creationId xmlns:a16="http://schemas.microsoft.com/office/drawing/2014/main" id="{5BD79CC8-9DC8-48A5-BB3B-97D6729B29E7}"/>
+                <a16:creationId xmlns:a16="http://schemas.microsoft.com/office/drawing/2014/main" id="{C567F285-CB71-4D59-BC8E-DA6177C3032E}"/>
               </a:ext>
             </a:extLst>
           </p:cNvPr>
@@ -2905,7 +2905,7 @@
           <p:cNvPr id="4" name="">
             <a:extLst xmlns:a="http://schemas.openxmlformats.org/drawingml/2006/main">
               <a:ext uri="{FF2B5EF4-FFF2-40B4-BE49-F238E27FC236}">
-                <a16:creationId xmlns:a16="http://schemas.microsoft.com/office/drawing/2014/main" id="{69C1F1CF-AA11-49C4-8DA5-AE6B2CDAC9F9}"/>
+                <a16:creationId xmlns:a16="http://schemas.microsoft.com/office/drawing/2014/main" id="{D5221E81-D6EA-4559-BBD3-283C88A6AEB6}"/>
               </a:ext>
             </a:extLst>
           </p:cNvPr>
@@ -2952,7 +2952,7 @@
                 <a:ea typeface="Arial"/>
                 <a:cs typeface="Arial"/>
               </a:rPr>
-              <a:t>“My portfolio is mostly U.S. company stocks. I chose VXUS because it holds companies outside the U.S. I compared it with VTI, which would add more U.S. stocks I already have. I checked each fund’s holdings and costs. VXUS adds geographic spread, but I can still lose money if global stocks fall.”</a:t>
+              <a:t>“I own mostly U.S. stocks, so VXUS adds companies outside the U.S. That fills a geographic gap, though global stocks can still fall. I also want a bigger technology position, so XLK adds technology companies. It overlaps with stocks I own, and a tech downturn would hurt both.”</a:t>
             </a:r>
           </a:p>
         </p:txBody>
@@ -2960,7 +2960,7 @@
     </p:spTree>
     <p:extLst>
       <p:ext uri="{BB962C8B-B14F-4D97-AF65-F5344CB8AC3E}">
-        <p14:creationId xmlns:p14="http://schemas.microsoft.com/office/powerpoint/2010/main" val="1334399815"/>
+        <p14:creationId xmlns:p14="http://schemas.microsoft.com/office/powerpoint/2010/main" val="1799184110"/>
       </p:ext>
     </p:extLst>
   </p:cSld>
@@ -2991,7 +2991,7 @@
           <p:cNvPr id="8" name="">
             <a:extLst xmlns:a="http://schemas.openxmlformats.org/drawingml/2006/main">
               <a:ext uri="{FF2B5EF4-FFF2-40B4-BE49-F238E27FC236}">
-                <a16:creationId xmlns:a16="http://schemas.microsoft.com/office/drawing/2014/main" id="{BA8648AA-4B1F-49AF-A643-3E7544C14426}"/>
+                <a16:creationId xmlns:a16="http://schemas.microsoft.com/office/drawing/2014/main" id="{4E8AECB4-5771-460B-AD14-142A91FE81CF}"/>
               </a:ext>
             </a:extLst>
           </p:cNvPr>
@@ -3048,7 +3048,7 @@
           <p:cNvPr id="2" name="">
             <a:extLst xmlns:a="http://schemas.openxmlformats.org/drawingml/2006/main">
               <a:ext uri="{FF2B5EF4-FFF2-40B4-BE49-F238E27FC236}">
-                <a16:creationId xmlns:a16="http://schemas.microsoft.com/office/drawing/2014/main" id="{69742FA8-40EA-44A1-92FF-9DCE4C1B2D0D}"/>
+                <a16:creationId xmlns:a16="http://schemas.microsoft.com/office/drawing/2014/main" id="{F3F60BBD-4631-412B-981D-D016E14A1BBD}"/>
               </a:ext>
             </a:extLst>
           </p:cNvPr>
@@ -3105,7 +3105,7 @@
           <p:cNvPr id="3" name="">
             <a:extLst xmlns:a="http://schemas.openxmlformats.org/drawingml/2006/main">
               <a:ext uri="{FF2B5EF4-FFF2-40B4-BE49-F238E27FC236}">
-                <a16:creationId xmlns:a16="http://schemas.microsoft.com/office/drawing/2014/main" id="{A2346768-F2C5-44E4-AE32-F10C375635AB}"/>
+                <a16:creationId xmlns:a16="http://schemas.microsoft.com/office/drawing/2014/main" id="{BF518746-092E-4DA5-8E36-E6C8EAC02DE8}"/>
               </a:ext>
             </a:extLst>
           </p:cNvPr>
@@ -3162,7 +3162,7 @@
           <p:cNvPr id="4" name="">
             <a:extLst xmlns:a="http://schemas.openxmlformats.org/drawingml/2006/main">
               <a:ext uri="{FF2B5EF4-FFF2-40B4-BE49-F238E27FC236}">
-                <a16:creationId xmlns:a16="http://schemas.microsoft.com/office/drawing/2014/main" id="{C57C0F29-CE68-4410-9171-C50C02377F72}"/>
+                <a16:creationId xmlns:a16="http://schemas.microsoft.com/office/drawing/2014/main" id="{94FC5986-78F1-4794-9E3D-E54541B24584}"/>
               </a:ext>
             </a:extLst>
           </p:cNvPr>
@@ -3209,7 +3209,7 @@
                 <a:ea typeface="Arial"/>
                 <a:cs typeface="Arial"/>
               </a:rPr>
-              <a:t>Which risk in your portfolio are you trying to change?</a:t>
+              <a:t>Where do you have little or no exposure?</a:t>
             </a:r>
           </a:p>
         </p:txBody>
@@ -3219,7 +3219,7 @@
           <p:cNvPr id="5" name="">
             <a:extLst xmlns:a="http://schemas.openxmlformats.org/drawingml/2006/main">
               <a:ext uri="{FF2B5EF4-FFF2-40B4-BE49-F238E27FC236}">
-                <a16:creationId xmlns:a16="http://schemas.microsoft.com/office/drawing/2014/main" id="{02551EFB-6C6A-4528-8089-994A02D9EBF1}"/>
+                <a16:creationId xmlns:a16="http://schemas.microsoft.com/office/drawing/2014/main" id="{5AF01A84-4A98-4267-939C-656B5F2959BE}"/>
               </a:ext>
             </a:extLst>
           </p:cNvPr>
@@ -3266,7 +3266,7 @@
                 <a:ea typeface="Arial"/>
                 <a:cs typeface="Arial"/>
               </a:rPr>
-              <a:t>Which two ETFs will you compare?</a:t>
+              <a:t>Which different area do you want to bet bigger on?</a:t>
             </a:r>
           </a:p>
         </p:txBody>
@@ -3276,7 +3276,7 @@
           <p:cNvPr id="6" name="">
             <a:extLst xmlns:a="http://schemas.openxmlformats.org/drawingml/2006/main">
               <a:ext uri="{FF2B5EF4-FFF2-40B4-BE49-F238E27FC236}">
-                <a16:creationId xmlns:a16="http://schemas.microsoft.com/office/drawing/2014/main" id="{9465D5D5-094F-4A35-A0E8-64EFCAE93036}"/>
+                <a16:creationId xmlns:a16="http://schemas.microsoft.com/office/drawing/2014/main" id="{A8B42FAD-06EA-42BC-B089-A2E617B60CDE}"/>
               </a:ext>
             </a:extLst>
           </p:cNvPr>
@@ -3323,7 +3323,7 @@
                 <a:ea typeface="Arial"/>
                 <a:cs typeface="Arial"/>
               </a:rPr>
-              <a:t>What would make you reject an ETF, even if its name sounds right?</a:t>
+              <a:t>Which two ETFs fit those goals, and what risks remain?</a:t>
             </a:r>
           </a:p>
         </p:txBody>
@@ -3333,7 +3333,7 @@
           <p:cNvPr id="7" name="">
             <a:extLst xmlns:a="http://schemas.openxmlformats.org/drawingml/2006/main">
               <a:ext uri="{FF2B5EF4-FFF2-40B4-BE49-F238E27FC236}">
-                <a16:creationId xmlns:a16="http://schemas.microsoft.com/office/drawing/2014/main" id="{D8C9402E-9830-4A81-A246-5B0B229EA744}"/>
+                <a16:creationId xmlns:a16="http://schemas.microsoft.com/office/drawing/2014/main" id="{9AE547A6-41C1-45F5-9B2E-281E030350CC}"/>
               </a:ext>
             </a:extLst>
           </p:cNvPr>
@@ -3380,7 +3380,7 @@
                 <a:ea typeface="Arial"/>
                 <a:cs typeface="Arial"/>
               </a:rPr>
-              <a:t>Next: open Investing, research two funds, then begin your Module 3 draft.</a:t>
+              <a:t>Next: open Investing, research both funds, then begin Module 3.</a:t>
             </a:r>
           </a:p>
         </p:txBody>
@@ -3388,7 +3388,7 @@
     </p:spTree>
     <p:extLst>
       <p:ext uri="{BB962C8B-B14F-4D97-AF65-F5344CB8AC3E}">
-        <p14:creationId xmlns:p14="http://schemas.microsoft.com/office/powerpoint/2010/main" val="33982885"/>
+        <p14:creationId xmlns:p14="http://schemas.microsoft.com/office/powerpoint/2010/main" val="2013665426"/>
       </p:ext>
     </p:extLst>
   </p:cSld>
@@ -3419,7 +3419,7 @@
           <p:cNvPr id="7" name="">
             <a:extLst xmlns:a="http://schemas.openxmlformats.org/drawingml/2006/main">
               <a:ext uri="{FF2B5EF4-FFF2-40B4-BE49-F238E27FC236}">
-                <a16:creationId xmlns:a16="http://schemas.microsoft.com/office/drawing/2014/main" id="{606B4F3F-826A-4EC1-BF4E-DC71881D87FD}"/>
+                <a16:creationId xmlns:a16="http://schemas.microsoft.com/office/drawing/2014/main" id="{E3365FAC-EF22-4AA5-BFB7-71A0C0E686AA}"/>
               </a:ext>
             </a:extLst>
           </p:cNvPr>
@@ -3476,7 +3476,7 @@
           <p:cNvPr id="2" name="">
             <a:extLst xmlns:a="http://schemas.openxmlformats.org/drawingml/2006/main">
               <a:ext uri="{FF2B5EF4-FFF2-40B4-BE49-F238E27FC236}">
-                <a16:creationId xmlns:a16="http://schemas.microsoft.com/office/drawing/2014/main" id="{97C45CBA-2516-472D-B00B-E522C841CF4D}"/>
+                <a16:creationId xmlns:a16="http://schemas.microsoft.com/office/drawing/2014/main" id="{74FE76A5-71D3-42C6-A20D-8E6014C45A03}"/>
               </a:ext>
             </a:extLst>
           </p:cNvPr>
@@ -3533,7 +3533,7 @@
           <p:cNvPr id="3" name="">
             <a:extLst xmlns:a="http://schemas.openxmlformats.org/drawingml/2006/main">
               <a:ext uri="{FF2B5EF4-FFF2-40B4-BE49-F238E27FC236}">
-                <a16:creationId xmlns:a16="http://schemas.microsoft.com/office/drawing/2014/main" id="{AD9ADE17-4EA5-4536-9992-34C86807B03E}"/>
+                <a16:creationId xmlns:a16="http://schemas.microsoft.com/office/drawing/2014/main" id="{8FB6FA2E-065A-425B-ABC9-607684AAE7DC}"/>
               </a:ext>
             </a:extLst>
           </p:cNvPr>
@@ -3590,7 +3590,7 @@
           <p:cNvPr id="4" name="">
             <a:extLst xmlns:a="http://schemas.openxmlformats.org/drawingml/2006/main">
               <a:ext uri="{FF2B5EF4-FFF2-40B4-BE49-F238E27FC236}">
-                <a16:creationId xmlns:a16="http://schemas.microsoft.com/office/drawing/2014/main" id="{2B694F19-DC55-499D-A4C8-68AB163195FF}"/>
+                <a16:creationId xmlns:a16="http://schemas.microsoft.com/office/drawing/2014/main" id="{7D6BAE29-7D63-4782-A255-7F9228E65AB2}"/>
               </a:ext>
             </a:extLst>
           </p:cNvPr>
@@ -3647,7 +3647,7 @@
           <p:cNvPr id="5" name="">
             <a:extLst xmlns:a="http://schemas.openxmlformats.org/drawingml/2006/main">
               <a:ext uri="{FF2B5EF4-FFF2-40B4-BE49-F238E27FC236}">
-                <a16:creationId xmlns:a16="http://schemas.microsoft.com/office/drawing/2014/main" id="{1C8B8E7B-4389-441E-B756-186519E5A75C}"/>
+                <a16:creationId xmlns:a16="http://schemas.microsoft.com/office/drawing/2014/main" id="{EE22F770-8B4B-4C93-8089-D931D0C718AA}"/>
               </a:ext>
             </a:extLst>
           </p:cNvPr>
@@ -3704,7 +3704,7 @@
           <p:cNvPr id="6" name="">
             <a:extLst xmlns:a="http://schemas.openxmlformats.org/drawingml/2006/main">
               <a:ext uri="{FF2B5EF4-FFF2-40B4-BE49-F238E27FC236}">
-                <a16:creationId xmlns:a16="http://schemas.microsoft.com/office/drawing/2014/main" id="{33BEF1FA-D298-44A3-BB8D-4102F8792174}"/>
+                <a16:creationId xmlns:a16="http://schemas.microsoft.com/office/drawing/2014/main" id="{DFCD0BC0-BACD-47A9-ADC0-721EAD9632CD}"/>
               </a:ext>
             </a:extLst>
           </p:cNvPr>
@@ -3759,7 +3759,7 @@
     </p:spTree>
     <p:extLst>
       <p:ext uri="{BB962C8B-B14F-4D97-AF65-F5344CB8AC3E}">
-        <p14:creationId xmlns:p14="http://schemas.microsoft.com/office/powerpoint/2010/main" val="1610357757"/>
+        <p14:creationId xmlns:p14="http://schemas.microsoft.com/office/powerpoint/2010/main" val="1301499005"/>
       </p:ext>
     </p:extLst>
   </p:cSld>
@@ -3790,7 +3790,7 @@
           <p:cNvPr id="9" name="">
             <a:extLst xmlns:a="http://schemas.openxmlformats.org/drawingml/2006/main">
               <a:ext uri="{FF2B5EF4-FFF2-40B4-BE49-F238E27FC236}">
-                <a16:creationId xmlns:a16="http://schemas.microsoft.com/office/drawing/2014/main" id="{E16DA133-9EE8-4E9A-ACD3-619C1C072961}"/>
+                <a16:creationId xmlns:a16="http://schemas.microsoft.com/office/drawing/2014/main" id="{E5F96D3A-CAE3-4073-BBBC-90D6CC34DA8C}"/>
               </a:ext>
             </a:extLst>
           </p:cNvPr>
@@ -3847,7 +3847,7 @@
           <p:cNvPr id="2" name="">
             <a:extLst xmlns:a="http://schemas.openxmlformats.org/drawingml/2006/main">
               <a:ext uri="{FF2B5EF4-FFF2-40B4-BE49-F238E27FC236}">
-                <a16:creationId xmlns:a16="http://schemas.microsoft.com/office/drawing/2014/main" id="{CEB2B7F9-45D4-4331-8C40-629EDE0D61BF}"/>
+                <a16:creationId xmlns:a16="http://schemas.microsoft.com/office/drawing/2014/main" id="{F21AB68F-AABD-476B-B31B-08A1D8A1E404}"/>
               </a:ext>
             </a:extLst>
           </p:cNvPr>
@@ -3904,7 +3904,7 @@
           <p:cNvPr id="3" name="">
             <a:extLst xmlns:a="http://schemas.openxmlformats.org/drawingml/2006/main">
               <a:ext uri="{FF2B5EF4-FFF2-40B4-BE49-F238E27FC236}">
-                <a16:creationId xmlns:a16="http://schemas.microsoft.com/office/drawing/2014/main" id="{77F9A663-0E8E-42C7-AA14-469FFDE47DA6}"/>
+                <a16:creationId xmlns:a16="http://schemas.microsoft.com/office/drawing/2014/main" id="{F3E3ED20-4B6F-45C1-8144-62CC15380597}"/>
               </a:ext>
             </a:extLst>
           </p:cNvPr>
@@ -3961,7 +3961,7 @@
           <p:cNvPr id="4" name="">
             <a:extLst xmlns:a="http://schemas.openxmlformats.org/drawingml/2006/main">
               <a:ext uri="{FF2B5EF4-FFF2-40B4-BE49-F238E27FC236}">
-                <a16:creationId xmlns:a16="http://schemas.microsoft.com/office/drawing/2014/main" id="{90C5025B-554C-4348-8449-6C16A8065B05}"/>
+                <a16:creationId xmlns:a16="http://schemas.microsoft.com/office/drawing/2014/main" id="{4D5F2088-7672-4B0A-9693-DC1A1AD806D5}"/>
               </a:ext>
             </a:extLst>
           </p:cNvPr>
@@ -4018,7 +4018,7 @@
           <p:cNvPr id="5" name="">
             <a:extLst xmlns:a="http://schemas.openxmlformats.org/drawingml/2006/main">
               <a:ext uri="{FF2B5EF4-FFF2-40B4-BE49-F238E27FC236}">
-                <a16:creationId xmlns:a16="http://schemas.microsoft.com/office/drawing/2014/main" id="{04EDFE0E-5A03-4754-84C6-664E5EC2528B}"/>
+                <a16:creationId xmlns:a16="http://schemas.microsoft.com/office/drawing/2014/main" id="{C85492DE-F2DE-48A7-9774-6B836B5C11F3}"/>
               </a:ext>
             </a:extLst>
           </p:cNvPr>
@@ -4075,7 +4075,7 @@
           <p:cNvPr id="6" name="">
             <a:extLst xmlns:a="http://schemas.openxmlformats.org/drawingml/2006/main">
               <a:ext uri="{FF2B5EF4-FFF2-40B4-BE49-F238E27FC236}">
-                <a16:creationId xmlns:a16="http://schemas.microsoft.com/office/drawing/2014/main" id="{F201F98A-9437-419C-8CCC-6DB7CA67324F}"/>
+                <a16:creationId xmlns:a16="http://schemas.microsoft.com/office/drawing/2014/main" id="{B766CDC9-2D12-45DB-8F9E-767B7B142010}"/>
               </a:ext>
             </a:extLst>
           </p:cNvPr>
@@ -4132,7 +4132,7 @@
           <p:cNvPr id="7" name="">
             <a:extLst xmlns:a="http://schemas.openxmlformats.org/drawingml/2006/main">
               <a:ext uri="{FF2B5EF4-FFF2-40B4-BE49-F238E27FC236}">
-                <a16:creationId xmlns:a16="http://schemas.microsoft.com/office/drawing/2014/main" id="{B0111D62-8A53-4FA8-88BA-6691360EDD2D}"/>
+                <a16:creationId xmlns:a16="http://schemas.microsoft.com/office/drawing/2014/main" id="{3515649F-E184-438C-934F-12E5AC2AB676}"/>
               </a:ext>
             </a:extLst>
           </p:cNvPr>
@@ -4189,7 +4189,7 @@
           <p:cNvPr id="8" name="">
             <a:extLst xmlns:a="http://schemas.openxmlformats.org/drawingml/2006/main">
               <a:ext uri="{FF2B5EF4-FFF2-40B4-BE49-F238E27FC236}">
-                <a16:creationId xmlns:a16="http://schemas.microsoft.com/office/drawing/2014/main" id="{15CC0673-B143-45A9-B070-FFF4FA663AC7}"/>
+                <a16:creationId xmlns:a16="http://schemas.microsoft.com/office/drawing/2014/main" id="{5993D9B5-D758-4656-9DF3-76C939E859AD}"/>
               </a:ext>
             </a:extLst>
           </p:cNvPr>
@@ -4244,7 +4244,7 @@
     </p:spTree>
     <p:extLst>
       <p:ext uri="{BB962C8B-B14F-4D97-AF65-F5344CB8AC3E}">
-        <p14:creationId xmlns:p14="http://schemas.microsoft.com/office/powerpoint/2010/main" val="720734449"/>
+        <p14:creationId xmlns:p14="http://schemas.microsoft.com/office/powerpoint/2010/main" val="1411391271"/>
       </p:ext>
     </p:extLst>
   </p:cSld>
@@ -4275,7 +4275,7 @@
           <p:cNvPr id="9" name="">
             <a:extLst xmlns:a="http://schemas.openxmlformats.org/drawingml/2006/main">
               <a:ext uri="{FF2B5EF4-FFF2-40B4-BE49-F238E27FC236}">
-                <a16:creationId xmlns:a16="http://schemas.microsoft.com/office/drawing/2014/main" id="{F37D4BC6-FE30-4757-BB4F-7FA720C92C39}"/>
+                <a16:creationId xmlns:a16="http://schemas.microsoft.com/office/drawing/2014/main" id="{5D9E71C1-27B7-4E6F-9A95-A0E593683E90}"/>
               </a:ext>
             </a:extLst>
           </p:cNvPr>
@@ -4332,7 +4332,7 @@
           <p:cNvPr id="2" name="">
             <a:extLst xmlns:a="http://schemas.openxmlformats.org/drawingml/2006/main">
               <a:ext uri="{FF2B5EF4-FFF2-40B4-BE49-F238E27FC236}">
-                <a16:creationId xmlns:a16="http://schemas.microsoft.com/office/drawing/2014/main" id="{7B550425-DCBB-48BE-8D01-BA2B089F7CB7}"/>
+                <a16:creationId xmlns:a16="http://schemas.microsoft.com/office/drawing/2014/main" id="{940DAAB8-03CE-4141-9111-87F02A8792EC}"/>
               </a:ext>
             </a:extLst>
           </p:cNvPr>
@@ -4389,7 +4389,7 @@
           <p:cNvPr id="3" name="">
             <a:extLst xmlns:a="http://schemas.openxmlformats.org/drawingml/2006/main">
               <a:ext uri="{FF2B5EF4-FFF2-40B4-BE49-F238E27FC236}">
-                <a16:creationId xmlns:a16="http://schemas.microsoft.com/office/drawing/2014/main" id="{8AB0CE40-6B65-429A-9F71-949CF60D40B7}"/>
+                <a16:creationId xmlns:a16="http://schemas.microsoft.com/office/drawing/2014/main" id="{3F35469D-C745-4B52-BF25-B0BDCD588906}"/>
               </a:ext>
             </a:extLst>
           </p:cNvPr>
@@ -4446,7 +4446,7 @@
           <p:cNvPr id="4" name="">
             <a:extLst xmlns:a="http://schemas.openxmlformats.org/drawingml/2006/main">
               <a:ext uri="{FF2B5EF4-FFF2-40B4-BE49-F238E27FC236}">
-                <a16:creationId xmlns:a16="http://schemas.microsoft.com/office/drawing/2014/main" id="{4967F643-185B-441F-BCD4-E3CE6A40C8DA}"/>
+                <a16:creationId xmlns:a16="http://schemas.microsoft.com/office/drawing/2014/main" id="{8A4C3045-49E0-4905-9CDF-2A89C2A2C87D}"/>
               </a:ext>
             </a:extLst>
           </p:cNvPr>
@@ -4503,7 +4503,7 @@
           <p:cNvPr id="5" name="">
             <a:extLst xmlns:a="http://schemas.openxmlformats.org/drawingml/2006/main">
               <a:ext uri="{FF2B5EF4-FFF2-40B4-BE49-F238E27FC236}">
-                <a16:creationId xmlns:a16="http://schemas.microsoft.com/office/drawing/2014/main" id="{96756E61-48CA-40D7-8332-BCA0C51E96AE}"/>
+                <a16:creationId xmlns:a16="http://schemas.microsoft.com/office/drawing/2014/main" id="{BAE33145-F641-466D-9AFE-053A85A1521A}"/>
               </a:ext>
             </a:extLst>
           </p:cNvPr>
@@ -4560,7 +4560,7 @@
           <p:cNvPr id="6" name="">
             <a:extLst xmlns:a="http://schemas.openxmlformats.org/drawingml/2006/main">
               <a:ext uri="{FF2B5EF4-FFF2-40B4-BE49-F238E27FC236}">
-                <a16:creationId xmlns:a16="http://schemas.microsoft.com/office/drawing/2014/main" id="{93CF5C9E-CC01-4C2C-AA1F-301BDB257F5F}"/>
+                <a16:creationId xmlns:a16="http://schemas.microsoft.com/office/drawing/2014/main" id="{7917A0E9-4A6E-4789-9E9D-1F59D09903DE}"/>
               </a:ext>
             </a:extLst>
           </p:cNvPr>
@@ -4617,7 +4617,7 @@
           <p:cNvPr id="7" name="">
             <a:extLst xmlns:a="http://schemas.openxmlformats.org/drawingml/2006/main">
               <a:ext uri="{FF2B5EF4-FFF2-40B4-BE49-F238E27FC236}">
-                <a16:creationId xmlns:a16="http://schemas.microsoft.com/office/drawing/2014/main" id="{6A1763E6-6E84-4B1C-882D-79015D1314CC}"/>
+                <a16:creationId xmlns:a16="http://schemas.microsoft.com/office/drawing/2014/main" id="{A0BBF089-3372-4B3F-813F-23864DFB9463}"/>
               </a:ext>
             </a:extLst>
           </p:cNvPr>
@@ -4674,7 +4674,7 @@
           <p:cNvPr id="8" name="">
             <a:extLst xmlns:a="http://schemas.openxmlformats.org/drawingml/2006/main">
               <a:ext uri="{FF2B5EF4-FFF2-40B4-BE49-F238E27FC236}">
-                <a16:creationId xmlns:a16="http://schemas.microsoft.com/office/drawing/2014/main" id="{8900C267-2DAB-4195-9BB2-419556983BC8}"/>
+                <a16:creationId xmlns:a16="http://schemas.microsoft.com/office/drawing/2014/main" id="{2CC8251A-EDD5-4B6F-A3FB-837F566088A9}"/>
               </a:ext>
             </a:extLst>
           </p:cNvPr>
@@ -4729,7 +4729,7 @@
     </p:spTree>
     <p:extLst>
       <p:ext uri="{BB962C8B-B14F-4D97-AF65-F5344CB8AC3E}">
-        <p14:creationId xmlns:p14="http://schemas.microsoft.com/office/powerpoint/2010/main" val="216281331"/>
+        <p14:creationId xmlns:p14="http://schemas.microsoft.com/office/powerpoint/2010/main" val="1538572675"/>
       </p:ext>
     </p:extLst>
   </p:cSld>
@@ -4760,7 +4760,7 @@
           <p:cNvPr id="9" name="">
             <a:extLst xmlns:a="http://schemas.openxmlformats.org/drawingml/2006/main">
               <a:ext uri="{FF2B5EF4-FFF2-40B4-BE49-F238E27FC236}">
-                <a16:creationId xmlns:a16="http://schemas.microsoft.com/office/drawing/2014/main" id="{371C7F9F-37EC-414D-A58C-A506C3A0344A}"/>
+                <a16:creationId xmlns:a16="http://schemas.microsoft.com/office/drawing/2014/main" id="{E4C9D85F-DC60-4896-8550-141BE46FACC9}"/>
               </a:ext>
             </a:extLst>
           </p:cNvPr>
@@ -4817,7 +4817,7 @@
           <p:cNvPr id="2" name="">
             <a:extLst xmlns:a="http://schemas.openxmlformats.org/drawingml/2006/main">
               <a:ext uri="{FF2B5EF4-FFF2-40B4-BE49-F238E27FC236}">
-                <a16:creationId xmlns:a16="http://schemas.microsoft.com/office/drawing/2014/main" id="{E77D3F4B-3DD1-4D72-A509-E7E1E2A270F2}"/>
+                <a16:creationId xmlns:a16="http://schemas.microsoft.com/office/drawing/2014/main" id="{F7761DFB-3D69-4E2E-AF51-C16A8DC13119}"/>
               </a:ext>
             </a:extLst>
           </p:cNvPr>
@@ -4874,7 +4874,7 @@
           <p:cNvPr id="3" name="">
             <a:extLst xmlns:a="http://schemas.openxmlformats.org/drawingml/2006/main">
               <a:ext uri="{FF2B5EF4-FFF2-40B4-BE49-F238E27FC236}">
-                <a16:creationId xmlns:a16="http://schemas.microsoft.com/office/drawing/2014/main" id="{486B99B3-60E9-4207-8307-DD9DED00ED8D}"/>
+                <a16:creationId xmlns:a16="http://schemas.microsoft.com/office/drawing/2014/main" id="{51DB7248-F5F4-4803-901F-FB241BDB242E}"/>
               </a:ext>
             </a:extLst>
           </p:cNvPr>
@@ -4931,7 +4931,7 @@
           <p:cNvPr id="4" name="">
             <a:extLst xmlns:a="http://schemas.openxmlformats.org/drawingml/2006/main">
               <a:ext uri="{FF2B5EF4-FFF2-40B4-BE49-F238E27FC236}">
-                <a16:creationId xmlns:a16="http://schemas.microsoft.com/office/drawing/2014/main" id="{F44FC570-35EE-4FD0-B45F-E17A42344255}"/>
+                <a16:creationId xmlns:a16="http://schemas.microsoft.com/office/drawing/2014/main" id="{0E24EF34-1F25-40AB-A763-FE3B64DB9409}"/>
               </a:ext>
             </a:extLst>
           </p:cNvPr>
@@ -4988,7 +4988,7 @@
           <p:cNvPr id="5" name="">
             <a:extLst xmlns:a="http://schemas.openxmlformats.org/drawingml/2006/main">
               <a:ext uri="{FF2B5EF4-FFF2-40B4-BE49-F238E27FC236}">
-                <a16:creationId xmlns:a16="http://schemas.microsoft.com/office/drawing/2014/main" id="{416D9622-8341-494A-8C3B-106D12178781}"/>
+                <a16:creationId xmlns:a16="http://schemas.microsoft.com/office/drawing/2014/main" id="{A030C4A0-0D39-44D4-9150-BC8EDAB0F0F0}"/>
               </a:ext>
             </a:extLst>
           </p:cNvPr>
@@ -5045,7 +5045,7 @@
           <p:cNvPr id="6" name="">
             <a:extLst xmlns:a="http://schemas.openxmlformats.org/drawingml/2006/main">
               <a:ext uri="{FF2B5EF4-FFF2-40B4-BE49-F238E27FC236}">
-                <a16:creationId xmlns:a16="http://schemas.microsoft.com/office/drawing/2014/main" id="{10B39352-8D40-4E33-A77F-D662FCC4B826}"/>
+                <a16:creationId xmlns:a16="http://schemas.microsoft.com/office/drawing/2014/main" id="{DA3C99A8-16AB-48CC-AC74-F87D9834ED5D}"/>
               </a:ext>
             </a:extLst>
           </p:cNvPr>
@@ -5102,7 +5102,7 @@
           <p:cNvPr id="7" name="">
             <a:extLst xmlns:a="http://schemas.openxmlformats.org/drawingml/2006/main">
               <a:ext uri="{FF2B5EF4-FFF2-40B4-BE49-F238E27FC236}">
-                <a16:creationId xmlns:a16="http://schemas.microsoft.com/office/drawing/2014/main" id="{5F7F5E26-1B73-4336-A5AD-35048522EFB9}"/>
+                <a16:creationId xmlns:a16="http://schemas.microsoft.com/office/drawing/2014/main" id="{39EE7076-F0AD-462B-8780-F72D6C552459}"/>
               </a:ext>
             </a:extLst>
           </p:cNvPr>
@@ -5159,7 +5159,7 @@
           <p:cNvPr id="8" name="">
             <a:extLst xmlns:a="http://schemas.openxmlformats.org/drawingml/2006/main">
               <a:ext uri="{FF2B5EF4-FFF2-40B4-BE49-F238E27FC236}">
-                <a16:creationId xmlns:a16="http://schemas.microsoft.com/office/drawing/2014/main" id="{665D299D-6992-4A78-8B51-DD8A3D2F6959}"/>
+                <a16:creationId xmlns:a16="http://schemas.microsoft.com/office/drawing/2014/main" id="{2311B750-B53E-46F3-8D74-3A5F80DC04E7}"/>
               </a:ext>
             </a:extLst>
           </p:cNvPr>
@@ -5214,7 +5214,7 @@
     </p:spTree>
     <p:extLst>
       <p:ext uri="{BB962C8B-B14F-4D97-AF65-F5344CB8AC3E}">
-        <p14:creationId xmlns:p14="http://schemas.microsoft.com/office/powerpoint/2010/main" val="527990130"/>
+        <p14:creationId xmlns:p14="http://schemas.microsoft.com/office/powerpoint/2010/main" val="2079609831"/>
       </p:ext>
     </p:extLst>
   </p:cSld>
@@ -5245,7 +5245,7 @@
           <p:cNvPr id="9" name="">
             <a:extLst xmlns:a="http://schemas.openxmlformats.org/drawingml/2006/main">
               <a:ext uri="{FF2B5EF4-FFF2-40B4-BE49-F238E27FC236}">
-                <a16:creationId xmlns:a16="http://schemas.microsoft.com/office/drawing/2014/main" id="{60FEA383-7CED-41AF-B0E4-6CE975828210}"/>
+                <a16:creationId xmlns:a16="http://schemas.microsoft.com/office/drawing/2014/main" id="{EB3FD4DD-99A5-4A73-BE76-F25787162270}"/>
               </a:ext>
             </a:extLst>
           </p:cNvPr>
@@ -5302,7 +5302,7 @@
           <p:cNvPr id="2" name="">
             <a:extLst xmlns:a="http://schemas.openxmlformats.org/drawingml/2006/main">
               <a:ext uri="{FF2B5EF4-FFF2-40B4-BE49-F238E27FC236}">
-                <a16:creationId xmlns:a16="http://schemas.microsoft.com/office/drawing/2014/main" id="{96DB7AAB-CA36-4651-85B9-2EEA1996828E}"/>
+                <a16:creationId xmlns:a16="http://schemas.microsoft.com/office/drawing/2014/main" id="{A2F1411C-7F3B-4D1B-9157-6FA558EE6EB8}"/>
               </a:ext>
             </a:extLst>
           </p:cNvPr>
@@ -5359,7 +5359,7 @@
           <p:cNvPr id="3" name="">
             <a:extLst xmlns:a="http://schemas.openxmlformats.org/drawingml/2006/main">
               <a:ext uri="{FF2B5EF4-FFF2-40B4-BE49-F238E27FC236}">
-                <a16:creationId xmlns:a16="http://schemas.microsoft.com/office/drawing/2014/main" id="{21C038A9-1D8D-4246-9AB5-30ACAAEBBB61}"/>
+                <a16:creationId xmlns:a16="http://schemas.microsoft.com/office/drawing/2014/main" id="{C7E0B348-1673-48CE-BA9D-47AC216DC723}"/>
               </a:ext>
             </a:extLst>
           </p:cNvPr>
@@ -5416,7 +5416,7 @@
           <p:cNvPr id="4" name="">
             <a:extLst xmlns:a="http://schemas.openxmlformats.org/drawingml/2006/main">
               <a:ext uri="{FF2B5EF4-FFF2-40B4-BE49-F238E27FC236}">
-                <a16:creationId xmlns:a16="http://schemas.microsoft.com/office/drawing/2014/main" id="{3241C036-1CC2-4917-B359-8ED393952A84}"/>
+                <a16:creationId xmlns:a16="http://schemas.microsoft.com/office/drawing/2014/main" id="{117DBE64-F529-4FEE-B592-8BB73195BB52}"/>
               </a:ext>
             </a:extLst>
           </p:cNvPr>
@@ -5473,7 +5473,7 @@
           <p:cNvPr id="5" name="">
             <a:extLst xmlns:a="http://schemas.openxmlformats.org/drawingml/2006/main">
               <a:ext uri="{FF2B5EF4-FFF2-40B4-BE49-F238E27FC236}">
-                <a16:creationId xmlns:a16="http://schemas.microsoft.com/office/drawing/2014/main" id="{F9814781-206B-4D2E-A63B-224B82E75C73}"/>
+                <a16:creationId xmlns:a16="http://schemas.microsoft.com/office/drawing/2014/main" id="{3A87FDEF-D0CD-4A0D-AC8C-583D74F798A8}"/>
               </a:ext>
             </a:extLst>
           </p:cNvPr>
@@ -5530,7 +5530,7 @@
           <p:cNvPr id="6" name="">
             <a:extLst xmlns:a="http://schemas.openxmlformats.org/drawingml/2006/main">
               <a:ext uri="{FF2B5EF4-FFF2-40B4-BE49-F238E27FC236}">
-                <a16:creationId xmlns:a16="http://schemas.microsoft.com/office/drawing/2014/main" id="{5982B1D7-B0CD-4A48-AA6D-69108C715F06}"/>
+                <a16:creationId xmlns:a16="http://schemas.microsoft.com/office/drawing/2014/main" id="{800E3F21-F2A4-4B3D-8B2F-A9E8E746D8E2}"/>
               </a:ext>
             </a:extLst>
           </p:cNvPr>
@@ -5587,7 +5587,7 @@
           <p:cNvPr id="7" name="">
             <a:extLst xmlns:a="http://schemas.openxmlformats.org/drawingml/2006/main">
               <a:ext uri="{FF2B5EF4-FFF2-40B4-BE49-F238E27FC236}">
-                <a16:creationId xmlns:a16="http://schemas.microsoft.com/office/drawing/2014/main" id="{041637BA-1E4F-4C95-8D77-92786E57B2EE}"/>
+                <a16:creationId xmlns:a16="http://schemas.microsoft.com/office/drawing/2014/main" id="{0BFF791A-8671-403C-8EF7-B825A892A3D7}"/>
               </a:ext>
             </a:extLst>
           </p:cNvPr>
@@ -5644,7 +5644,7 @@
           <p:cNvPr id="8" name="">
             <a:extLst xmlns:a="http://schemas.openxmlformats.org/drawingml/2006/main">
               <a:ext uri="{FF2B5EF4-FFF2-40B4-BE49-F238E27FC236}">
-                <a16:creationId xmlns:a16="http://schemas.microsoft.com/office/drawing/2014/main" id="{C2E6A98E-8A46-46DD-80B2-8F81F0507C31}"/>
+                <a16:creationId xmlns:a16="http://schemas.microsoft.com/office/drawing/2014/main" id="{E5AAF4E8-3D46-48A3-89F3-560B8428DAD3}"/>
               </a:ext>
             </a:extLst>
           </p:cNvPr>
@@ -5699,7 +5699,7 @@
     </p:spTree>
     <p:extLst>
       <p:ext uri="{BB962C8B-B14F-4D97-AF65-F5344CB8AC3E}">
-        <p14:creationId xmlns:p14="http://schemas.microsoft.com/office/powerpoint/2010/main" val="2057541329"/>
+        <p14:creationId xmlns:p14="http://schemas.microsoft.com/office/powerpoint/2010/main" val="992520246"/>
       </p:ext>
     </p:extLst>
   </p:cSld>
@@ -5730,7 +5730,7 @@
           <p:cNvPr id="8" name="">
             <a:extLst xmlns:a="http://schemas.openxmlformats.org/drawingml/2006/main">
               <a:ext uri="{FF2B5EF4-FFF2-40B4-BE49-F238E27FC236}">
-                <a16:creationId xmlns:a16="http://schemas.microsoft.com/office/drawing/2014/main" id="{1328366E-F8DF-47E0-A7CF-B3824BB46305}"/>
+                <a16:creationId xmlns:a16="http://schemas.microsoft.com/office/drawing/2014/main" id="{35F11E95-83F4-4DDB-8508-A4BAC7F77F2E}"/>
               </a:ext>
             </a:extLst>
           </p:cNvPr>
@@ -5787,7 +5787,7 @@
           <p:cNvPr id="2" name="">
             <a:extLst xmlns:a="http://schemas.openxmlformats.org/drawingml/2006/main">
               <a:ext uri="{FF2B5EF4-FFF2-40B4-BE49-F238E27FC236}">
-                <a16:creationId xmlns:a16="http://schemas.microsoft.com/office/drawing/2014/main" id="{0526294E-77F2-4C87-8E34-324D07831ED7}"/>
+                <a16:creationId xmlns:a16="http://schemas.microsoft.com/office/drawing/2014/main" id="{7CD2DFAE-D1B4-4B40-9F6B-48A016048A37}"/>
               </a:ext>
             </a:extLst>
           </p:cNvPr>
@@ -5844,7 +5844,7 @@
           <p:cNvPr id="3" name="">
             <a:extLst xmlns:a="http://schemas.openxmlformats.org/drawingml/2006/main">
               <a:ext uri="{FF2B5EF4-FFF2-40B4-BE49-F238E27FC236}">
-                <a16:creationId xmlns:a16="http://schemas.microsoft.com/office/drawing/2014/main" id="{C73D0935-7FAC-4908-BDD8-61425058D054}"/>
+                <a16:creationId xmlns:a16="http://schemas.microsoft.com/office/drawing/2014/main" id="{654821FD-A095-4184-8E24-E9264FABC162}"/>
               </a:ext>
             </a:extLst>
           </p:cNvPr>
@@ -5901,7 +5901,7 @@
           <p:cNvPr id="4" name="">
             <a:extLst xmlns:a="http://schemas.openxmlformats.org/drawingml/2006/main">
               <a:ext uri="{FF2B5EF4-FFF2-40B4-BE49-F238E27FC236}">
-                <a16:creationId xmlns:a16="http://schemas.microsoft.com/office/drawing/2014/main" id="{30521CAD-5C56-4B87-BCF9-59996F258B7E}"/>
+                <a16:creationId xmlns:a16="http://schemas.microsoft.com/office/drawing/2014/main" id="{1C677288-092C-4AC7-B26D-2DA3274FD6FD}"/>
               </a:ext>
             </a:extLst>
           </p:cNvPr>
@@ -5958,7 +5958,7 @@
           <p:cNvPr id="5" name="">
             <a:extLst xmlns:a="http://schemas.openxmlformats.org/drawingml/2006/main">
               <a:ext uri="{FF2B5EF4-FFF2-40B4-BE49-F238E27FC236}">
-                <a16:creationId xmlns:a16="http://schemas.microsoft.com/office/drawing/2014/main" id="{EA45623E-7B0B-4E9A-972A-1C9DA9EE2D14}"/>
+                <a16:creationId xmlns:a16="http://schemas.microsoft.com/office/drawing/2014/main" id="{ACD81BE9-279A-4ADA-96A2-0649610CF945}"/>
               </a:ext>
             </a:extLst>
           </p:cNvPr>
@@ -6015,7 +6015,7 @@
           <p:cNvPr id="6" name="">
             <a:extLst xmlns:a="http://schemas.openxmlformats.org/drawingml/2006/main">
               <a:ext uri="{FF2B5EF4-FFF2-40B4-BE49-F238E27FC236}">
-                <a16:creationId xmlns:a16="http://schemas.microsoft.com/office/drawing/2014/main" id="{0A29D0B0-6AD0-43B4-9424-7D6C9C413F53}"/>
+                <a16:creationId xmlns:a16="http://schemas.microsoft.com/office/drawing/2014/main" id="{EF99E058-3E5C-4BFE-9F45-F4A5E4F8672D}"/>
               </a:ext>
             </a:extLst>
           </p:cNvPr>
@@ -6072,7 +6072,7 @@
           <p:cNvPr id="7" name="">
             <a:extLst xmlns:a="http://schemas.openxmlformats.org/drawingml/2006/main">
               <a:ext uri="{FF2B5EF4-FFF2-40B4-BE49-F238E27FC236}">
-                <a16:creationId xmlns:a16="http://schemas.microsoft.com/office/drawing/2014/main" id="{391C5C6D-5452-497C-82AC-BD5FA19FE05A}"/>
+                <a16:creationId xmlns:a16="http://schemas.microsoft.com/office/drawing/2014/main" id="{10D70C31-B5BB-4FF3-9832-D3AE6759E277}"/>
               </a:ext>
             </a:extLst>
           </p:cNvPr>
@@ -6127,7 +6127,7 @@
     </p:spTree>
     <p:extLst>
       <p:ext uri="{BB962C8B-B14F-4D97-AF65-F5344CB8AC3E}">
-        <p14:creationId xmlns:p14="http://schemas.microsoft.com/office/powerpoint/2010/main" val="756145041"/>
+        <p14:creationId xmlns:p14="http://schemas.microsoft.com/office/powerpoint/2010/main" val="878617064"/>
       </p:ext>
     </p:extLst>
   </p:cSld>
@@ -6158,7 +6158,7 @@
           <p:cNvPr id="7" name="">
             <a:extLst xmlns:a="http://schemas.openxmlformats.org/drawingml/2006/main">
               <a:ext uri="{FF2B5EF4-FFF2-40B4-BE49-F238E27FC236}">
-                <a16:creationId xmlns:a16="http://schemas.microsoft.com/office/drawing/2014/main" id="{64AE453E-FD53-4807-8323-EA9DFBC20D1E}"/>
+                <a16:creationId xmlns:a16="http://schemas.microsoft.com/office/drawing/2014/main" id="{FB31EEB6-7184-4584-8EEF-1C4BC991C244}"/>
               </a:ext>
             </a:extLst>
           </p:cNvPr>
@@ -6215,7 +6215,7 @@
           <p:cNvPr id="2" name="">
             <a:extLst xmlns:a="http://schemas.openxmlformats.org/drawingml/2006/main">
               <a:ext uri="{FF2B5EF4-FFF2-40B4-BE49-F238E27FC236}">
-                <a16:creationId xmlns:a16="http://schemas.microsoft.com/office/drawing/2014/main" id="{47D89786-6D2C-41C0-8512-09044869DFC4}"/>
+                <a16:creationId xmlns:a16="http://schemas.microsoft.com/office/drawing/2014/main" id="{20B5EE04-42E5-43EC-BD55-DE387E223DDC}"/>
               </a:ext>
             </a:extLst>
           </p:cNvPr>
@@ -6272,7 +6272,7 @@
           <p:cNvPr id="3" name="">
             <a:extLst xmlns:a="http://schemas.openxmlformats.org/drawingml/2006/main">
               <a:ext uri="{FF2B5EF4-FFF2-40B4-BE49-F238E27FC236}">
-                <a16:creationId xmlns:a16="http://schemas.microsoft.com/office/drawing/2014/main" id="{8ABA28E7-BF1E-4C2F-B6C1-2DF4F229EB0B}"/>
+                <a16:creationId xmlns:a16="http://schemas.microsoft.com/office/drawing/2014/main" id="{51CB31ED-1C41-43D3-BD68-024A7524E58A}"/>
               </a:ext>
             </a:extLst>
           </p:cNvPr>
@@ -6329,7 +6329,7 @@
           <p:cNvPr id="4" name="">
             <a:extLst xmlns:a="http://schemas.openxmlformats.org/drawingml/2006/main">
               <a:ext uri="{FF2B5EF4-FFF2-40B4-BE49-F238E27FC236}">
-                <a16:creationId xmlns:a16="http://schemas.microsoft.com/office/drawing/2014/main" id="{B50C6662-31D9-49D7-8F57-BBC4A17C9516}"/>
+                <a16:creationId xmlns:a16="http://schemas.microsoft.com/office/drawing/2014/main" id="{7C99E720-C6A9-4850-B323-536DE64E5C5A}"/>
               </a:ext>
             </a:extLst>
           </p:cNvPr>
@@ -6386,7 +6386,7 @@
           <p:cNvPr id="5" name="">
             <a:extLst xmlns:a="http://schemas.openxmlformats.org/drawingml/2006/main">
               <a:ext uri="{FF2B5EF4-FFF2-40B4-BE49-F238E27FC236}">
-                <a16:creationId xmlns:a16="http://schemas.microsoft.com/office/drawing/2014/main" id="{BE8BE172-B793-4F8B-8207-01E8B3875B53}"/>
+                <a16:creationId xmlns:a16="http://schemas.microsoft.com/office/drawing/2014/main" id="{078329A3-C04C-4013-9F24-28D8793D53DA}"/>
               </a:ext>
             </a:extLst>
           </p:cNvPr>
@@ -6443,7 +6443,7 @@
           <p:cNvPr id="6" name="">
             <a:extLst xmlns:a="http://schemas.openxmlformats.org/drawingml/2006/main">
               <a:ext uri="{FF2B5EF4-FFF2-40B4-BE49-F238E27FC236}">
-                <a16:creationId xmlns:a16="http://schemas.microsoft.com/office/drawing/2014/main" id="{7D12867A-E134-4D13-8AD3-FF94359B3ED5}"/>
+                <a16:creationId xmlns:a16="http://schemas.microsoft.com/office/drawing/2014/main" id="{0BC6CFD8-B275-4905-97DD-3EC3B48C348E}"/>
               </a:ext>
             </a:extLst>
           </p:cNvPr>
@@ -6498,7 +6498,7 @@
     </p:spTree>
     <p:extLst>
       <p:ext uri="{BB962C8B-B14F-4D97-AF65-F5344CB8AC3E}">
-        <p14:creationId xmlns:p14="http://schemas.microsoft.com/office/powerpoint/2010/main" val="965544412"/>
+        <p14:creationId xmlns:p14="http://schemas.microsoft.com/office/powerpoint/2010/main" val="67883030"/>
       </p:ext>
     </p:extLst>
   </p:cSld>
@@ -6529,7 +6529,7 @@
           <p:cNvPr id="9" name="">
             <a:extLst xmlns:a="http://schemas.openxmlformats.org/drawingml/2006/main">
               <a:ext uri="{FF2B5EF4-FFF2-40B4-BE49-F238E27FC236}">
-                <a16:creationId xmlns:a16="http://schemas.microsoft.com/office/drawing/2014/main" id="{C8772634-4CFB-4C82-B2B0-15B1E39C176A}"/>
+                <a16:creationId xmlns:a16="http://schemas.microsoft.com/office/drawing/2014/main" id="{CC446F48-1527-49F1-A4EA-1AB03A7D2BE6}"/>
               </a:ext>
             </a:extLst>
           </p:cNvPr>
@@ -6586,7 +6586,7 @@
           <p:cNvPr id="2" name="">
             <a:extLst xmlns:a="http://schemas.openxmlformats.org/drawingml/2006/main">
               <a:ext uri="{FF2B5EF4-FFF2-40B4-BE49-F238E27FC236}">
-                <a16:creationId xmlns:a16="http://schemas.microsoft.com/office/drawing/2014/main" id="{4086E3D1-A76D-4FDC-AEDD-1F714CD31464}"/>
+                <a16:creationId xmlns:a16="http://schemas.microsoft.com/office/drawing/2014/main" id="{572F0E86-94D4-4D62-AFE2-37282800C6A7}"/>
               </a:ext>
             </a:extLst>
           </p:cNvPr>
@@ -6633,7 +6633,7 @@
                 <a:ea typeface="Georgia"/>
                 <a:cs typeface="Georgia"/>
               </a:rPr>
-              <a:t>Compare two ETF candidates</a:t>
+              <a:t>Two goals can call for two funds</a:t>
             </a:r>
           </a:p>
         </p:txBody>
@@ -6643,7 +6643,7 @@
           <p:cNvPr id="3" name="">
             <a:extLst xmlns:a="http://schemas.openxmlformats.org/drawingml/2006/main">
               <a:ext uri="{FF2B5EF4-FFF2-40B4-BE49-F238E27FC236}">
-                <a16:creationId xmlns:a16="http://schemas.microsoft.com/office/drawing/2014/main" id="{0AFDFD2F-9DE2-4E10-8E16-EB9AB89FBB36}"/>
+                <a16:creationId xmlns:a16="http://schemas.microsoft.com/office/drawing/2014/main" id="{3F21456E-0EDD-4BA9-A8BD-E9500A05564F}"/>
               </a:ext>
             </a:extLst>
           </p:cNvPr>
@@ -6700,7 +6700,7 @@
           <p:cNvPr id="4" name="">
             <a:extLst xmlns:a="http://schemas.openxmlformats.org/drawingml/2006/main">
               <a:ext uri="{FF2B5EF4-FFF2-40B4-BE49-F238E27FC236}">
-                <a16:creationId xmlns:a16="http://schemas.microsoft.com/office/drawing/2014/main" id="{727882C9-76A1-44AE-80F6-D8AC0BD1BEDA}"/>
+                <a16:creationId xmlns:a16="http://schemas.microsoft.com/office/drawing/2014/main" id="{6A694108-187B-4801-9E99-035F6F8269C2}"/>
               </a:ext>
             </a:extLst>
           </p:cNvPr>
@@ -6757,7 +6757,7 @@
           <p:cNvPr id="5" name="">
             <a:extLst xmlns:a="http://schemas.openxmlformats.org/drawingml/2006/main">
               <a:ext uri="{FF2B5EF4-FFF2-40B4-BE49-F238E27FC236}">
-                <a16:creationId xmlns:a16="http://schemas.microsoft.com/office/drawing/2014/main" id="{B27F4AB9-834B-4FE9-A07C-24F212905117}"/>
+                <a16:creationId xmlns:a16="http://schemas.microsoft.com/office/drawing/2014/main" id="{F4172EE8-C593-4685-8D68-5CD9D66EFCB6}"/>
               </a:ext>
             </a:extLst>
           </p:cNvPr>
@@ -6814,7 +6814,7 @@
           <p:cNvPr id="6" name="">
             <a:extLst xmlns:a="http://schemas.openxmlformats.org/drawingml/2006/main">
               <a:ext uri="{FF2B5EF4-FFF2-40B4-BE49-F238E27FC236}">
-                <a16:creationId xmlns:a16="http://schemas.microsoft.com/office/drawing/2014/main" id="{03B02B38-0E6E-4CE4-854B-4AFBB6A90D39}"/>
+                <a16:creationId xmlns:a16="http://schemas.microsoft.com/office/drawing/2014/main" id="{174CBBDF-3662-4E22-B760-7D21E35AE352}"/>
               </a:ext>
             </a:extLst>
           </p:cNvPr>
@@ -6917,7 +6917,7 @@
           <p:cNvPr id="7" name="">
             <a:extLst xmlns:a="http://schemas.openxmlformats.org/drawingml/2006/main">
               <a:ext uri="{FF2B5EF4-FFF2-40B4-BE49-F238E27FC236}">
-                <a16:creationId xmlns:a16="http://schemas.microsoft.com/office/drawing/2014/main" id="{B02D5346-967E-43AD-B23B-E867ECF6B50C}"/>
+                <a16:creationId xmlns:a16="http://schemas.microsoft.com/office/drawing/2014/main" id="{B87C9781-8E8A-4345-97ED-870CFF431819}"/>
               </a:ext>
             </a:extLst>
           </p:cNvPr>
@@ -6974,7 +6974,7 @@
           <p:cNvPr id="8" name="">
             <a:extLst xmlns:a="http://schemas.openxmlformats.org/drawingml/2006/main">
               <a:ext uri="{FF2B5EF4-FFF2-40B4-BE49-F238E27FC236}">
-                <a16:creationId xmlns:a16="http://schemas.microsoft.com/office/drawing/2014/main" id="{4529001F-7A4F-430E-A629-02AB24F5D686}"/>
+                <a16:creationId xmlns:a16="http://schemas.microsoft.com/office/drawing/2014/main" id="{5DAA1F79-5172-4614-BCB2-870A8D528A61}"/>
               </a:ext>
             </a:extLst>
           </p:cNvPr>
@@ -7075,7 +7075,7 @@
     </p:spTree>
     <p:extLst>
       <p:ext uri="{BB962C8B-B14F-4D97-AF65-F5344CB8AC3E}">
-        <p14:creationId xmlns:p14="http://schemas.microsoft.com/office/powerpoint/2010/main" val="1960122303"/>
+        <p14:creationId xmlns:p14="http://schemas.microsoft.com/office/powerpoint/2010/main" val="1181893355"/>
       </p:ext>
     </p:extLst>
   </p:cSld>

</xml_diff>

<commit_message>
Ask students to challenge their ETF investment thesis
</commit_message>
<xml_diff>
--- a/docs/module3-etfs/output/Module_3_ETFs_Lesson.pptx
+++ b/docs/module3-etfs/output/Module_3_ETFs_Lesson.pptx
@@ -2,24 +2,24 @@
 <file path=ppt/presentation.xml><?xml version="1.0" encoding="utf-8"?>
 <p:presentation xmlns:p="http://schemas.openxmlformats.org/presentationml/2006/main">
   <p:sldMasterIdLst>
-    <p:sldMasterId xmlns:r="http://schemas.openxmlformats.org/officeDocument/2006/relationships" id="2147483648" r:id="R10b659b71ca740ba"/>
+    <p:sldMasterId xmlns:r="http://schemas.openxmlformats.org/officeDocument/2006/relationships" id="2147483648" r:id="R072550d6ba2e4354"/>
   </p:sldMasterIdLst>
   <p:notesMasterIdLst>
-    <p:notesMasterId xmlns:r="http://schemas.openxmlformats.org/officeDocument/2006/relationships" r:id="Rc2c7becfba024ee2"/>
+    <p:notesMasterId xmlns:r="http://schemas.openxmlformats.org/officeDocument/2006/relationships" r:id="R68f34228d290423d"/>
   </p:notesMasterIdLst>
   <p:sldIdLst>
-    <p:sldId xmlns:r="http://schemas.openxmlformats.org/officeDocument/2006/relationships" id="256" r:id="R749cb38325fd41db"/>
-    <p:sldId xmlns:r="http://schemas.openxmlformats.org/officeDocument/2006/relationships" id="257" r:id="Rea5c12c3d6404266"/>
-    <p:sldId xmlns:r="http://schemas.openxmlformats.org/officeDocument/2006/relationships" id="258" r:id="R11f5e08630cf4ba6"/>
-    <p:sldId xmlns:r="http://schemas.openxmlformats.org/officeDocument/2006/relationships" id="259" r:id="Rf87fa734e4bb4ac2"/>
-    <p:sldId xmlns:r="http://schemas.openxmlformats.org/officeDocument/2006/relationships" id="260" r:id="Rb87fc5ee152f43b1"/>
-    <p:sldId xmlns:r="http://schemas.openxmlformats.org/officeDocument/2006/relationships" id="261" r:id="R5c6118cd47f84767"/>
-    <p:sldId xmlns:r="http://schemas.openxmlformats.org/officeDocument/2006/relationships" id="262" r:id="R44327b9ecf1a468e"/>
-    <p:sldId xmlns:r="http://schemas.openxmlformats.org/officeDocument/2006/relationships" id="263" r:id="R8d379beb1d724bdc"/>
-    <p:sldId xmlns:r="http://schemas.openxmlformats.org/officeDocument/2006/relationships" id="264" r:id="R50b05ae3690e4c7c"/>
-    <p:sldId xmlns:r="http://schemas.openxmlformats.org/officeDocument/2006/relationships" id="265" r:id="R9bd9db0a819a4fbf"/>
-    <p:sldId xmlns:r="http://schemas.openxmlformats.org/officeDocument/2006/relationships" id="266" r:id="R18462eea307f479e"/>
-    <p:sldId xmlns:r="http://schemas.openxmlformats.org/officeDocument/2006/relationships" id="267" r:id="R59811aa17c124809"/>
+    <p:sldId xmlns:r="http://schemas.openxmlformats.org/officeDocument/2006/relationships" id="256" r:id="R25f37d2912e14bbe"/>
+    <p:sldId xmlns:r="http://schemas.openxmlformats.org/officeDocument/2006/relationships" id="257" r:id="Rb47b7bdb92504df4"/>
+    <p:sldId xmlns:r="http://schemas.openxmlformats.org/officeDocument/2006/relationships" id="258" r:id="Rd772bb314b764151"/>
+    <p:sldId xmlns:r="http://schemas.openxmlformats.org/officeDocument/2006/relationships" id="259" r:id="R4ff98672700c4d9b"/>
+    <p:sldId xmlns:r="http://schemas.openxmlformats.org/officeDocument/2006/relationships" id="260" r:id="Rfc75469c684f4c33"/>
+    <p:sldId xmlns:r="http://schemas.openxmlformats.org/officeDocument/2006/relationships" id="261" r:id="Ra387d33326674e35"/>
+    <p:sldId xmlns:r="http://schemas.openxmlformats.org/officeDocument/2006/relationships" id="262" r:id="Rd8c4931f92d54dbe"/>
+    <p:sldId xmlns:r="http://schemas.openxmlformats.org/officeDocument/2006/relationships" id="263" r:id="R405b157801fe4db7"/>
+    <p:sldId xmlns:r="http://schemas.openxmlformats.org/officeDocument/2006/relationships" id="264" r:id="R48a3f436fb7a4fb1"/>
+    <p:sldId xmlns:r="http://schemas.openxmlformats.org/officeDocument/2006/relationships" id="265" r:id="R1b39afb471084ad9"/>
+    <p:sldId xmlns:r="http://schemas.openxmlformats.org/officeDocument/2006/relationships" id="266" r:id="R119ba8266b004464"/>
+    <p:sldId xmlns:r="http://schemas.openxmlformats.org/officeDocument/2006/relationships" id="267" r:id="R2d4de4713db94578"/>
   </p:sldIdLst>
   <p:sldSz cx="12192000" cy="6858000"/>
   <p:notesSz cx="6858000" cy="9144000"/>
@@ -523,7 +523,7 @@
           <a:lstStyle xmlns:a="http://schemas.openxmlformats.org/drawingml/2006/main"/>
           <a:p xmlns:a="http://schemas.openxmlformats.org/drawingml/2006/main">
             <a:r>
-              <a:t>The app checks for two different current ETF holdings. Broad, sector, and thematic funds count; single asset products do not. The teacher judges whether each explanation connects the fund to the stated goal. No fixed spending minimum and no requirement to preserve Module 2 holdings.</a:t>
+              <a:t>The app checks for two different current ETF holdings. Broad, sector, and thematic funds count; single asset products do not. The teacher judges whether each explanation connects the fund to the stated goal and gives a reasoned challenge to the investment idea. No fixed spending minimum and no requirement to preserve Module 2 holdings.</a:t>
             </a:r>
           </a:p>
         </p:txBody>
@@ -593,7 +593,7 @@
           <a:lstStyle xmlns:a="http://schemas.openxmlformats.org/drawingml/2006/main"/>
           <a:p xmlns:a="http://schemas.openxmlformats.org/drawingml/2006/main">
             <a:r>
-              <a:t>Model answer only. Students should use their own actual portfolio and fund research. Ask the class to identify both goals, the fund fit, overlap, and remaining risks. Do not grade on agreement with one ticker.</a:t>
+              <a:t>Model answer only. Students should use their own actual portfolio and fund research. Ask the class to identify both goals, what each fund owns, overlap, remaining risks, and what evidence would change the second decision. Do not grade on agreement with one ticker or a predicted return.</a:t>
             </a:r>
           </a:p>
           <a:p xmlns:a="http://schemas.openxmlformats.org/drawingml/2006/main">
@@ -1441,7 +1441,7 @@
   </p:cSld>
   <p:clrMap bg1="lt1" tx1="dk1" bg2="lt2" tx2="dk2" accent1="accent1" accent2="accent2" accent3="accent3" accent4="accent4" accent5="accent5" accent6="accent6" hlink="hlink" folHlink="folHlink"/>
   <p:sldLayoutIdLst>
-    <p:sldLayoutId xmlns:r="http://schemas.openxmlformats.org/officeDocument/2006/relationships" id="2147483649" r:id="R5ab128c0b00d48dc"/>
+    <p:sldLayoutId xmlns:r="http://schemas.openxmlformats.org/officeDocument/2006/relationships" id="2147483649" r:id="Rb48b28b76f6b4b8a"/>
   </p:sldLayoutIdLst>
   <p:txStyles>
     <p:titleStyle>
@@ -1992,7 +1992,7 @@
           <p:cNvPr id="6" name="">
             <a:extLst xmlns:a="http://schemas.openxmlformats.org/drawingml/2006/main">
               <a:ext uri="{FF2B5EF4-FFF2-40B4-BE49-F238E27FC236}">
-                <a16:creationId xmlns:a16="http://schemas.microsoft.com/office/drawing/2014/main" id="{59860AB7-6138-45B3-BD64-73FE2B3EC5F6}"/>
+                <a16:creationId xmlns:a16="http://schemas.microsoft.com/office/drawing/2014/main" id="{CFF51A19-BD4E-43D6-8F71-2B7A8C7D4FF5}"/>
               </a:ext>
             </a:extLst>
           </p:cNvPr>
@@ -2049,7 +2049,7 @@
           <p:cNvPr id="2" name="">
             <a:extLst xmlns:a="http://schemas.openxmlformats.org/drawingml/2006/main">
               <a:ext uri="{FF2B5EF4-FFF2-40B4-BE49-F238E27FC236}">
-                <a16:creationId xmlns:a16="http://schemas.microsoft.com/office/drawing/2014/main" id="{AFB14DD9-1369-4395-96D7-84E9E3F796FB}"/>
+                <a16:creationId xmlns:a16="http://schemas.microsoft.com/office/drawing/2014/main" id="{EA6ECBFE-216F-4021-ACF9-D25EA7F4469C}"/>
               </a:ext>
             </a:extLst>
           </p:cNvPr>
@@ -2106,7 +2106,7 @@
           <p:cNvPr id="3" name="">
             <a:extLst xmlns:a="http://schemas.openxmlformats.org/drawingml/2006/main">
               <a:ext uri="{FF2B5EF4-FFF2-40B4-BE49-F238E27FC236}">
-                <a16:creationId xmlns:a16="http://schemas.microsoft.com/office/drawing/2014/main" id="{CA8F09AD-964C-4DEA-BE07-D015CEBAE220}"/>
+                <a16:creationId xmlns:a16="http://schemas.microsoft.com/office/drawing/2014/main" id="{8D6563BE-92DD-4172-88B0-17089A7A17B0}"/>
               </a:ext>
             </a:extLst>
           </p:cNvPr>
@@ -2163,7 +2163,7 @@
           <p:cNvPr id="4" name="">
             <a:extLst xmlns:a="http://schemas.openxmlformats.org/drawingml/2006/main">
               <a:ext uri="{FF2B5EF4-FFF2-40B4-BE49-F238E27FC236}">
-                <a16:creationId xmlns:a16="http://schemas.microsoft.com/office/drawing/2014/main" id="{2A2C137A-E192-4006-9EC4-7CA8EC821ACD}"/>
+                <a16:creationId xmlns:a16="http://schemas.microsoft.com/office/drawing/2014/main" id="{28E3BC28-B310-4930-8159-C843A89C5CF7}"/>
               </a:ext>
             </a:extLst>
           </p:cNvPr>
@@ -2220,7 +2220,7 @@
           <p:cNvPr id="5" name="">
             <a:extLst xmlns:a="http://schemas.openxmlformats.org/drawingml/2006/main">
               <a:ext uri="{FF2B5EF4-FFF2-40B4-BE49-F238E27FC236}">
-                <a16:creationId xmlns:a16="http://schemas.microsoft.com/office/drawing/2014/main" id="{F0639318-249D-4899-BFC2-4C9F3C418496}"/>
+                <a16:creationId xmlns:a16="http://schemas.microsoft.com/office/drawing/2014/main" id="{1BE942F8-8BA4-429F-9657-0FB9B68982AE}"/>
               </a:ext>
             </a:extLst>
           </p:cNvPr>
@@ -2275,7 +2275,7 @@
     </p:spTree>
     <p:extLst>
       <p:ext uri="{BB962C8B-B14F-4D97-AF65-F5344CB8AC3E}">
-        <p14:creationId xmlns:p14="http://schemas.microsoft.com/office/powerpoint/2010/main" val="229057472"/>
+        <p14:creationId xmlns:p14="http://schemas.microsoft.com/office/powerpoint/2010/main" val="2074083466"/>
       </p:ext>
     </p:extLst>
   </p:cSld>
@@ -2306,7 +2306,7 @@
           <p:cNvPr id="8" name="">
             <a:extLst xmlns:a="http://schemas.openxmlformats.org/drawingml/2006/main">
               <a:ext uri="{FF2B5EF4-FFF2-40B4-BE49-F238E27FC236}">
-                <a16:creationId xmlns:a16="http://schemas.microsoft.com/office/drawing/2014/main" id="{2C5CCD9C-2C3F-4241-901A-02303AEC2D95}"/>
+                <a16:creationId xmlns:a16="http://schemas.microsoft.com/office/drawing/2014/main" id="{B8E0CC85-04F7-4C45-941D-2BCCDA21817D}"/>
               </a:ext>
             </a:extLst>
           </p:cNvPr>
@@ -2363,7 +2363,7 @@
           <p:cNvPr id="2" name="">
             <a:extLst xmlns:a="http://schemas.openxmlformats.org/drawingml/2006/main">
               <a:ext uri="{FF2B5EF4-FFF2-40B4-BE49-F238E27FC236}">
-                <a16:creationId xmlns:a16="http://schemas.microsoft.com/office/drawing/2014/main" id="{C120D794-C6CE-49AD-982B-17B2C5AD20D7}"/>
+                <a16:creationId xmlns:a16="http://schemas.microsoft.com/office/drawing/2014/main" id="{D013EDFE-CEB7-4778-934F-287AFB5464CD}"/>
               </a:ext>
             </a:extLst>
           </p:cNvPr>
@@ -2420,7 +2420,7 @@
           <p:cNvPr id="3" name="">
             <a:extLst xmlns:a="http://schemas.openxmlformats.org/drawingml/2006/main">
               <a:ext uri="{FF2B5EF4-FFF2-40B4-BE49-F238E27FC236}">
-                <a16:creationId xmlns:a16="http://schemas.microsoft.com/office/drawing/2014/main" id="{EFBD91FD-1395-46EC-8D36-B7F4965F4442}"/>
+                <a16:creationId xmlns:a16="http://schemas.microsoft.com/office/drawing/2014/main" id="{3A294F43-BBA7-425E-A61D-203B19EFF07D}"/>
               </a:ext>
             </a:extLst>
           </p:cNvPr>
@@ -2477,7 +2477,7 @@
           <p:cNvPr id="4" name="">
             <a:extLst xmlns:a="http://schemas.openxmlformats.org/drawingml/2006/main">
               <a:ext uri="{FF2B5EF4-FFF2-40B4-BE49-F238E27FC236}">
-                <a16:creationId xmlns:a16="http://schemas.microsoft.com/office/drawing/2014/main" id="{A520B61A-AA83-48EB-861C-2071450F45D5}"/>
+                <a16:creationId xmlns:a16="http://schemas.microsoft.com/office/drawing/2014/main" id="{45EB6BA6-2AC5-42F2-ABA7-2C1A1BBE0584}"/>
               </a:ext>
             </a:extLst>
           </p:cNvPr>
@@ -2534,7 +2534,7 @@
           <p:cNvPr id="5" name="">
             <a:extLst xmlns:a="http://schemas.openxmlformats.org/drawingml/2006/main">
               <a:ext uri="{FF2B5EF4-FFF2-40B4-BE49-F238E27FC236}">
-                <a16:creationId xmlns:a16="http://schemas.microsoft.com/office/drawing/2014/main" id="{0B7098A9-F000-453D-B270-3B14C097DDEF}"/>
+                <a16:creationId xmlns:a16="http://schemas.microsoft.com/office/drawing/2014/main" id="{80F00DEB-BC94-4F4F-8EF0-FBBC779CDC54}"/>
               </a:ext>
             </a:extLst>
           </p:cNvPr>
@@ -2581,7 +2581,7 @@
                 <a:ea typeface="Arial"/>
                 <a:cs typeface="Arial"/>
               </a:rPr>
-              <a:t>Find a different idea you believe in; hold a second ETF.</a:t>
+              <a:t>Build a reasoned idea; hold a second ETF that fits it.</a:t>
             </a:r>
           </a:p>
         </p:txBody>
@@ -2591,7 +2591,7 @@
           <p:cNvPr id="6" name="">
             <a:extLst xmlns:a="http://schemas.openxmlformats.org/drawingml/2006/main">
               <a:ext uri="{FF2B5EF4-FFF2-40B4-BE49-F238E27FC236}">
-                <a16:creationId xmlns:a16="http://schemas.microsoft.com/office/drawing/2014/main" id="{198339A1-80A4-4AB2-8BD7-3B6B62BF1FDE}"/>
+                <a16:creationId xmlns:a16="http://schemas.microsoft.com/office/drawing/2014/main" id="{8CB357BC-299B-4515-A0F3-44DB33A76EFF}"/>
               </a:ext>
             </a:extLst>
           </p:cNvPr>
@@ -2638,7 +2638,7 @@
                 <a:ea typeface="Arial"/>
                 <a:cs typeface="Arial"/>
               </a:rPr>
-              <a:t>Explain how each fund serves its goal.</a:t>
+              <a:t>Explain holdings, overlap, fees, and risks for each.</a:t>
             </a:r>
           </a:p>
         </p:txBody>
@@ -2648,7 +2648,7 @@
           <p:cNvPr id="7" name="">
             <a:extLst xmlns:a="http://schemas.openxmlformats.org/drawingml/2006/main">
               <a:ext uri="{FF2B5EF4-FFF2-40B4-BE49-F238E27FC236}">
-                <a16:creationId xmlns:a16="http://schemas.microsoft.com/office/drawing/2014/main" id="{5E472AF8-78FF-4A03-8CF3-F805D79AC87C}"/>
+                <a16:creationId xmlns:a16="http://schemas.microsoft.com/office/drawing/2014/main" id="{629C5DD0-FCAF-47B8-B790-1EC7BB7C3839}"/>
               </a:ext>
             </a:extLst>
           </p:cNvPr>
@@ -2695,7 +2695,7 @@
                 <a:ea typeface="Arial"/>
                 <a:cs typeface="Arial"/>
               </a:rPr>
-              <a:t>Check both funds’ holdings, overlap, fees, and risks.</a:t>
+              <a:t>Name evidence that would make you reconsider the idea.</a:t>
             </a:r>
           </a:p>
         </p:txBody>
@@ -2703,7 +2703,7 @@
     </p:spTree>
     <p:extLst>
       <p:ext uri="{BB962C8B-B14F-4D97-AF65-F5344CB8AC3E}">
-        <p14:creationId xmlns:p14="http://schemas.microsoft.com/office/powerpoint/2010/main" val="1523284784"/>
+        <p14:creationId xmlns:p14="http://schemas.microsoft.com/office/powerpoint/2010/main" val="1738417784"/>
       </p:ext>
     </p:extLst>
   </p:cSld>
@@ -2734,7 +2734,7 @@
           <p:cNvPr id="5" name="">
             <a:extLst xmlns:a="http://schemas.openxmlformats.org/drawingml/2006/main">
               <a:ext uri="{FF2B5EF4-FFF2-40B4-BE49-F238E27FC236}">
-                <a16:creationId xmlns:a16="http://schemas.microsoft.com/office/drawing/2014/main" id="{9AEE6A04-98CB-4CC1-B0D6-9F3F724F45F5}"/>
+                <a16:creationId xmlns:a16="http://schemas.microsoft.com/office/drawing/2014/main" id="{4C411FF2-B296-41D7-955A-7AB0170872BD}"/>
               </a:ext>
             </a:extLst>
           </p:cNvPr>
@@ -2791,7 +2791,7 @@
           <p:cNvPr id="2" name="">
             <a:extLst xmlns:a="http://schemas.openxmlformats.org/drawingml/2006/main">
               <a:ext uri="{FF2B5EF4-FFF2-40B4-BE49-F238E27FC236}">
-                <a16:creationId xmlns:a16="http://schemas.microsoft.com/office/drawing/2014/main" id="{20560128-69C8-4995-B833-C68C47544792}"/>
+                <a16:creationId xmlns:a16="http://schemas.microsoft.com/office/drawing/2014/main" id="{9D4F7340-8F33-4075-A972-BCD8097FB6BC}"/>
               </a:ext>
             </a:extLst>
           </p:cNvPr>
@@ -2848,7 +2848,7 @@
           <p:cNvPr id="3" name="">
             <a:extLst xmlns:a="http://schemas.openxmlformats.org/drawingml/2006/main">
               <a:ext uri="{FF2B5EF4-FFF2-40B4-BE49-F238E27FC236}">
-                <a16:creationId xmlns:a16="http://schemas.microsoft.com/office/drawing/2014/main" id="{C567F285-CB71-4D59-BC8E-DA6177C3032E}"/>
+                <a16:creationId xmlns:a16="http://schemas.microsoft.com/office/drawing/2014/main" id="{A90A37A2-6F2A-4AC2-9AF2-2503DA89C123}"/>
               </a:ext>
             </a:extLst>
           </p:cNvPr>
@@ -2905,7 +2905,7 @@
           <p:cNvPr id="4" name="">
             <a:extLst xmlns:a="http://schemas.openxmlformats.org/drawingml/2006/main">
               <a:ext uri="{FF2B5EF4-FFF2-40B4-BE49-F238E27FC236}">
-                <a16:creationId xmlns:a16="http://schemas.microsoft.com/office/drawing/2014/main" id="{D5221E81-D6EA-4559-BBD3-283C88A6AEB6}"/>
+                <a16:creationId xmlns:a16="http://schemas.microsoft.com/office/drawing/2014/main" id="{D7D40FF0-1687-42C3-B135-F7E66B00A87B}"/>
               </a:ext>
             </a:extLst>
           </p:cNvPr>
@@ -2952,7 +2952,7 @@
                 <a:ea typeface="Arial"/>
                 <a:cs typeface="Arial"/>
               </a:rPr>
-              <a:t>“I own mostly U.S. stocks, so VXUS adds companies outside the U.S. That fills a geographic gap, though global stocks can still fall. I also want a bigger technology position, so XLK adds technology companies. It overlaps with stocks I own, and a tech downturn would hurt both.”</a:t>
+              <a:t>“I own mostly U.S. stocks, so VXUS adds companies outside the U.S. That fills a geographic gap, though global stocks can still fall. I also want more technology exposure, so XLK adds technology companies. It overlaps with stocks I own. If those companies’ earnings stopped growing, I would reconsider that bet.”</a:t>
             </a:r>
           </a:p>
         </p:txBody>
@@ -2960,7 +2960,7 @@
     </p:spTree>
     <p:extLst>
       <p:ext uri="{BB962C8B-B14F-4D97-AF65-F5344CB8AC3E}">
-        <p14:creationId xmlns:p14="http://schemas.microsoft.com/office/powerpoint/2010/main" val="1799184110"/>
+        <p14:creationId xmlns:p14="http://schemas.microsoft.com/office/powerpoint/2010/main" val="544733763"/>
       </p:ext>
     </p:extLst>
   </p:cSld>
@@ -2991,7 +2991,7 @@
           <p:cNvPr id="8" name="">
             <a:extLst xmlns:a="http://schemas.openxmlformats.org/drawingml/2006/main">
               <a:ext uri="{FF2B5EF4-FFF2-40B4-BE49-F238E27FC236}">
-                <a16:creationId xmlns:a16="http://schemas.microsoft.com/office/drawing/2014/main" id="{4E8AECB4-5771-460B-AD14-142A91FE81CF}"/>
+                <a16:creationId xmlns:a16="http://schemas.microsoft.com/office/drawing/2014/main" id="{89C5FAC5-C15D-47F3-AB45-57F98B7A59D8}"/>
               </a:ext>
             </a:extLst>
           </p:cNvPr>
@@ -3048,7 +3048,7 @@
           <p:cNvPr id="2" name="">
             <a:extLst xmlns:a="http://schemas.openxmlformats.org/drawingml/2006/main">
               <a:ext uri="{FF2B5EF4-FFF2-40B4-BE49-F238E27FC236}">
-                <a16:creationId xmlns:a16="http://schemas.microsoft.com/office/drawing/2014/main" id="{F3F60BBD-4631-412B-981D-D016E14A1BBD}"/>
+                <a16:creationId xmlns:a16="http://schemas.microsoft.com/office/drawing/2014/main" id="{751B5DC0-9028-4459-BEBF-6A7A2355E9C5}"/>
               </a:ext>
             </a:extLst>
           </p:cNvPr>
@@ -3105,7 +3105,7 @@
           <p:cNvPr id="3" name="">
             <a:extLst xmlns:a="http://schemas.openxmlformats.org/drawingml/2006/main">
               <a:ext uri="{FF2B5EF4-FFF2-40B4-BE49-F238E27FC236}">
-                <a16:creationId xmlns:a16="http://schemas.microsoft.com/office/drawing/2014/main" id="{BF518746-092E-4DA5-8E36-E6C8EAC02DE8}"/>
+                <a16:creationId xmlns:a16="http://schemas.microsoft.com/office/drawing/2014/main" id="{18BADA2D-8DB1-4ED9-92E7-F1F9DB3513A5}"/>
               </a:ext>
             </a:extLst>
           </p:cNvPr>
@@ -3162,7 +3162,7 @@
           <p:cNvPr id="4" name="">
             <a:extLst xmlns:a="http://schemas.openxmlformats.org/drawingml/2006/main">
               <a:ext uri="{FF2B5EF4-FFF2-40B4-BE49-F238E27FC236}">
-                <a16:creationId xmlns:a16="http://schemas.microsoft.com/office/drawing/2014/main" id="{94FC5986-78F1-4794-9E3D-E54541B24584}"/>
+                <a16:creationId xmlns:a16="http://schemas.microsoft.com/office/drawing/2014/main" id="{92DD13B9-2E31-44C3-B720-458EAA5C6C69}"/>
               </a:ext>
             </a:extLst>
           </p:cNvPr>
@@ -3219,7 +3219,7 @@
           <p:cNvPr id="5" name="">
             <a:extLst xmlns:a="http://schemas.openxmlformats.org/drawingml/2006/main">
               <a:ext uri="{FF2B5EF4-FFF2-40B4-BE49-F238E27FC236}">
-                <a16:creationId xmlns:a16="http://schemas.microsoft.com/office/drawing/2014/main" id="{5AF01A84-4A98-4267-939C-656B5F2959BE}"/>
+                <a16:creationId xmlns:a16="http://schemas.microsoft.com/office/drawing/2014/main" id="{45912FDC-46F6-46D7-85F4-CD45785B994A}"/>
               </a:ext>
             </a:extLst>
           </p:cNvPr>
@@ -3266,7 +3266,7 @@
                 <a:ea typeface="Arial"/>
                 <a:cs typeface="Arial"/>
               </a:rPr>
-              <a:t>Which different area do you want to bet bigger on?</a:t>
+              <a:t>Which different idea do you have a reason to believe in?</a:t>
             </a:r>
           </a:p>
         </p:txBody>
@@ -3276,7 +3276,7 @@
           <p:cNvPr id="6" name="">
             <a:extLst xmlns:a="http://schemas.openxmlformats.org/drawingml/2006/main">
               <a:ext uri="{FF2B5EF4-FFF2-40B4-BE49-F238E27FC236}">
-                <a16:creationId xmlns:a16="http://schemas.microsoft.com/office/drawing/2014/main" id="{A8B42FAD-06EA-42BC-B089-A2E617B60CDE}"/>
+                <a16:creationId xmlns:a16="http://schemas.microsoft.com/office/drawing/2014/main" id="{07B25851-C1C7-472D-93DC-52DECBB6C28E}"/>
               </a:ext>
             </a:extLst>
           </p:cNvPr>
@@ -3323,7 +3323,7 @@
                 <a:ea typeface="Arial"/>
                 <a:cs typeface="Arial"/>
               </a:rPr>
-              <a:t>Which two ETFs fit those goals, and what risks remain?</a:t>
+              <a:t>What would make you reconsider that idea?</a:t>
             </a:r>
           </a:p>
         </p:txBody>
@@ -3333,7 +3333,7 @@
           <p:cNvPr id="7" name="">
             <a:extLst xmlns:a="http://schemas.openxmlformats.org/drawingml/2006/main">
               <a:ext uri="{FF2B5EF4-FFF2-40B4-BE49-F238E27FC236}">
-                <a16:creationId xmlns:a16="http://schemas.microsoft.com/office/drawing/2014/main" id="{9AE547A6-41C1-45F5-9B2E-281E030350CC}"/>
+                <a16:creationId xmlns:a16="http://schemas.microsoft.com/office/drawing/2014/main" id="{8BEA37FB-6A10-477C-8591-48266589DCA4}"/>
               </a:ext>
             </a:extLst>
           </p:cNvPr>
@@ -3388,7 +3388,7 @@
     </p:spTree>
     <p:extLst>
       <p:ext uri="{BB962C8B-B14F-4D97-AF65-F5344CB8AC3E}">
-        <p14:creationId xmlns:p14="http://schemas.microsoft.com/office/powerpoint/2010/main" val="2013665426"/>
+        <p14:creationId xmlns:p14="http://schemas.microsoft.com/office/powerpoint/2010/main" val="241966994"/>
       </p:ext>
     </p:extLst>
   </p:cSld>
@@ -3419,7 +3419,7 @@
           <p:cNvPr id="7" name="">
             <a:extLst xmlns:a="http://schemas.openxmlformats.org/drawingml/2006/main">
               <a:ext uri="{FF2B5EF4-FFF2-40B4-BE49-F238E27FC236}">
-                <a16:creationId xmlns:a16="http://schemas.microsoft.com/office/drawing/2014/main" id="{E3365FAC-EF22-4AA5-BFB7-71A0C0E686AA}"/>
+                <a16:creationId xmlns:a16="http://schemas.microsoft.com/office/drawing/2014/main" id="{65137E9E-061E-4687-9177-C51EE7488F5A}"/>
               </a:ext>
             </a:extLst>
           </p:cNvPr>
@@ -3476,7 +3476,7 @@
           <p:cNvPr id="2" name="">
             <a:extLst xmlns:a="http://schemas.openxmlformats.org/drawingml/2006/main">
               <a:ext uri="{FF2B5EF4-FFF2-40B4-BE49-F238E27FC236}">
-                <a16:creationId xmlns:a16="http://schemas.microsoft.com/office/drawing/2014/main" id="{74FE76A5-71D3-42C6-A20D-8E6014C45A03}"/>
+                <a16:creationId xmlns:a16="http://schemas.microsoft.com/office/drawing/2014/main" id="{087BCACB-415A-4519-B8BB-6F484E4E263F}"/>
               </a:ext>
             </a:extLst>
           </p:cNvPr>
@@ -3533,7 +3533,7 @@
           <p:cNvPr id="3" name="">
             <a:extLst xmlns:a="http://schemas.openxmlformats.org/drawingml/2006/main">
               <a:ext uri="{FF2B5EF4-FFF2-40B4-BE49-F238E27FC236}">
-                <a16:creationId xmlns:a16="http://schemas.microsoft.com/office/drawing/2014/main" id="{8FB6FA2E-065A-425B-ABC9-607684AAE7DC}"/>
+                <a16:creationId xmlns:a16="http://schemas.microsoft.com/office/drawing/2014/main" id="{9F972E06-D52B-4969-BAA0-6DA61FF3EAF6}"/>
               </a:ext>
             </a:extLst>
           </p:cNvPr>
@@ -3590,7 +3590,7 @@
           <p:cNvPr id="4" name="">
             <a:extLst xmlns:a="http://schemas.openxmlformats.org/drawingml/2006/main">
               <a:ext uri="{FF2B5EF4-FFF2-40B4-BE49-F238E27FC236}">
-                <a16:creationId xmlns:a16="http://schemas.microsoft.com/office/drawing/2014/main" id="{7D6BAE29-7D63-4782-A255-7F9228E65AB2}"/>
+                <a16:creationId xmlns:a16="http://schemas.microsoft.com/office/drawing/2014/main" id="{B09EFC50-FF0A-4F35-A875-AAA5E26059AA}"/>
               </a:ext>
             </a:extLst>
           </p:cNvPr>
@@ -3647,7 +3647,7 @@
           <p:cNvPr id="5" name="">
             <a:extLst xmlns:a="http://schemas.openxmlformats.org/drawingml/2006/main">
               <a:ext uri="{FF2B5EF4-FFF2-40B4-BE49-F238E27FC236}">
-                <a16:creationId xmlns:a16="http://schemas.microsoft.com/office/drawing/2014/main" id="{EE22F770-8B4B-4C93-8089-D931D0C718AA}"/>
+                <a16:creationId xmlns:a16="http://schemas.microsoft.com/office/drawing/2014/main" id="{9A90D65E-63FA-4E07-B827-33B01398110D}"/>
               </a:ext>
             </a:extLst>
           </p:cNvPr>
@@ -3704,7 +3704,7 @@
           <p:cNvPr id="6" name="">
             <a:extLst xmlns:a="http://schemas.openxmlformats.org/drawingml/2006/main">
               <a:ext uri="{FF2B5EF4-FFF2-40B4-BE49-F238E27FC236}">
-                <a16:creationId xmlns:a16="http://schemas.microsoft.com/office/drawing/2014/main" id="{DFCD0BC0-BACD-47A9-ADC0-721EAD9632CD}"/>
+                <a16:creationId xmlns:a16="http://schemas.microsoft.com/office/drawing/2014/main" id="{162741D2-F569-4018-82EB-64B044BDC94E}"/>
               </a:ext>
             </a:extLst>
           </p:cNvPr>
@@ -3759,7 +3759,7 @@
     </p:spTree>
     <p:extLst>
       <p:ext uri="{BB962C8B-B14F-4D97-AF65-F5344CB8AC3E}">
-        <p14:creationId xmlns:p14="http://schemas.microsoft.com/office/powerpoint/2010/main" val="1301499005"/>
+        <p14:creationId xmlns:p14="http://schemas.microsoft.com/office/powerpoint/2010/main" val="63601939"/>
       </p:ext>
     </p:extLst>
   </p:cSld>
@@ -3790,7 +3790,7 @@
           <p:cNvPr id="9" name="">
             <a:extLst xmlns:a="http://schemas.openxmlformats.org/drawingml/2006/main">
               <a:ext uri="{FF2B5EF4-FFF2-40B4-BE49-F238E27FC236}">
-                <a16:creationId xmlns:a16="http://schemas.microsoft.com/office/drawing/2014/main" id="{E5F96D3A-CAE3-4073-BBBC-90D6CC34DA8C}"/>
+                <a16:creationId xmlns:a16="http://schemas.microsoft.com/office/drawing/2014/main" id="{0C339C8D-56BB-4453-B03F-B516A3443EDC}"/>
               </a:ext>
             </a:extLst>
           </p:cNvPr>
@@ -3847,7 +3847,7 @@
           <p:cNvPr id="2" name="">
             <a:extLst xmlns:a="http://schemas.openxmlformats.org/drawingml/2006/main">
               <a:ext uri="{FF2B5EF4-FFF2-40B4-BE49-F238E27FC236}">
-                <a16:creationId xmlns:a16="http://schemas.microsoft.com/office/drawing/2014/main" id="{F21AB68F-AABD-476B-B31B-08A1D8A1E404}"/>
+                <a16:creationId xmlns:a16="http://schemas.microsoft.com/office/drawing/2014/main" id="{F5E49B55-9867-48AA-86FB-5477CF93AF9D}"/>
               </a:ext>
             </a:extLst>
           </p:cNvPr>
@@ -3904,7 +3904,7 @@
           <p:cNvPr id="3" name="">
             <a:extLst xmlns:a="http://schemas.openxmlformats.org/drawingml/2006/main">
               <a:ext uri="{FF2B5EF4-FFF2-40B4-BE49-F238E27FC236}">
-                <a16:creationId xmlns:a16="http://schemas.microsoft.com/office/drawing/2014/main" id="{F3E3ED20-4B6F-45C1-8144-62CC15380597}"/>
+                <a16:creationId xmlns:a16="http://schemas.microsoft.com/office/drawing/2014/main" id="{692A8F10-CBC7-42B8-8AE9-462191C742E2}"/>
               </a:ext>
             </a:extLst>
           </p:cNvPr>
@@ -3961,7 +3961,7 @@
           <p:cNvPr id="4" name="">
             <a:extLst xmlns:a="http://schemas.openxmlformats.org/drawingml/2006/main">
               <a:ext uri="{FF2B5EF4-FFF2-40B4-BE49-F238E27FC236}">
-                <a16:creationId xmlns:a16="http://schemas.microsoft.com/office/drawing/2014/main" id="{4D5F2088-7672-4B0A-9693-DC1A1AD806D5}"/>
+                <a16:creationId xmlns:a16="http://schemas.microsoft.com/office/drawing/2014/main" id="{7EA25E66-0C9E-4F2F-9220-CB55ADD8750B}"/>
               </a:ext>
             </a:extLst>
           </p:cNvPr>
@@ -4018,7 +4018,7 @@
           <p:cNvPr id="5" name="">
             <a:extLst xmlns:a="http://schemas.openxmlformats.org/drawingml/2006/main">
               <a:ext uri="{FF2B5EF4-FFF2-40B4-BE49-F238E27FC236}">
-                <a16:creationId xmlns:a16="http://schemas.microsoft.com/office/drawing/2014/main" id="{C85492DE-F2DE-48A7-9774-6B836B5C11F3}"/>
+                <a16:creationId xmlns:a16="http://schemas.microsoft.com/office/drawing/2014/main" id="{648AD556-01AC-4079-BE8A-11BDA7337EC7}"/>
               </a:ext>
             </a:extLst>
           </p:cNvPr>
@@ -4075,7 +4075,7 @@
           <p:cNvPr id="6" name="">
             <a:extLst xmlns:a="http://schemas.openxmlformats.org/drawingml/2006/main">
               <a:ext uri="{FF2B5EF4-FFF2-40B4-BE49-F238E27FC236}">
-                <a16:creationId xmlns:a16="http://schemas.microsoft.com/office/drawing/2014/main" id="{B766CDC9-2D12-45DB-8F9E-767B7B142010}"/>
+                <a16:creationId xmlns:a16="http://schemas.microsoft.com/office/drawing/2014/main" id="{415B9A83-29FD-4AB6-BD82-568D449770EA}"/>
               </a:ext>
             </a:extLst>
           </p:cNvPr>
@@ -4132,7 +4132,7 @@
           <p:cNvPr id="7" name="">
             <a:extLst xmlns:a="http://schemas.openxmlformats.org/drawingml/2006/main">
               <a:ext uri="{FF2B5EF4-FFF2-40B4-BE49-F238E27FC236}">
-                <a16:creationId xmlns:a16="http://schemas.microsoft.com/office/drawing/2014/main" id="{3515649F-E184-438C-934F-12E5AC2AB676}"/>
+                <a16:creationId xmlns:a16="http://schemas.microsoft.com/office/drawing/2014/main" id="{FA36A7F2-7872-4248-B317-CBB2C9F72DA0}"/>
               </a:ext>
             </a:extLst>
           </p:cNvPr>
@@ -4189,7 +4189,7 @@
           <p:cNvPr id="8" name="">
             <a:extLst xmlns:a="http://schemas.openxmlformats.org/drawingml/2006/main">
               <a:ext uri="{FF2B5EF4-FFF2-40B4-BE49-F238E27FC236}">
-                <a16:creationId xmlns:a16="http://schemas.microsoft.com/office/drawing/2014/main" id="{5993D9B5-D758-4656-9DF3-76C939E859AD}"/>
+                <a16:creationId xmlns:a16="http://schemas.microsoft.com/office/drawing/2014/main" id="{EDF44291-1125-4CA9-AB6B-C3AE7BC2EA25}"/>
               </a:ext>
             </a:extLst>
           </p:cNvPr>
@@ -4244,7 +4244,7 @@
     </p:spTree>
     <p:extLst>
       <p:ext uri="{BB962C8B-B14F-4D97-AF65-F5344CB8AC3E}">
-        <p14:creationId xmlns:p14="http://schemas.microsoft.com/office/powerpoint/2010/main" val="1411391271"/>
+        <p14:creationId xmlns:p14="http://schemas.microsoft.com/office/powerpoint/2010/main" val="1122698100"/>
       </p:ext>
     </p:extLst>
   </p:cSld>
@@ -4275,7 +4275,7 @@
           <p:cNvPr id="9" name="">
             <a:extLst xmlns:a="http://schemas.openxmlformats.org/drawingml/2006/main">
               <a:ext uri="{FF2B5EF4-FFF2-40B4-BE49-F238E27FC236}">
-                <a16:creationId xmlns:a16="http://schemas.microsoft.com/office/drawing/2014/main" id="{5D9E71C1-27B7-4E6F-9A95-A0E593683E90}"/>
+                <a16:creationId xmlns:a16="http://schemas.microsoft.com/office/drawing/2014/main" id="{668CEB84-E162-46CF-92B6-54F5A283C7F7}"/>
               </a:ext>
             </a:extLst>
           </p:cNvPr>
@@ -4332,7 +4332,7 @@
           <p:cNvPr id="2" name="">
             <a:extLst xmlns:a="http://schemas.openxmlformats.org/drawingml/2006/main">
               <a:ext uri="{FF2B5EF4-FFF2-40B4-BE49-F238E27FC236}">
-                <a16:creationId xmlns:a16="http://schemas.microsoft.com/office/drawing/2014/main" id="{940DAAB8-03CE-4141-9111-87F02A8792EC}"/>
+                <a16:creationId xmlns:a16="http://schemas.microsoft.com/office/drawing/2014/main" id="{755FB795-0E97-4013-A107-046867A57068}"/>
               </a:ext>
             </a:extLst>
           </p:cNvPr>
@@ -4389,7 +4389,7 @@
           <p:cNvPr id="3" name="">
             <a:extLst xmlns:a="http://schemas.openxmlformats.org/drawingml/2006/main">
               <a:ext uri="{FF2B5EF4-FFF2-40B4-BE49-F238E27FC236}">
-                <a16:creationId xmlns:a16="http://schemas.microsoft.com/office/drawing/2014/main" id="{3F35469D-C745-4B52-BF25-B0BDCD588906}"/>
+                <a16:creationId xmlns:a16="http://schemas.microsoft.com/office/drawing/2014/main" id="{9C2C4D45-D4CA-4A8C-A27F-308B2762C1A1}"/>
               </a:ext>
             </a:extLst>
           </p:cNvPr>
@@ -4446,7 +4446,7 @@
           <p:cNvPr id="4" name="">
             <a:extLst xmlns:a="http://schemas.openxmlformats.org/drawingml/2006/main">
               <a:ext uri="{FF2B5EF4-FFF2-40B4-BE49-F238E27FC236}">
-                <a16:creationId xmlns:a16="http://schemas.microsoft.com/office/drawing/2014/main" id="{8A4C3045-49E0-4905-9CDF-2A89C2A2C87D}"/>
+                <a16:creationId xmlns:a16="http://schemas.microsoft.com/office/drawing/2014/main" id="{D0B12893-F155-4607-8284-B7FE08C502DB}"/>
               </a:ext>
             </a:extLst>
           </p:cNvPr>
@@ -4503,7 +4503,7 @@
           <p:cNvPr id="5" name="">
             <a:extLst xmlns:a="http://schemas.openxmlformats.org/drawingml/2006/main">
               <a:ext uri="{FF2B5EF4-FFF2-40B4-BE49-F238E27FC236}">
-                <a16:creationId xmlns:a16="http://schemas.microsoft.com/office/drawing/2014/main" id="{BAE33145-F641-466D-9AFE-053A85A1521A}"/>
+                <a16:creationId xmlns:a16="http://schemas.microsoft.com/office/drawing/2014/main" id="{1A9B205E-CD13-400B-8AC9-BA1E9B018533}"/>
               </a:ext>
             </a:extLst>
           </p:cNvPr>
@@ -4560,7 +4560,7 @@
           <p:cNvPr id="6" name="">
             <a:extLst xmlns:a="http://schemas.openxmlformats.org/drawingml/2006/main">
               <a:ext uri="{FF2B5EF4-FFF2-40B4-BE49-F238E27FC236}">
-                <a16:creationId xmlns:a16="http://schemas.microsoft.com/office/drawing/2014/main" id="{7917A0E9-4A6E-4789-9E9D-1F59D09903DE}"/>
+                <a16:creationId xmlns:a16="http://schemas.microsoft.com/office/drawing/2014/main" id="{DE553C31-21E8-4E42-8628-E8F8E1415BE9}"/>
               </a:ext>
             </a:extLst>
           </p:cNvPr>
@@ -4617,7 +4617,7 @@
           <p:cNvPr id="7" name="">
             <a:extLst xmlns:a="http://schemas.openxmlformats.org/drawingml/2006/main">
               <a:ext uri="{FF2B5EF4-FFF2-40B4-BE49-F238E27FC236}">
-                <a16:creationId xmlns:a16="http://schemas.microsoft.com/office/drawing/2014/main" id="{A0BBF089-3372-4B3F-813F-23864DFB9463}"/>
+                <a16:creationId xmlns:a16="http://schemas.microsoft.com/office/drawing/2014/main" id="{D68A2352-8265-443C-B906-F8513EC4AC34}"/>
               </a:ext>
             </a:extLst>
           </p:cNvPr>
@@ -4674,7 +4674,7 @@
           <p:cNvPr id="8" name="">
             <a:extLst xmlns:a="http://schemas.openxmlformats.org/drawingml/2006/main">
               <a:ext uri="{FF2B5EF4-FFF2-40B4-BE49-F238E27FC236}">
-                <a16:creationId xmlns:a16="http://schemas.microsoft.com/office/drawing/2014/main" id="{2CC8251A-EDD5-4B6F-A3FB-837F566088A9}"/>
+                <a16:creationId xmlns:a16="http://schemas.microsoft.com/office/drawing/2014/main" id="{37C6BE2A-3C6B-453B-A5FD-8A52C922A731}"/>
               </a:ext>
             </a:extLst>
           </p:cNvPr>
@@ -4729,7 +4729,7 @@
     </p:spTree>
     <p:extLst>
       <p:ext uri="{BB962C8B-B14F-4D97-AF65-F5344CB8AC3E}">
-        <p14:creationId xmlns:p14="http://schemas.microsoft.com/office/powerpoint/2010/main" val="1538572675"/>
+        <p14:creationId xmlns:p14="http://schemas.microsoft.com/office/powerpoint/2010/main" val="1771475792"/>
       </p:ext>
     </p:extLst>
   </p:cSld>
@@ -4760,7 +4760,7 @@
           <p:cNvPr id="9" name="">
             <a:extLst xmlns:a="http://schemas.openxmlformats.org/drawingml/2006/main">
               <a:ext uri="{FF2B5EF4-FFF2-40B4-BE49-F238E27FC236}">
-                <a16:creationId xmlns:a16="http://schemas.microsoft.com/office/drawing/2014/main" id="{E4C9D85F-DC60-4896-8550-141BE46FACC9}"/>
+                <a16:creationId xmlns:a16="http://schemas.microsoft.com/office/drawing/2014/main" id="{E3719296-53B9-4AB8-B5D4-469C2AF1AFD1}"/>
               </a:ext>
             </a:extLst>
           </p:cNvPr>
@@ -4817,7 +4817,7 @@
           <p:cNvPr id="2" name="">
             <a:extLst xmlns:a="http://schemas.openxmlformats.org/drawingml/2006/main">
               <a:ext uri="{FF2B5EF4-FFF2-40B4-BE49-F238E27FC236}">
-                <a16:creationId xmlns:a16="http://schemas.microsoft.com/office/drawing/2014/main" id="{F7761DFB-3D69-4E2E-AF51-C16A8DC13119}"/>
+                <a16:creationId xmlns:a16="http://schemas.microsoft.com/office/drawing/2014/main" id="{B9FAB6EF-D9C4-4852-80A6-05A767EA87DC}"/>
               </a:ext>
             </a:extLst>
           </p:cNvPr>
@@ -4874,7 +4874,7 @@
           <p:cNvPr id="3" name="">
             <a:extLst xmlns:a="http://schemas.openxmlformats.org/drawingml/2006/main">
               <a:ext uri="{FF2B5EF4-FFF2-40B4-BE49-F238E27FC236}">
-                <a16:creationId xmlns:a16="http://schemas.microsoft.com/office/drawing/2014/main" id="{51DB7248-F5F4-4803-901F-FB241BDB242E}"/>
+                <a16:creationId xmlns:a16="http://schemas.microsoft.com/office/drawing/2014/main" id="{E75E96FA-E244-444B-9EB2-B314ACD4783E}"/>
               </a:ext>
             </a:extLst>
           </p:cNvPr>
@@ -4931,7 +4931,7 @@
           <p:cNvPr id="4" name="">
             <a:extLst xmlns:a="http://schemas.openxmlformats.org/drawingml/2006/main">
               <a:ext uri="{FF2B5EF4-FFF2-40B4-BE49-F238E27FC236}">
-                <a16:creationId xmlns:a16="http://schemas.microsoft.com/office/drawing/2014/main" id="{0E24EF34-1F25-40AB-A763-FE3B64DB9409}"/>
+                <a16:creationId xmlns:a16="http://schemas.microsoft.com/office/drawing/2014/main" id="{DE230CA7-0C6B-4FF9-8A36-292B9D66CAD3}"/>
               </a:ext>
             </a:extLst>
           </p:cNvPr>
@@ -4988,7 +4988,7 @@
           <p:cNvPr id="5" name="">
             <a:extLst xmlns:a="http://schemas.openxmlformats.org/drawingml/2006/main">
               <a:ext uri="{FF2B5EF4-FFF2-40B4-BE49-F238E27FC236}">
-                <a16:creationId xmlns:a16="http://schemas.microsoft.com/office/drawing/2014/main" id="{A030C4A0-0D39-44D4-9150-BC8EDAB0F0F0}"/>
+                <a16:creationId xmlns:a16="http://schemas.microsoft.com/office/drawing/2014/main" id="{12911A0A-A55D-4F8F-87F5-63ACA88BB794}"/>
               </a:ext>
             </a:extLst>
           </p:cNvPr>
@@ -5045,7 +5045,7 @@
           <p:cNvPr id="6" name="">
             <a:extLst xmlns:a="http://schemas.openxmlformats.org/drawingml/2006/main">
               <a:ext uri="{FF2B5EF4-FFF2-40B4-BE49-F238E27FC236}">
-                <a16:creationId xmlns:a16="http://schemas.microsoft.com/office/drawing/2014/main" id="{DA3C99A8-16AB-48CC-AC74-F87D9834ED5D}"/>
+                <a16:creationId xmlns:a16="http://schemas.microsoft.com/office/drawing/2014/main" id="{D5469EF0-F280-43A9-BAC6-9DE77C02DA36}"/>
               </a:ext>
             </a:extLst>
           </p:cNvPr>
@@ -5102,7 +5102,7 @@
           <p:cNvPr id="7" name="">
             <a:extLst xmlns:a="http://schemas.openxmlformats.org/drawingml/2006/main">
               <a:ext uri="{FF2B5EF4-FFF2-40B4-BE49-F238E27FC236}">
-                <a16:creationId xmlns:a16="http://schemas.microsoft.com/office/drawing/2014/main" id="{39EE7076-F0AD-462B-8780-F72D6C552459}"/>
+                <a16:creationId xmlns:a16="http://schemas.microsoft.com/office/drawing/2014/main" id="{2CED5B12-F76E-4935-A090-AD491BEDC55F}"/>
               </a:ext>
             </a:extLst>
           </p:cNvPr>
@@ -5159,7 +5159,7 @@
           <p:cNvPr id="8" name="">
             <a:extLst xmlns:a="http://schemas.openxmlformats.org/drawingml/2006/main">
               <a:ext uri="{FF2B5EF4-FFF2-40B4-BE49-F238E27FC236}">
-                <a16:creationId xmlns:a16="http://schemas.microsoft.com/office/drawing/2014/main" id="{2311B750-B53E-46F3-8D74-3A5F80DC04E7}"/>
+                <a16:creationId xmlns:a16="http://schemas.microsoft.com/office/drawing/2014/main" id="{34A3D54F-C643-4ECE-B202-134957FC2594}"/>
               </a:ext>
             </a:extLst>
           </p:cNvPr>
@@ -5214,7 +5214,7 @@
     </p:spTree>
     <p:extLst>
       <p:ext uri="{BB962C8B-B14F-4D97-AF65-F5344CB8AC3E}">
-        <p14:creationId xmlns:p14="http://schemas.microsoft.com/office/powerpoint/2010/main" val="2079609831"/>
+        <p14:creationId xmlns:p14="http://schemas.microsoft.com/office/powerpoint/2010/main" val="1892849846"/>
       </p:ext>
     </p:extLst>
   </p:cSld>
@@ -5245,7 +5245,7 @@
           <p:cNvPr id="9" name="">
             <a:extLst xmlns:a="http://schemas.openxmlformats.org/drawingml/2006/main">
               <a:ext uri="{FF2B5EF4-FFF2-40B4-BE49-F238E27FC236}">
-                <a16:creationId xmlns:a16="http://schemas.microsoft.com/office/drawing/2014/main" id="{EB3FD4DD-99A5-4A73-BE76-F25787162270}"/>
+                <a16:creationId xmlns:a16="http://schemas.microsoft.com/office/drawing/2014/main" id="{B88B0082-98AF-4953-961E-44A206C3A982}"/>
               </a:ext>
             </a:extLst>
           </p:cNvPr>
@@ -5302,7 +5302,7 @@
           <p:cNvPr id="2" name="">
             <a:extLst xmlns:a="http://schemas.openxmlformats.org/drawingml/2006/main">
               <a:ext uri="{FF2B5EF4-FFF2-40B4-BE49-F238E27FC236}">
-                <a16:creationId xmlns:a16="http://schemas.microsoft.com/office/drawing/2014/main" id="{A2F1411C-7F3B-4D1B-9157-6FA558EE6EB8}"/>
+                <a16:creationId xmlns:a16="http://schemas.microsoft.com/office/drawing/2014/main" id="{8C671548-141B-4C5B-9E5F-E93E9EE23F77}"/>
               </a:ext>
             </a:extLst>
           </p:cNvPr>
@@ -5359,7 +5359,7 @@
           <p:cNvPr id="3" name="">
             <a:extLst xmlns:a="http://schemas.openxmlformats.org/drawingml/2006/main">
               <a:ext uri="{FF2B5EF4-FFF2-40B4-BE49-F238E27FC236}">
-                <a16:creationId xmlns:a16="http://schemas.microsoft.com/office/drawing/2014/main" id="{C7E0B348-1673-48CE-BA9D-47AC216DC723}"/>
+                <a16:creationId xmlns:a16="http://schemas.microsoft.com/office/drawing/2014/main" id="{676D5655-F971-4A74-84CD-2BB57313A978}"/>
               </a:ext>
             </a:extLst>
           </p:cNvPr>
@@ -5416,7 +5416,7 @@
           <p:cNvPr id="4" name="">
             <a:extLst xmlns:a="http://schemas.openxmlformats.org/drawingml/2006/main">
               <a:ext uri="{FF2B5EF4-FFF2-40B4-BE49-F238E27FC236}">
-                <a16:creationId xmlns:a16="http://schemas.microsoft.com/office/drawing/2014/main" id="{117DBE64-F529-4FEE-B592-8BB73195BB52}"/>
+                <a16:creationId xmlns:a16="http://schemas.microsoft.com/office/drawing/2014/main" id="{DD7D6592-C02A-4B3D-A973-FEA5E9D02039}"/>
               </a:ext>
             </a:extLst>
           </p:cNvPr>
@@ -5473,7 +5473,7 @@
           <p:cNvPr id="5" name="">
             <a:extLst xmlns:a="http://schemas.openxmlformats.org/drawingml/2006/main">
               <a:ext uri="{FF2B5EF4-FFF2-40B4-BE49-F238E27FC236}">
-                <a16:creationId xmlns:a16="http://schemas.microsoft.com/office/drawing/2014/main" id="{3A87FDEF-D0CD-4A0D-AC8C-583D74F798A8}"/>
+                <a16:creationId xmlns:a16="http://schemas.microsoft.com/office/drawing/2014/main" id="{B0B71827-2E46-41A1-AF6B-D0FD53FA8E91}"/>
               </a:ext>
             </a:extLst>
           </p:cNvPr>
@@ -5530,7 +5530,7 @@
           <p:cNvPr id="6" name="">
             <a:extLst xmlns:a="http://schemas.openxmlformats.org/drawingml/2006/main">
               <a:ext uri="{FF2B5EF4-FFF2-40B4-BE49-F238E27FC236}">
-                <a16:creationId xmlns:a16="http://schemas.microsoft.com/office/drawing/2014/main" id="{800E3F21-F2A4-4B3D-8B2F-A9E8E746D8E2}"/>
+                <a16:creationId xmlns:a16="http://schemas.microsoft.com/office/drawing/2014/main" id="{5C6E700B-809E-4B07-8715-6ADA1762A7C0}"/>
               </a:ext>
             </a:extLst>
           </p:cNvPr>
@@ -5587,7 +5587,7 @@
           <p:cNvPr id="7" name="">
             <a:extLst xmlns:a="http://schemas.openxmlformats.org/drawingml/2006/main">
               <a:ext uri="{FF2B5EF4-FFF2-40B4-BE49-F238E27FC236}">
-                <a16:creationId xmlns:a16="http://schemas.microsoft.com/office/drawing/2014/main" id="{0BFF791A-8671-403C-8EF7-B825A892A3D7}"/>
+                <a16:creationId xmlns:a16="http://schemas.microsoft.com/office/drawing/2014/main" id="{AEDD4EAC-BC8E-49E6-BCB0-C6002F3C35C1}"/>
               </a:ext>
             </a:extLst>
           </p:cNvPr>
@@ -5644,7 +5644,7 @@
           <p:cNvPr id="8" name="">
             <a:extLst xmlns:a="http://schemas.openxmlformats.org/drawingml/2006/main">
               <a:ext uri="{FF2B5EF4-FFF2-40B4-BE49-F238E27FC236}">
-                <a16:creationId xmlns:a16="http://schemas.microsoft.com/office/drawing/2014/main" id="{E5AAF4E8-3D46-48A3-89F3-560B8428DAD3}"/>
+                <a16:creationId xmlns:a16="http://schemas.microsoft.com/office/drawing/2014/main" id="{F53A7C3E-3496-4099-92DF-AE60D4D41379}"/>
               </a:ext>
             </a:extLst>
           </p:cNvPr>
@@ -5699,7 +5699,7 @@
     </p:spTree>
     <p:extLst>
       <p:ext uri="{BB962C8B-B14F-4D97-AF65-F5344CB8AC3E}">
-        <p14:creationId xmlns:p14="http://schemas.microsoft.com/office/powerpoint/2010/main" val="992520246"/>
+        <p14:creationId xmlns:p14="http://schemas.microsoft.com/office/powerpoint/2010/main" val="2125042382"/>
       </p:ext>
     </p:extLst>
   </p:cSld>
@@ -5730,7 +5730,7 @@
           <p:cNvPr id="8" name="">
             <a:extLst xmlns:a="http://schemas.openxmlformats.org/drawingml/2006/main">
               <a:ext uri="{FF2B5EF4-FFF2-40B4-BE49-F238E27FC236}">
-                <a16:creationId xmlns:a16="http://schemas.microsoft.com/office/drawing/2014/main" id="{35F11E95-83F4-4DDB-8508-A4BAC7F77F2E}"/>
+                <a16:creationId xmlns:a16="http://schemas.microsoft.com/office/drawing/2014/main" id="{40188B5C-C49E-4B31-9607-47B61A0C2D4B}"/>
               </a:ext>
             </a:extLst>
           </p:cNvPr>
@@ -5787,7 +5787,7 @@
           <p:cNvPr id="2" name="">
             <a:extLst xmlns:a="http://schemas.openxmlformats.org/drawingml/2006/main">
               <a:ext uri="{FF2B5EF4-FFF2-40B4-BE49-F238E27FC236}">
-                <a16:creationId xmlns:a16="http://schemas.microsoft.com/office/drawing/2014/main" id="{7CD2DFAE-D1B4-4B40-9F6B-48A016048A37}"/>
+                <a16:creationId xmlns:a16="http://schemas.microsoft.com/office/drawing/2014/main" id="{527AB36C-5B3B-4427-A319-1CD361C2813D}"/>
               </a:ext>
             </a:extLst>
           </p:cNvPr>
@@ -5844,7 +5844,7 @@
           <p:cNvPr id="3" name="">
             <a:extLst xmlns:a="http://schemas.openxmlformats.org/drawingml/2006/main">
               <a:ext uri="{FF2B5EF4-FFF2-40B4-BE49-F238E27FC236}">
-                <a16:creationId xmlns:a16="http://schemas.microsoft.com/office/drawing/2014/main" id="{654821FD-A095-4184-8E24-E9264FABC162}"/>
+                <a16:creationId xmlns:a16="http://schemas.microsoft.com/office/drawing/2014/main" id="{839BB935-02A1-4871-8CB2-8FEC4218D2C0}"/>
               </a:ext>
             </a:extLst>
           </p:cNvPr>
@@ -5901,7 +5901,7 @@
           <p:cNvPr id="4" name="">
             <a:extLst xmlns:a="http://schemas.openxmlformats.org/drawingml/2006/main">
               <a:ext uri="{FF2B5EF4-FFF2-40B4-BE49-F238E27FC236}">
-                <a16:creationId xmlns:a16="http://schemas.microsoft.com/office/drawing/2014/main" id="{1C677288-092C-4AC7-B26D-2DA3274FD6FD}"/>
+                <a16:creationId xmlns:a16="http://schemas.microsoft.com/office/drawing/2014/main" id="{AA795C6C-4486-4B2D-823B-5EFD1CD97781}"/>
               </a:ext>
             </a:extLst>
           </p:cNvPr>
@@ -5958,7 +5958,7 @@
           <p:cNvPr id="5" name="">
             <a:extLst xmlns:a="http://schemas.openxmlformats.org/drawingml/2006/main">
               <a:ext uri="{FF2B5EF4-FFF2-40B4-BE49-F238E27FC236}">
-                <a16:creationId xmlns:a16="http://schemas.microsoft.com/office/drawing/2014/main" id="{ACD81BE9-279A-4ADA-96A2-0649610CF945}"/>
+                <a16:creationId xmlns:a16="http://schemas.microsoft.com/office/drawing/2014/main" id="{DECEB8C4-2504-42E6-A758-078E0E10BE61}"/>
               </a:ext>
             </a:extLst>
           </p:cNvPr>
@@ -6015,7 +6015,7 @@
           <p:cNvPr id="6" name="">
             <a:extLst xmlns:a="http://schemas.openxmlformats.org/drawingml/2006/main">
               <a:ext uri="{FF2B5EF4-FFF2-40B4-BE49-F238E27FC236}">
-                <a16:creationId xmlns:a16="http://schemas.microsoft.com/office/drawing/2014/main" id="{EF99E058-3E5C-4BFE-9F45-F4A5E4F8672D}"/>
+                <a16:creationId xmlns:a16="http://schemas.microsoft.com/office/drawing/2014/main" id="{3691521D-4B92-4F59-AF8A-5287D9E83788}"/>
               </a:ext>
             </a:extLst>
           </p:cNvPr>
@@ -6072,7 +6072,7 @@
           <p:cNvPr id="7" name="">
             <a:extLst xmlns:a="http://schemas.openxmlformats.org/drawingml/2006/main">
               <a:ext uri="{FF2B5EF4-FFF2-40B4-BE49-F238E27FC236}">
-                <a16:creationId xmlns:a16="http://schemas.microsoft.com/office/drawing/2014/main" id="{10D70C31-B5BB-4FF3-9832-D3AE6759E277}"/>
+                <a16:creationId xmlns:a16="http://schemas.microsoft.com/office/drawing/2014/main" id="{820CCF38-4CFD-484C-804D-9CE73C7ECC7D}"/>
               </a:ext>
             </a:extLst>
           </p:cNvPr>
@@ -6127,7 +6127,7 @@
     </p:spTree>
     <p:extLst>
       <p:ext uri="{BB962C8B-B14F-4D97-AF65-F5344CB8AC3E}">
-        <p14:creationId xmlns:p14="http://schemas.microsoft.com/office/powerpoint/2010/main" val="878617064"/>
+        <p14:creationId xmlns:p14="http://schemas.microsoft.com/office/powerpoint/2010/main" val="181248265"/>
       </p:ext>
     </p:extLst>
   </p:cSld>
@@ -6158,7 +6158,7 @@
           <p:cNvPr id="7" name="">
             <a:extLst xmlns:a="http://schemas.openxmlformats.org/drawingml/2006/main">
               <a:ext uri="{FF2B5EF4-FFF2-40B4-BE49-F238E27FC236}">
-                <a16:creationId xmlns:a16="http://schemas.microsoft.com/office/drawing/2014/main" id="{FB31EEB6-7184-4584-8EEF-1C4BC991C244}"/>
+                <a16:creationId xmlns:a16="http://schemas.microsoft.com/office/drawing/2014/main" id="{7424DA96-22ED-4209-A484-4285488D9896}"/>
               </a:ext>
             </a:extLst>
           </p:cNvPr>
@@ -6215,7 +6215,7 @@
           <p:cNvPr id="2" name="">
             <a:extLst xmlns:a="http://schemas.openxmlformats.org/drawingml/2006/main">
               <a:ext uri="{FF2B5EF4-FFF2-40B4-BE49-F238E27FC236}">
-                <a16:creationId xmlns:a16="http://schemas.microsoft.com/office/drawing/2014/main" id="{20B5EE04-42E5-43EC-BD55-DE387E223DDC}"/>
+                <a16:creationId xmlns:a16="http://schemas.microsoft.com/office/drawing/2014/main" id="{A92A7423-701E-410F-8BE0-3A2BEF879050}"/>
               </a:ext>
             </a:extLst>
           </p:cNvPr>
@@ -6272,7 +6272,7 @@
           <p:cNvPr id="3" name="">
             <a:extLst xmlns:a="http://schemas.openxmlformats.org/drawingml/2006/main">
               <a:ext uri="{FF2B5EF4-FFF2-40B4-BE49-F238E27FC236}">
-                <a16:creationId xmlns:a16="http://schemas.microsoft.com/office/drawing/2014/main" id="{51CB31ED-1C41-43D3-BD68-024A7524E58A}"/>
+                <a16:creationId xmlns:a16="http://schemas.microsoft.com/office/drawing/2014/main" id="{D401FDF1-F95E-4CC4-9250-5AD69BBF463D}"/>
               </a:ext>
             </a:extLst>
           </p:cNvPr>
@@ -6329,7 +6329,7 @@
           <p:cNvPr id="4" name="">
             <a:extLst xmlns:a="http://schemas.openxmlformats.org/drawingml/2006/main">
               <a:ext uri="{FF2B5EF4-FFF2-40B4-BE49-F238E27FC236}">
-                <a16:creationId xmlns:a16="http://schemas.microsoft.com/office/drawing/2014/main" id="{7C99E720-C6A9-4850-B323-536DE64E5C5A}"/>
+                <a16:creationId xmlns:a16="http://schemas.microsoft.com/office/drawing/2014/main" id="{F247D48B-4F2E-4BD7-A2E1-9811B001B6C5}"/>
               </a:ext>
             </a:extLst>
           </p:cNvPr>
@@ -6386,7 +6386,7 @@
           <p:cNvPr id="5" name="">
             <a:extLst xmlns:a="http://schemas.openxmlformats.org/drawingml/2006/main">
               <a:ext uri="{FF2B5EF4-FFF2-40B4-BE49-F238E27FC236}">
-                <a16:creationId xmlns:a16="http://schemas.microsoft.com/office/drawing/2014/main" id="{078329A3-C04C-4013-9F24-28D8793D53DA}"/>
+                <a16:creationId xmlns:a16="http://schemas.microsoft.com/office/drawing/2014/main" id="{6744AF25-D59D-47E0-B258-473124B29AEF}"/>
               </a:ext>
             </a:extLst>
           </p:cNvPr>
@@ -6443,7 +6443,7 @@
           <p:cNvPr id="6" name="">
             <a:extLst xmlns:a="http://schemas.openxmlformats.org/drawingml/2006/main">
               <a:ext uri="{FF2B5EF4-FFF2-40B4-BE49-F238E27FC236}">
-                <a16:creationId xmlns:a16="http://schemas.microsoft.com/office/drawing/2014/main" id="{0BC6CFD8-B275-4905-97DD-3EC3B48C348E}"/>
+                <a16:creationId xmlns:a16="http://schemas.microsoft.com/office/drawing/2014/main" id="{033BBB6C-8CB0-4415-A2D9-5F45EB791DF9}"/>
               </a:ext>
             </a:extLst>
           </p:cNvPr>
@@ -6498,7 +6498,7 @@
     </p:spTree>
     <p:extLst>
       <p:ext uri="{BB962C8B-B14F-4D97-AF65-F5344CB8AC3E}">
-        <p14:creationId xmlns:p14="http://schemas.microsoft.com/office/powerpoint/2010/main" val="67883030"/>
+        <p14:creationId xmlns:p14="http://schemas.microsoft.com/office/powerpoint/2010/main" val="1036171666"/>
       </p:ext>
     </p:extLst>
   </p:cSld>
@@ -6529,7 +6529,7 @@
           <p:cNvPr id="9" name="">
             <a:extLst xmlns:a="http://schemas.openxmlformats.org/drawingml/2006/main">
               <a:ext uri="{FF2B5EF4-FFF2-40B4-BE49-F238E27FC236}">
-                <a16:creationId xmlns:a16="http://schemas.microsoft.com/office/drawing/2014/main" id="{CC446F48-1527-49F1-A4EA-1AB03A7D2BE6}"/>
+                <a16:creationId xmlns:a16="http://schemas.microsoft.com/office/drawing/2014/main" id="{4716F1AE-0CD3-49E8-BC06-457AC62AC2A9}"/>
               </a:ext>
             </a:extLst>
           </p:cNvPr>
@@ -6586,7 +6586,7 @@
           <p:cNvPr id="2" name="">
             <a:extLst xmlns:a="http://schemas.openxmlformats.org/drawingml/2006/main">
               <a:ext uri="{FF2B5EF4-FFF2-40B4-BE49-F238E27FC236}">
-                <a16:creationId xmlns:a16="http://schemas.microsoft.com/office/drawing/2014/main" id="{572F0E86-94D4-4D62-AFE2-37282800C6A7}"/>
+                <a16:creationId xmlns:a16="http://schemas.microsoft.com/office/drawing/2014/main" id="{22D31BFD-59EA-463D-AE0A-EE85F5CA34C0}"/>
               </a:ext>
             </a:extLst>
           </p:cNvPr>
@@ -6643,7 +6643,7 @@
           <p:cNvPr id="3" name="">
             <a:extLst xmlns:a="http://schemas.openxmlformats.org/drawingml/2006/main">
               <a:ext uri="{FF2B5EF4-FFF2-40B4-BE49-F238E27FC236}">
-                <a16:creationId xmlns:a16="http://schemas.microsoft.com/office/drawing/2014/main" id="{3F21456E-0EDD-4BA9-A8BD-E9500A05564F}"/>
+                <a16:creationId xmlns:a16="http://schemas.microsoft.com/office/drawing/2014/main" id="{E3AA4F58-2C18-4641-97B8-E09497551B74}"/>
               </a:ext>
             </a:extLst>
           </p:cNvPr>
@@ -6700,7 +6700,7 @@
           <p:cNvPr id="4" name="">
             <a:extLst xmlns:a="http://schemas.openxmlformats.org/drawingml/2006/main">
               <a:ext uri="{FF2B5EF4-FFF2-40B4-BE49-F238E27FC236}">
-                <a16:creationId xmlns:a16="http://schemas.microsoft.com/office/drawing/2014/main" id="{6A694108-187B-4801-9E99-035F6F8269C2}"/>
+                <a16:creationId xmlns:a16="http://schemas.microsoft.com/office/drawing/2014/main" id="{F5FC4573-30EA-47AF-9465-95F2EBB77CF4}"/>
               </a:ext>
             </a:extLst>
           </p:cNvPr>
@@ -6757,7 +6757,7 @@
           <p:cNvPr id="5" name="">
             <a:extLst xmlns:a="http://schemas.openxmlformats.org/drawingml/2006/main">
               <a:ext uri="{FF2B5EF4-FFF2-40B4-BE49-F238E27FC236}">
-                <a16:creationId xmlns:a16="http://schemas.microsoft.com/office/drawing/2014/main" id="{F4172EE8-C593-4685-8D68-5CD9D66EFCB6}"/>
+                <a16:creationId xmlns:a16="http://schemas.microsoft.com/office/drawing/2014/main" id="{B970B759-556E-4FEA-A1BD-D25DA78C1008}"/>
               </a:ext>
             </a:extLst>
           </p:cNvPr>
@@ -6814,7 +6814,7 @@
           <p:cNvPr id="6" name="">
             <a:extLst xmlns:a="http://schemas.openxmlformats.org/drawingml/2006/main">
               <a:ext uri="{FF2B5EF4-FFF2-40B4-BE49-F238E27FC236}">
-                <a16:creationId xmlns:a16="http://schemas.microsoft.com/office/drawing/2014/main" id="{174CBBDF-3662-4E22-B760-7D21E35AE352}"/>
+                <a16:creationId xmlns:a16="http://schemas.microsoft.com/office/drawing/2014/main" id="{CBCB2D0F-4FD0-4943-8CDB-DA349597A1F5}"/>
               </a:ext>
             </a:extLst>
           </p:cNvPr>
@@ -6917,7 +6917,7 @@
           <p:cNvPr id="7" name="">
             <a:extLst xmlns:a="http://schemas.openxmlformats.org/drawingml/2006/main">
               <a:ext uri="{FF2B5EF4-FFF2-40B4-BE49-F238E27FC236}">
-                <a16:creationId xmlns:a16="http://schemas.microsoft.com/office/drawing/2014/main" id="{B87C9781-8E8A-4345-97ED-870CFF431819}"/>
+                <a16:creationId xmlns:a16="http://schemas.microsoft.com/office/drawing/2014/main" id="{5BBC3ACC-0B24-4814-960D-462F82152784}"/>
               </a:ext>
             </a:extLst>
           </p:cNvPr>
@@ -6974,7 +6974,7 @@
           <p:cNvPr id="8" name="">
             <a:extLst xmlns:a="http://schemas.openxmlformats.org/drawingml/2006/main">
               <a:ext uri="{FF2B5EF4-FFF2-40B4-BE49-F238E27FC236}">
-                <a16:creationId xmlns:a16="http://schemas.microsoft.com/office/drawing/2014/main" id="{5DAA1F79-5172-4614-BCB2-870A8D528A61}"/>
+                <a16:creationId xmlns:a16="http://schemas.microsoft.com/office/drawing/2014/main" id="{C9A40039-A108-48D7-8462-0C362BAA3CCA}"/>
               </a:ext>
             </a:extLst>
           </p:cNvPr>
@@ -7075,7 +7075,7 @@
     </p:spTree>
     <p:extLst>
       <p:ext uri="{BB962C8B-B14F-4D97-AF65-F5344CB8AC3E}">
-        <p14:creationId xmlns:p14="http://schemas.microsoft.com/office/powerpoint/2010/main" val="1181893355"/>
+        <p14:creationId xmlns:p14="http://schemas.microsoft.com/office/powerpoint/2010/main" val="1714728097"/>
       </p:ext>
     </p:extLst>
   </p:cSld>

</xml_diff>